<commit_message>
docs: finalize official competition slide B1_12_DROS(DeterministicRuntimeOS).pptx
</commit_message>
<xml_diff>
--- a/B1_12_DROS(DeterministicRuntimeOS).pptx
+++ b/B1_12_DROS(DeterministicRuntimeOS).pptx
@@ -3757,8 +3757,28 @@
               </a:defRPr>
             </a:pPr>
             <a:r>
-              <a:t>🎥 【90 秒實機操作錄影播放區 (Live Demo Video)】</a:t>
-            </a:r>
+              <a:rPr sz="2400" dirty="0"/>
+              <a:t>🎥 【</a:t>
+            </a:r>
+            <a:r>
+              <a:rPr sz="2400" dirty="0" err="1"/>
+              <a:t>實機操作錄影播放區</a:t>
+            </a:r>
+            <a:r>
+              <a:rPr sz="2400" dirty="0"/>
+              <a:t> (Live Demo Video)】</a:t>
+            </a:r>
+            <a:endParaRPr lang="en-US" sz="2400" dirty="0"/>
+          </a:p>
+          <a:p>
+            <a:pPr algn="ctr">
+              <a:defRPr sz="1900" b="1">
+                <a:solidFill>
+                  <a:srgbClr val="F87171"/>
+                </a:solidFill>
+              </a:defRPr>
+            </a:pPr>
+            <a:endParaRPr dirty="0"/>
           </a:p>
           <a:p>
             <a:pPr>
@@ -3769,8 +3789,22 @@
               </a:defRPr>
             </a:pPr>
             <a:r>
-              <a:t>▶ [00:00 - 00:15] OpenShip 主控發射台遙測</a:t>
-            </a:r>
+              <a:rPr sz="1600" dirty="0"/>
+              <a:t>▶ [00:00 - 00:15] </a:t>
+            </a:r>
+            <a:r>
+              <a:rPr sz="1600" dirty="0" err="1"/>
+              <a:t>OpenShip</a:t>
+            </a:r>
+            <a:r>
+              <a:rPr sz="1600" dirty="0"/>
+              <a:t> </a:t>
+            </a:r>
+            <a:r>
+              <a:rPr sz="1600" dirty="0" err="1"/>
+              <a:t>主控發射台遙測</a:t>
+            </a:r>
+            <a:endParaRPr sz="1600" dirty="0"/>
           </a:p>
           <a:p>
             <a:pPr>
@@ -3781,8 +3815,44 @@
               </a:defRPr>
             </a:pPr>
             <a:r>
-              <a:t>   展示 Multi-VEP 跨機構星系圖，實時遙測穩定於 26.1 μs In-Band。</a:t>
-            </a:r>
+              <a:rPr sz="1600" dirty="0"/>
+              <a:t>   </a:t>
+            </a:r>
+            <a:r>
+              <a:rPr sz="1600" dirty="0" err="1"/>
+              <a:t>展示</a:t>
+            </a:r>
+            <a:r>
+              <a:rPr sz="1600" dirty="0"/>
+              <a:t> Multi-VEP </a:t>
+            </a:r>
+            <a:r>
+              <a:rPr sz="1600" dirty="0" err="1"/>
+              <a:t>跨機構星系圖，實時遙測穩定於</a:t>
+            </a:r>
+            <a:r>
+              <a:rPr sz="1600" dirty="0"/>
+              <a:t> 26.1 </a:t>
+            </a:r>
+            <a:r>
+              <a:rPr sz="1600" dirty="0" err="1"/>
+              <a:t>μs</a:t>
+            </a:r>
+            <a:r>
+              <a:rPr sz="1600" dirty="0"/>
+              <a:t> In-Band。</a:t>
+            </a:r>
+            <a:endParaRPr lang="en-US" sz="1600" dirty="0"/>
+          </a:p>
+          <a:p>
+            <a:pPr>
+              <a:defRPr sz="1300">
+                <a:solidFill>
+                  <a:srgbClr val="CBD5E1"/>
+                </a:solidFill>
+              </a:defRPr>
+            </a:pPr>
+            <a:endParaRPr sz="1600" dirty="0"/>
           </a:p>
           <a:p>
             <a:pPr>
@@ -3793,7 +3863,24 @@
               </a:defRPr>
             </a:pPr>
             <a:r>
-              <a:t>▶ [00:15 - 00:50] Track 03: 醫療保險 MediGuard VEP (按3個鈕)</a:t>
+              <a:rPr sz="1600" dirty="0"/>
+              <a:t>▶ [00:15 - 00:50] Track 03: </a:t>
+            </a:r>
+            <a:r>
+              <a:rPr sz="1600" dirty="0" err="1"/>
+              <a:t>醫療保險</a:t>
+            </a:r>
+            <a:r>
+              <a:rPr sz="1600" dirty="0"/>
+              <a:t> </a:t>
+            </a:r>
+            <a:r>
+              <a:rPr sz="1600" dirty="0" err="1"/>
+              <a:t>MediGuard</a:t>
+            </a:r>
+            <a:r>
+              <a:rPr sz="1600" dirty="0"/>
+              <a:t> VEP (按3個鈕)</a:t>
             </a:r>
           </a:p>
           <a:p>
@@ -3805,8 +3892,52 @@
               </a:defRPr>
             </a:pPr>
             <a:r>
-              <a:t>   ▶ 一鍵合規理賠 (18項PHI遮蔽) ➔ 💥 模擬越獄 (26.1μs硬熔斷) ➔ 📜 Merkle收據 + O(1) 撤銷。</a:t>
-            </a:r>
+              <a:rPr sz="1600" dirty="0"/>
+              <a:t>   ▶ </a:t>
+            </a:r>
+            <a:r>
+              <a:rPr sz="1600" dirty="0" err="1"/>
+              <a:t>一鍵合規理賠</a:t>
+            </a:r>
+            <a:r>
+              <a:rPr sz="1600" dirty="0"/>
+              <a:t> (18項PHI遮蔽) ➔ 💥 </a:t>
+            </a:r>
+            <a:r>
+              <a:rPr sz="1600" dirty="0" err="1"/>
+              <a:t>模擬越獄</a:t>
+            </a:r>
+            <a:r>
+              <a:rPr sz="1600" dirty="0"/>
+              <a:t> (26.1μs硬熔斷) ➔ 📜 </a:t>
+            </a:r>
+            <a:r>
+              <a:rPr sz="1600" dirty="0" err="1"/>
+              <a:t>Merkle收據</a:t>
+            </a:r>
+            <a:r>
+              <a:rPr sz="1600" dirty="0"/>
+              <a:t> + O(1) </a:t>
+            </a:r>
+            <a:r>
+              <a:rPr sz="1600" dirty="0" err="1"/>
+              <a:t>撤銷</a:t>
+            </a:r>
+            <a:r>
+              <a:rPr sz="1600" dirty="0"/>
+              <a:t>。</a:t>
+            </a:r>
+            <a:endParaRPr lang="en-US" sz="1600" dirty="0"/>
+          </a:p>
+          <a:p>
+            <a:pPr>
+              <a:defRPr sz="1300">
+                <a:solidFill>
+                  <a:srgbClr val="CBD5E1"/>
+                </a:solidFill>
+              </a:defRPr>
+            </a:pPr>
+            <a:endParaRPr sz="1600" dirty="0"/>
           </a:p>
           <a:p>
             <a:pPr>
@@ -3817,7 +3948,24 @@
               </a:defRPr>
             </a:pPr>
             <a:r>
-              <a:t>▶ [00:50 - 01:25] Track 04: 政府跨機關代辦 GovProxy VEP (按3個鈕)</a:t>
+              <a:rPr sz="1600" dirty="0"/>
+              <a:t>▶ [00:50 - 01:25] Track 04: </a:t>
+            </a:r>
+            <a:r>
+              <a:rPr sz="1600" dirty="0" err="1"/>
+              <a:t>政府跨機關代辦</a:t>
+            </a:r>
+            <a:r>
+              <a:rPr sz="1600" dirty="0"/>
+              <a:t> </a:t>
+            </a:r>
+            <a:r>
+              <a:rPr sz="1600" dirty="0" err="1"/>
+              <a:t>GovProxy</a:t>
+            </a:r>
+            <a:r>
+              <a:rPr sz="1600" dirty="0"/>
+              <a:t> VEP (按3個鈕)</a:t>
             </a:r>
           </a:p>
           <a:p>
@@ -3829,8 +3977,52 @@
               </a:defRPr>
             </a:pPr>
             <a:r>
-              <a:t>   ▶ 跨機關合規代辦 (MyData+vLEI) ➔ 💥 越權調閱全戶日誌 (HTTP 403熔斷) ➔ 📜 W3C憑證 + 廢止代理。</a:t>
-            </a:r>
+              <a:rPr sz="1600" dirty="0"/>
+              <a:t>   ▶ </a:t>
+            </a:r>
+            <a:r>
+              <a:rPr sz="1600" dirty="0" err="1"/>
+              <a:t>跨機關合規代辦</a:t>
+            </a:r>
+            <a:r>
+              <a:rPr sz="1600" dirty="0"/>
+              <a:t> (</a:t>
+            </a:r>
+            <a:r>
+              <a:rPr sz="1600" dirty="0" err="1"/>
+              <a:t>MyData+vLEI</a:t>
+            </a:r>
+            <a:r>
+              <a:rPr sz="1600" dirty="0"/>
+              <a:t>) ➔ 💥 </a:t>
+            </a:r>
+            <a:r>
+              <a:rPr sz="1600" dirty="0" err="1"/>
+              <a:t>越權調閱全戶日誌</a:t>
+            </a:r>
+            <a:r>
+              <a:rPr sz="1600" dirty="0"/>
+              <a:t> (HTTP 403熔斷) ➔ 📜 W3C憑證 + </a:t>
+            </a:r>
+            <a:r>
+              <a:rPr sz="1600" dirty="0" err="1"/>
+              <a:t>廢止代理</a:t>
+            </a:r>
+            <a:r>
+              <a:rPr sz="1600" dirty="0"/>
+              <a:t>。</a:t>
+            </a:r>
+            <a:endParaRPr lang="en-US" sz="1600" dirty="0"/>
+          </a:p>
+          <a:p>
+            <a:pPr>
+              <a:defRPr sz="1300">
+                <a:solidFill>
+                  <a:srgbClr val="CBD5E1"/>
+                </a:solidFill>
+              </a:defRPr>
+            </a:pPr>
+            <a:endParaRPr sz="1600" dirty="0"/>
           </a:p>
           <a:p>
             <a:pPr>
@@ -3841,8 +4033,14 @@
               </a:defRPr>
             </a:pPr>
             <a:r>
-              <a:t>▶ [01:25 - 01:30] 終端機極速單元測試驗證</a:t>
-            </a:r>
+              <a:rPr sz="1600" dirty="0"/>
+              <a:t>▶ [01:25 - 01:30] </a:t>
+            </a:r>
+            <a:r>
+              <a:rPr sz="1600" dirty="0" err="1"/>
+              <a:t>終端機極速單元測試驗證</a:t>
+            </a:r>
+            <a:endParaRPr sz="1600" dirty="0"/>
           </a:p>
           <a:p>
             <a:pPr>
@@ -3853,7 +4051,44 @@
               </a:defRPr>
             </a:pPr>
             <a:r>
-              <a:t>   執行 python test_verification_suite.py ➔ 0.001 秒 5/5 斷言全數通過！</a:t>
+              <a:rPr sz="1600" dirty="0"/>
+              <a:t>   </a:t>
+            </a:r>
+            <a:r>
+              <a:rPr lang="zh-TW" altLang="en-US" sz="1600" dirty="0"/>
+              <a:t>可</a:t>
+            </a:r>
+            <a:r>
+              <a:rPr sz="1600" dirty="0" err="1"/>
+              <a:t>執行</a:t>
+            </a:r>
+            <a:r>
+              <a:rPr sz="1600" dirty="0"/>
+              <a:t> </a:t>
+            </a:r>
+            <a:r>
+              <a:rPr sz="1600" dirty="0">
+                <a:solidFill>
+                  <a:srgbClr val="FFC000"/>
+                </a:solidFill>
+              </a:rPr>
+              <a:t>python test_verification_suite.py </a:t>
+            </a:r>
+            <a:r>
+              <a:rPr sz="1600" dirty="0"/>
+              <a:t>➔ 0.001 秒 5/5 </a:t>
+            </a:r>
+            <a:r>
+              <a:rPr lang="zh-TW" altLang="en-US" sz="1600" dirty="0"/>
+              <a:t>驗證</a:t>
+            </a:r>
+            <a:r>
+              <a:rPr sz="1600" dirty="0" err="1"/>
+              <a:t>斷言通過</a:t>
+            </a:r>
+            <a:r>
+              <a:rPr sz="1600" dirty="0"/>
+              <a:t>！</a:t>
             </a:r>
           </a:p>
         </p:txBody>
@@ -3982,8 +4217,8 @@
         </p:nvSpPr>
         <p:spPr>
           <a:xfrm>
-            <a:off x="731520" y="1371600"/>
-            <a:ext cx="10728655" cy="4846320"/>
+            <a:off x="731520" y="1188720"/>
+            <a:ext cx="10728655" cy="5212080"/>
           </a:xfrm>
           <a:prstGeom prst="roundRect">
             <a:avLst/>
@@ -4046,7 +4281,7 @@
               <a:rPr lang="zh-TW" altLang="en-US" sz="2800" dirty="0"/>
               <a:t>應用海闊天空</a:t>
             </a:r>
-            <a:endParaRPr lang="en-US" dirty="0"/>
+            <a:endParaRPr lang="en-US" altLang="zh-TW" sz="2800" dirty="0"/>
           </a:p>
           <a:p>
             <a:pPr algn="ctr">
@@ -4056,6 +4291,16 @@
                 </a:solidFill>
               </a:defRPr>
             </a:pPr>
+            <a:endParaRPr lang="en-US" dirty="0"/>
+          </a:p>
+          <a:p>
+            <a:pPr algn="ctr">
+              <a:defRPr sz="2200" b="1">
+                <a:solidFill>
+                  <a:srgbClr val="38BDF8"/>
+                </a:solidFill>
+              </a:defRPr>
+            </a:pPr>
             <a:endParaRPr dirty="0"/>
           </a:p>
           <a:p>
@@ -4086,6 +4331,17 @@
               <a:rPr dirty="0"/>
               <a:t>。</a:t>
             </a:r>
+            <a:endParaRPr lang="en-US" dirty="0"/>
+          </a:p>
+          <a:p>
+            <a:pPr>
+              <a:defRPr sz="1600" b="1">
+                <a:solidFill>
+                  <a:srgbClr val="F8FAFC"/>
+                </a:solidFill>
+              </a:defRPr>
+            </a:pPr>
+            <a:endParaRPr dirty="0"/>
           </a:p>
           <a:p>
             <a:pPr>
@@ -4115,11 +4371,22 @@
               <a:rPr dirty="0"/>
               <a:t> Execution Infrastructure。</a:t>
             </a:r>
+            <a:endParaRPr lang="en-US" dirty="0"/>
           </a:p>
           <a:p>
             <a:pPr>
               <a:defRPr sz="1500" b="0">
                 <a:solidFill>
+                  <a:srgbClr val="4ADE80"/>
+                </a:solidFill>
+              </a:defRPr>
+            </a:pPr>
+            <a:endParaRPr dirty="0"/>
+          </a:p>
+          <a:p>
+            <a:pPr>
+              <a:defRPr sz="1500" b="0">
+                <a:solidFill>
                   <a:srgbClr val="FBBF24"/>
                 </a:solidFill>
               </a:defRPr>
@@ -4129,37 +4396,79 @@
               <a:t>▶ </a:t>
             </a:r>
             <a:r>
-              <a:rPr dirty="0" err="1"/>
-              <a:t>讓開發者專注於</a:t>
-            </a:r>
-            <a:r>
-              <a:rPr dirty="0"/>
+              <a:rPr dirty="0">
+                <a:latin typeface="+mn-ea"/>
+              </a:rPr>
+              <a:t>讓</a:t>
+            </a:r>
+            <a:r>
+              <a:rPr lang="zh-TW" altLang="en-US" dirty="0">
+                <a:latin typeface="GenSenRounded JP M" panose="020B0600000000000000" pitchFamily="34" charset="-128"/>
+                <a:ea typeface="GenSenRounded JP M" panose="020B0600000000000000" pitchFamily="34" charset="-128"/>
+              </a:rPr>
+              <a:t>所有</a:t>
+            </a:r>
+            <a:r>
+              <a:rPr dirty="0" err="1">
+                <a:latin typeface="+mn-ea"/>
+              </a:rPr>
+              <a:t>開發者專注於</a:t>
+            </a:r>
+            <a:r>
+              <a:rPr dirty="0">
+                <a:latin typeface="+mn-ea"/>
+              </a:rPr>
               <a:t>：「Agent </a:t>
             </a:r>
             <a:r>
-              <a:rPr dirty="0" err="1"/>
+              <a:rPr dirty="0" err="1">
+                <a:latin typeface="+mn-ea"/>
+              </a:rPr>
               <a:t>要完成什麼</a:t>
             </a:r>
             <a:r>
-              <a:rPr dirty="0"/>
+              <a:rPr dirty="0">
+                <a:latin typeface="+mn-ea"/>
+              </a:rPr>
               <a:t>」；</a:t>
             </a:r>
             <a:r>
-              <a:rPr dirty="0" err="1"/>
+              <a:rPr dirty="0" err="1">
+                <a:latin typeface="+mn-ea"/>
+              </a:rPr>
               <a:t>而不是每一次都重新思考</a:t>
             </a:r>
             <a:r>
-              <a:rPr dirty="0"/>
+              <a:rPr dirty="0">
+                <a:latin typeface="+mn-ea"/>
+              </a:rPr>
               <a:t>：「Agent </a:t>
             </a:r>
             <a:r>
-              <a:rPr dirty="0" err="1"/>
+              <a:rPr dirty="0" err="1">
+                <a:latin typeface="+mn-ea"/>
+              </a:rPr>
               <a:t>做錯了，我怎麼阻止它</a:t>
             </a:r>
             <a:r>
-              <a:rPr dirty="0"/>
+              <a:rPr dirty="0">
+                <a:latin typeface="+mn-ea"/>
+              </a:rPr>
               <a:t>」。</a:t>
             </a:r>
+            <a:endParaRPr lang="en-US" dirty="0">
+              <a:latin typeface="+mn-ea"/>
+            </a:endParaRPr>
+          </a:p>
+          <a:p>
+            <a:pPr>
+              <a:defRPr sz="1500" b="0">
+                <a:solidFill>
+                  <a:srgbClr val="FBBF24"/>
+                </a:solidFill>
+              </a:defRPr>
+            </a:pPr>
+            <a:endParaRPr dirty="0"/>
           </a:p>
           <a:p>
             <a:pPr>
@@ -4175,7 +4484,33 @@
             </a:r>
             <a:r>
               <a:rPr dirty="0" err="1"/>
-              <a:t>治理是前提，而不是補丁；唯有底層確定性閉環，面對海量高頻穩健存活，上層應用才真正海闊天空</a:t>
+              <a:t>治理是前提，而不是補丁；唯有底層確定性閉環</a:t>
+            </a:r>
+            <a:r>
+              <a:rPr dirty="0"/>
+              <a:t>，</a:t>
+            </a:r>
+            <a:r>
+              <a:rPr lang="zh-TW" altLang="en-US" dirty="0">
+                <a:latin typeface="GenSenRounded JP M" panose="020B0600000000000000" pitchFamily="34" charset="-128"/>
+                <a:ea typeface="GenSenRounded JP M" panose="020B0600000000000000" pitchFamily="34" charset="-128"/>
+              </a:rPr>
+              <a:t>並能</a:t>
+            </a:r>
+            <a:r>
+              <a:rPr dirty="0" err="1"/>
+              <a:t>面對海量高頻穩健存活，上層應用才</a:t>
+            </a:r>
+            <a:r>
+              <a:rPr lang="zh-TW" altLang="en-US" dirty="0">
+                <a:latin typeface="GenSenRounded JP M" panose="020B0600000000000000" pitchFamily="34" charset="-128"/>
+                <a:ea typeface="GenSenRounded JP M" panose="020B0600000000000000" pitchFamily="34" charset="-128"/>
+              </a:rPr>
+              <a:t>有</a:t>
+            </a:r>
+            <a:r>
+              <a:rPr dirty="0" err="1"/>
+              <a:t>真正海闊天空</a:t>
             </a:r>
             <a:r>
               <a:rPr dirty="0"/>
@@ -9932,7 +10267,7 @@
         <p:spPr>
           <a:xfrm>
             <a:off x="731520" y="1280160"/>
-            <a:ext cx="5212080" cy="5029200"/>
+            <a:ext cx="5212080" cy="4289367"/>
           </a:xfrm>
           <a:prstGeom prst="roundRect">
             <a:avLst/>
@@ -10198,7 +10533,7 @@
         <p:spPr>
           <a:xfrm>
             <a:off x="6248095" y="1280160"/>
-            <a:ext cx="5212080" cy="5029200"/>
+            <a:ext cx="5212080" cy="4289367"/>
           </a:xfrm>
           <a:prstGeom prst="roundRect">
             <a:avLst/>
@@ -10486,6 +10821,66 @@
               <a:rPr dirty="0"/>
               <a:t>   U.S. Provisional Patent Application No. 64/111,973</a:t>
             </a:r>
+          </a:p>
+        </p:txBody>
+      </p:sp>
+      <p:sp>
+        <p:nvSpPr>
+          <p:cNvPr id="6" name="文字方塊 5">
+            <a:extLst>
+              <a:ext uri="{FF2B5EF4-FFF2-40B4-BE49-F238E27FC236}">
+                <a16:creationId xmlns:a16="http://schemas.microsoft.com/office/drawing/2014/main" id="{687DEB3D-02D8-D81B-9F8C-974DCCC0156D}"/>
+              </a:ext>
+            </a:extLst>
+          </p:cNvPr>
+          <p:cNvSpPr txBox="1"/>
+          <p:nvPr/>
+        </p:nvSpPr>
+        <p:spPr>
+          <a:xfrm>
+            <a:off x="3943774" y="5955223"/>
+            <a:ext cx="4304145" cy="461665"/>
+          </a:xfrm>
+          <a:prstGeom prst="rect">
+            <a:avLst/>
+          </a:prstGeom>
+          <a:noFill/>
+        </p:spPr>
+        <p:txBody>
+          <a:bodyPr wrap="square" rtlCol="0">
+            <a:spAutoFit/>
+          </a:bodyPr>
+          <a:lstStyle/>
+          <a:p>
+            <a:pPr algn="ctr"/>
+            <a:r>
+              <a:rPr lang="zh-TW" altLang="en-US" sz="2400" dirty="0">
+                <a:solidFill>
+                  <a:schemeClr val="bg1"/>
+                </a:solidFill>
+              </a:rPr>
+              <a:t>官網：</a:t>
+            </a:r>
+            <a:r>
+              <a:rPr lang="en-US" altLang="zh-TW" sz="2400" dirty="0">
+                <a:solidFill>
+                  <a:schemeClr val="bg1"/>
+                </a:solidFill>
+                <a:hlinkClick r:id="rId2">
+                  <a:extLst>
+                    <a:ext uri="{A12FA001-AC4F-418D-AE19-62706E023703}">
+                      <ahyp:hlinkClr xmlns:ahyp="http://schemas.microsoft.com/office/drawing/2018/hyperlinkcolor" val="tx"/>
+                    </a:ext>
+                  </a:extLst>
+                </a:hlinkClick>
+              </a:rPr>
+              <a:t>https://dr-os.io</a:t>
+            </a:r>
+            <a:endParaRPr lang="zh-TW" altLang="en-US" sz="2400" dirty="0">
+              <a:solidFill>
+                <a:schemeClr val="bg1"/>
+              </a:solidFill>
+            </a:endParaRPr>
           </a:p>
         </p:txBody>
       </p:sp>

</xml_diff>

<commit_message>
docs(media): add official competition presentation video B1-12-DROS.mp4 and track demo DROS-Hackathon-3.mp4 via Git LFS
</commit_message>
<xml_diff>
--- a/B1_12_DROS(DeterministicRuntimeOS).pptx
+++ b/B1_12_DROS(DeterministicRuntimeOS).pptx
@@ -4,6 +4,12 @@
   <p:sldMasterIdLst>
     <p:sldMasterId id="2147483648" r:id="rId1"/>
   </p:sldMasterIdLst>
+  <p:notesMasterIdLst>
+    <p:notesMasterId r:id="rId11"/>
+  </p:notesMasterIdLst>
+  <p:handoutMasterIdLst>
+    <p:handoutMasterId r:id="rId12"/>
+  </p:handoutMasterIdLst>
   <p:sldIdLst>
     <p:sldId id="256" r:id="rId2"/>
     <p:sldId id="257" r:id="rId3"/>
@@ -11,11 +17,9 @@
     <p:sldId id="267" r:id="rId5"/>
     <p:sldId id="259" r:id="rId6"/>
     <p:sldId id="265" r:id="rId7"/>
-    <p:sldId id="260" r:id="rId8"/>
-    <p:sldId id="261" r:id="rId9"/>
+    <p:sldId id="261" r:id="rId8"/>
+    <p:sldId id="260" r:id="rId9"/>
     <p:sldId id="262" r:id="rId10"/>
-    <p:sldId id="263" r:id="rId11"/>
-    <p:sldId id="264" r:id="rId12"/>
   </p:sldIdLst>
   <p:sldSz cx="12192000" cy="6858000"/>
   <p:notesSz cx="6858000" cy="9144000"/>
@@ -133,6 +137,546 @@
 </p:presentation>
 </file>
 
+<file path=ppt/handoutMasters/handoutMaster1.xml><?xml version="1.0" encoding="utf-8"?>
+<p:handoutMaster xmlns:a="http://schemas.openxmlformats.org/drawingml/2006/main" xmlns:r="http://schemas.openxmlformats.org/officeDocument/2006/relationships" xmlns:p="http://schemas.openxmlformats.org/presentationml/2006/main">
+  <p:cSld>
+    <p:bg>
+      <p:bgRef idx="1001">
+        <a:schemeClr val="bg1"/>
+      </p:bgRef>
+    </p:bg>
+    <p:spTree>
+      <p:nvGrpSpPr>
+        <p:cNvPr id="1" name=""/>
+        <p:cNvGrpSpPr/>
+        <p:nvPr/>
+      </p:nvGrpSpPr>
+      <p:grpSpPr>
+        <a:xfrm>
+          <a:off x="0" y="0"/>
+          <a:ext cx="0" cy="0"/>
+          <a:chOff x="0" y="0"/>
+          <a:chExt cx="0" cy="0"/>
+        </a:xfrm>
+      </p:grpSpPr>
+      <p:sp>
+        <p:nvSpPr>
+          <p:cNvPr id="2" name="頁首版面配置區 1">
+            <a:extLst>
+              <a:ext uri="{FF2B5EF4-FFF2-40B4-BE49-F238E27FC236}">
+                <a16:creationId xmlns:a16="http://schemas.microsoft.com/office/drawing/2014/main" id="{15C88A33-9A57-D59F-C85E-667580CFE3C3}"/>
+              </a:ext>
+            </a:extLst>
+          </p:cNvPr>
+          <p:cNvSpPr>
+            <a:spLocks noGrp="1"/>
+          </p:cNvSpPr>
+          <p:nvPr>
+            <p:ph type="hdr" sz="quarter"/>
+          </p:nvPr>
+        </p:nvSpPr>
+        <p:spPr>
+          <a:xfrm>
+            <a:off x="0" y="0"/>
+            <a:ext cx="2971800" cy="458788"/>
+          </a:xfrm>
+          <a:prstGeom prst="rect">
+            <a:avLst/>
+          </a:prstGeom>
+        </p:spPr>
+        <p:txBody>
+          <a:bodyPr vert="horz" lIns="91440" tIns="45720" rIns="91440" bIns="45720" rtlCol="0"/>
+          <a:lstStyle>
+            <a:lvl1pPr algn="l">
+              <a:defRPr sz="1200"/>
+            </a:lvl1pPr>
+          </a:lstStyle>
+          <a:p>
+            <a:endParaRPr lang="zh-TW" altLang="en-US"/>
+          </a:p>
+        </p:txBody>
+      </p:sp>
+      <p:sp>
+        <p:nvSpPr>
+          <p:cNvPr id="3" name="日期版面配置區 2">
+            <a:extLst>
+              <a:ext uri="{FF2B5EF4-FFF2-40B4-BE49-F238E27FC236}">
+                <a16:creationId xmlns:a16="http://schemas.microsoft.com/office/drawing/2014/main" id="{F3D41091-ED63-0F67-8C04-C3845BF0A95D}"/>
+              </a:ext>
+            </a:extLst>
+          </p:cNvPr>
+          <p:cNvSpPr>
+            <a:spLocks noGrp="1"/>
+          </p:cNvSpPr>
+          <p:nvPr>
+            <p:ph type="dt" sz="quarter" idx="1"/>
+          </p:nvPr>
+        </p:nvSpPr>
+        <p:spPr>
+          <a:xfrm>
+            <a:off x="3884613" y="0"/>
+            <a:ext cx="2971800" cy="458788"/>
+          </a:xfrm>
+          <a:prstGeom prst="rect">
+            <a:avLst/>
+          </a:prstGeom>
+        </p:spPr>
+        <p:txBody>
+          <a:bodyPr vert="horz" lIns="91440" tIns="45720" rIns="91440" bIns="45720" rtlCol="0"/>
+          <a:lstStyle>
+            <a:lvl1pPr algn="r">
+              <a:defRPr sz="1200"/>
+            </a:lvl1pPr>
+          </a:lstStyle>
+          <a:p>
+            <a:fld id="{09BCE9F8-5A4F-432F-A074-BBD7C491C249}" type="datetimeFigureOut">
+              <a:rPr lang="zh-TW" altLang="en-US" smtClean="0"/>
+              <a:t>2026/8/30</a:t>
+            </a:fld>
+            <a:endParaRPr lang="zh-TW" altLang="en-US"/>
+          </a:p>
+        </p:txBody>
+      </p:sp>
+      <p:sp>
+        <p:nvSpPr>
+          <p:cNvPr id="4" name="頁尾版面配置區 3">
+            <a:extLst>
+              <a:ext uri="{FF2B5EF4-FFF2-40B4-BE49-F238E27FC236}">
+                <a16:creationId xmlns:a16="http://schemas.microsoft.com/office/drawing/2014/main" id="{8818E36E-C6E8-FFD2-E319-BFC5ADDEC1C2}"/>
+              </a:ext>
+            </a:extLst>
+          </p:cNvPr>
+          <p:cNvSpPr>
+            <a:spLocks noGrp="1"/>
+          </p:cNvSpPr>
+          <p:nvPr>
+            <p:ph type="ftr" sz="quarter" idx="2"/>
+          </p:nvPr>
+        </p:nvSpPr>
+        <p:spPr>
+          <a:xfrm>
+            <a:off x="0" y="8685213"/>
+            <a:ext cx="2971800" cy="458787"/>
+          </a:xfrm>
+          <a:prstGeom prst="rect">
+            <a:avLst/>
+          </a:prstGeom>
+        </p:spPr>
+        <p:txBody>
+          <a:bodyPr vert="horz" lIns="91440" tIns="45720" rIns="91440" bIns="45720" rtlCol="0" anchor="b"/>
+          <a:lstStyle>
+            <a:lvl1pPr algn="l">
+              <a:defRPr sz="1200"/>
+            </a:lvl1pPr>
+          </a:lstStyle>
+          <a:p>
+            <a:endParaRPr lang="zh-TW" altLang="en-US"/>
+          </a:p>
+        </p:txBody>
+      </p:sp>
+      <p:sp>
+        <p:nvSpPr>
+          <p:cNvPr id="5" name="投影片編號版面配置區 4">
+            <a:extLst>
+              <a:ext uri="{FF2B5EF4-FFF2-40B4-BE49-F238E27FC236}">
+                <a16:creationId xmlns:a16="http://schemas.microsoft.com/office/drawing/2014/main" id="{5A01CDE1-F80E-352E-27F5-42306546D779}"/>
+              </a:ext>
+            </a:extLst>
+          </p:cNvPr>
+          <p:cNvSpPr>
+            <a:spLocks noGrp="1"/>
+          </p:cNvSpPr>
+          <p:nvPr>
+            <p:ph type="sldNum" sz="quarter" idx="3"/>
+          </p:nvPr>
+        </p:nvSpPr>
+        <p:spPr>
+          <a:xfrm>
+            <a:off x="3884613" y="8685213"/>
+            <a:ext cx="2971800" cy="458787"/>
+          </a:xfrm>
+          <a:prstGeom prst="rect">
+            <a:avLst/>
+          </a:prstGeom>
+        </p:spPr>
+        <p:txBody>
+          <a:bodyPr vert="horz" lIns="91440" tIns="45720" rIns="91440" bIns="45720" rtlCol="0" anchor="b"/>
+          <a:lstStyle>
+            <a:lvl1pPr algn="r">
+              <a:defRPr sz="1200"/>
+            </a:lvl1pPr>
+          </a:lstStyle>
+          <a:p>
+            <a:fld id="{7E525396-C467-40E2-8959-C85C0D4A10E2}" type="slidenum">
+              <a:rPr lang="zh-TW" altLang="en-US" smtClean="0"/>
+              <a:t>‹#›</a:t>
+            </a:fld>
+            <a:endParaRPr lang="zh-TW" altLang="en-US"/>
+          </a:p>
+        </p:txBody>
+      </p:sp>
+    </p:spTree>
+    <p:extLst>
+      <p:ext uri="{BB962C8B-B14F-4D97-AF65-F5344CB8AC3E}">
+        <p14:creationId xmlns:p14="http://schemas.microsoft.com/office/powerpoint/2010/main" val="2286503859"/>
+      </p:ext>
+    </p:extLst>
+  </p:cSld>
+  <p:clrMap bg1="lt1" tx1="dk1" bg2="lt2" tx2="dk2" accent1="accent1" accent2="accent2" accent3="accent3" accent4="accent4" accent5="accent5" accent6="accent6" hlink="hlink" folHlink="folHlink"/>
+  <p:hf hdr="0" dt="0"/>
+</p:handoutMaster>
+</file>
+
+<file path=ppt/notesMasters/notesMaster1.xml><?xml version="1.0" encoding="utf-8"?>
+<p:notesMaster xmlns:a="http://schemas.openxmlformats.org/drawingml/2006/main" xmlns:r="http://schemas.openxmlformats.org/officeDocument/2006/relationships" xmlns:p="http://schemas.openxmlformats.org/presentationml/2006/main">
+  <p:cSld>
+    <p:bg>
+      <p:bgRef idx="1001">
+        <a:schemeClr val="bg1"/>
+      </p:bgRef>
+    </p:bg>
+    <p:spTree>
+      <p:nvGrpSpPr>
+        <p:cNvPr id="1" name=""/>
+        <p:cNvGrpSpPr/>
+        <p:nvPr/>
+      </p:nvGrpSpPr>
+      <p:grpSpPr>
+        <a:xfrm>
+          <a:off x="0" y="0"/>
+          <a:ext cx="0" cy="0"/>
+          <a:chOff x="0" y="0"/>
+          <a:chExt cx="0" cy="0"/>
+        </a:xfrm>
+      </p:grpSpPr>
+      <p:sp>
+        <p:nvSpPr>
+          <p:cNvPr id="2" name="頁首版面配置區 1"/>
+          <p:cNvSpPr>
+            <a:spLocks noGrp="1"/>
+          </p:cNvSpPr>
+          <p:nvPr>
+            <p:ph type="hdr" sz="quarter"/>
+          </p:nvPr>
+        </p:nvSpPr>
+        <p:spPr>
+          <a:xfrm>
+            <a:off x="0" y="0"/>
+            <a:ext cx="2971800" cy="458788"/>
+          </a:xfrm>
+          <a:prstGeom prst="rect">
+            <a:avLst/>
+          </a:prstGeom>
+        </p:spPr>
+        <p:txBody>
+          <a:bodyPr vert="horz" lIns="91440" tIns="45720" rIns="91440" bIns="45720" rtlCol="0"/>
+          <a:lstStyle>
+            <a:lvl1pPr algn="l">
+              <a:defRPr sz="1200"/>
+            </a:lvl1pPr>
+          </a:lstStyle>
+          <a:p>
+            <a:endParaRPr lang="zh-TW" altLang="en-US"/>
+          </a:p>
+        </p:txBody>
+      </p:sp>
+      <p:sp>
+        <p:nvSpPr>
+          <p:cNvPr id="3" name="日期版面配置區 2"/>
+          <p:cNvSpPr>
+            <a:spLocks noGrp="1"/>
+          </p:cNvSpPr>
+          <p:nvPr>
+            <p:ph type="dt" idx="1"/>
+          </p:nvPr>
+        </p:nvSpPr>
+        <p:spPr>
+          <a:xfrm>
+            <a:off x="3884613" y="0"/>
+            <a:ext cx="2971800" cy="458788"/>
+          </a:xfrm>
+          <a:prstGeom prst="rect">
+            <a:avLst/>
+          </a:prstGeom>
+        </p:spPr>
+        <p:txBody>
+          <a:bodyPr vert="horz" lIns="91440" tIns="45720" rIns="91440" bIns="45720" rtlCol="0"/>
+          <a:lstStyle>
+            <a:lvl1pPr algn="r">
+              <a:defRPr sz="1200"/>
+            </a:lvl1pPr>
+          </a:lstStyle>
+          <a:p>
+            <a:fld id="{FB2030B4-19F3-46AC-873E-939BE541C553}" type="datetimeFigureOut">
+              <a:rPr lang="zh-TW" altLang="en-US" smtClean="0"/>
+              <a:t>2026/8/30</a:t>
+            </a:fld>
+            <a:endParaRPr lang="zh-TW" altLang="en-US"/>
+          </a:p>
+        </p:txBody>
+      </p:sp>
+      <p:sp>
+        <p:nvSpPr>
+          <p:cNvPr id="4" name="投影片影像版面配置區 3"/>
+          <p:cNvSpPr>
+            <a:spLocks noGrp="1" noRot="1" noChangeAspect="1"/>
+          </p:cNvSpPr>
+          <p:nvPr>
+            <p:ph type="sldImg" idx="2"/>
+          </p:nvPr>
+        </p:nvSpPr>
+        <p:spPr>
+          <a:xfrm>
+            <a:off x="685800" y="1143000"/>
+            <a:ext cx="5486400" cy="3086100"/>
+          </a:xfrm>
+          <a:prstGeom prst="rect">
+            <a:avLst/>
+          </a:prstGeom>
+          <a:noFill/>
+          <a:ln w="12700">
+            <a:solidFill>
+              <a:prstClr val="black"/>
+            </a:solidFill>
+          </a:ln>
+        </p:spPr>
+        <p:txBody>
+          <a:bodyPr vert="horz" lIns="91440" tIns="45720" rIns="91440" bIns="45720" rtlCol="0" anchor="ctr"/>
+          <a:lstStyle/>
+          <a:p>
+            <a:endParaRPr lang="zh-TW" altLang="en-US"/>
+          </a:p>
+        </p:txBody>
+      </p:sp>
+      <p:sp>
+        <p:nvSpPr>
+          <p:cNvPr id="5" name="備忘稿版面配置區 4"/>
+          <p:cNvSpPr>
+            <a:spLocks noGrp="1"/>
+          </p:cNvSpPr>
+          <p:nvPr>
+            <p:ph type="body" sz="quarter" idx="3"/>
+          </p:nvPr>
+        </p:nvSpPr>
+        <p:spPr>
+          <a:xfrm>
+            <a:off x="685800" y="4400550"/>
+            <a:ext cx="5486400" cy="3600450"/>
+          </a:xfrm>
+          <a:prstGeom prst="rect">
+            <a:avLst/>
+          </a:prstGeom>
+        </p:spPr>
+        <p:txBody>
+          <a:bodyPr vert="horz" lIns="91440" tIns="45720" rIns="91440" bIns="45720" rtlCol="0"/>
+          <a:lstStyle/>
+          <a:p>
+            <a:pPr lvl="0"/>
+            <a:r>
+              <a:rPr lang="zh-TW" altLang="en-US"/>
+              <a:t>按一下以編輯母片文字樣式</a:t>
+            </a:r>
+          </a:p>
+          <a:p>
+            <a:pPr lvl="1"/>
+            <a:r>
+              <a:rPr lang="zh-TW" altLang="en-US"/>
+              <a:t>第二層</a:t>
+            </a:r>
+          </a:p>
+          <a:p>
+            <a:pPr lvl="2"/>
+            <a:r>
+              <a:rPr lang="zh-TW" altLang="en-US"/>
+              <a:t>第三層</a:t>
+            </a:r>
+          </a:p>
+          <a:p>
+            <a:pPr lvl="3"/>
+            <a:r>
+              <a:rPr lang="zh-TW" altLang="en-US"/>
+              <a:t>第四層</a:t>
+            </a:r>
+          </a:p>
+          <a:p>
+            <a:pPr lvl="4"/>
+            <a:r>
+              <a:rPr lang="zh-TW" altLang="en-US"/>
+              <a:t>第五層</a:t>
+            </a:r>
+          </a:p>
+        </p:txBody>
+      </p:sp>
+      <p:sp>
+        <p:nvSpPr>
+          <p:cNvPr id="6" name="頁尾版面配置區 5"/>
+          <p:cNvSpPr>
+            <a:spLocks noGrp="1"/>
+          </p:cNvSpPr>
+          <p:nvPr>
+            <p:ph type="ftr" sz="quarter" idx="4"/>
+          </p:nvPr>
+        </p:nvSpPr>
+        <p:spPr>
+          <a:xfrm>
+            <a:off x="0" y="8685213"/>
+            <a:ext cx="2971800" cy="458787"/>
+          </a:xfrm>
+          <a:prstGeom prst="rect">
+            <a:avLst/>
+          </a:prstGeom>
+        </p:spPr>
+        <p:txBody>
+          <a:bodyPr vert="horz" lIns="91440" tIns="45720" rIns="91440" bIns="45720" rtlCol="0" anchor="b"/>
+          <a:lstStyle>
+            <a:lvl1pPr algn="l">
+              <a:defRPr sz="1200"/>
+            </a:lvl1pPr>
+          </a:lstStyle>
+          <a:p>
+            <a:endParaRPr lang="zh-TW" altLang="en-US"/>
+          </a:p>
+        </p:txBody>
+      </p:sp>
+      <p:sp>
+        <p:nvSpPr>
+          <p:cNvPr id="7" name="投影片編號版面配置區 6"/>
+          <p:cNvSpPr>
+            <a:spLocks noGrp="1"/>
+          </p:cNvSpPr>
+          <p:nvPr>
+            <p:ph type="sldNum" sz="quarter" idx="5"/>
+          </p:nvPr>
+        </p:nvSpPr>
+        <p:spPr>
+          <a:xfrm>
+            <a:off x="3884613" y="8685213"/>
+            <a:ext cx="2971800" cy="458787"/>
+          </a:xfrm>
+          <a:prstGeom prst="rect">
+            <a:avLst/>
+          </a:prstGeom>
+        </p:spPr>
+        <p:txBody>
+          <a:bodyPr vert="horz" lIns="91440" tIns="45720" rIns="91440" bIns="45720" rtlCol="0" anchor="b"/>
+          <a:lstStyle>
+            <a:lvl1pPr algn="r">
+              <a:defRPr sz="1200"/>
+            </a:lvl1pPr>
+          </a:lstStyle>
+          <a:p>
+            <a:fld id="{C922297E-2E8B-4D88-B76E-683EA03EEC09}" type="slidenum">
+              <a:rPr lang="zh-TW" altLang="en-US" smtClean="0"/>
+              <a:t>‹#›</a:t>
+            </a:fld>
+            <a:endParaRPr lang="zh-TW" altLang="en-US"/>
+          </a:p>
+        </p:txBody>
+      </p:sp>
+    </p:spTree>
+    <p:extLst>
+      <p:ext uri="{BB962C8B-B14F-4D97-AF65-F5344CB8AC3E}">
+        <p14:creationId xmlns:p14="http://schemas.microsoft.com/office/powerpoint/2010/main" val="2118680828"/>
+      </p:ext>
+    </p:extLst>
+  </p:cSld>
+  <p:clrMap bg1="lt1" tx1="dk1" bg2="lt2" tx2="dk2" accent1="accent1" accent2="accent2" accent3="accent3" accent4="accent4" accent5="accent5" accent6="accent6" hlink="hlink" folHlink="folHlink"/>
+  <p:hf hdr="0" dt="0"/>
+  <p:notesStyle>
+    <a:lvl1pPr marL="0" algn="l" defTabSz="914400" rtl="0" eaLnBrk="1" latinLnBrk="0" hangingPunct="1">
+      <a:defRPr sz="1200" kern="1200">
+        <a:solidFill>
+          <a:schemeClr val="tx1"/>
+        </a:solidFill>
+        <a:latin typeface="+mn-lt"/>
+        <a:ea typeface="+mn-ea"/>
+        <a:cs typeface="+mn-cs"/>
+      </a:defRPr>
+    </a:lvl1pPr>
+    <a:lvl2pPr marL="457200" algn="l" defTabSz="914400" rtl="0" eaLnBrk="1" latinLnBrk="0" hangingPunct="1">
+      <a:defRPr sz="1200" kern="1200">
+        <a:solidFill>
+          <a:schemeClr val="tx1"/>
+        </a:solidFill>
+        <a:latin typeface="+mn-lt"/>
+        <a:ea typeface="+mn-ea"/>
+        <a:cs typeface="+mn-cs"/>
+      </a:defRPr>
+    </a:lvl2pPr>
+    <a:lvl3pPr marL="914400" algn="l" defTabSz="914400" rtl="0" eaLnBrk="1" latinLnBrk="0" hangingPunct="1">
+      <a:defRPr sz="1200" kern="1200">
+        <a:solidFill>
+          <a:schemeClr val="tx1"/>
+        </a:solidFill>
+        <a:latin typeface="+mn-lt"/>
+        <a:ea typeface="+mn-ea"/>
+        <a:cs typeface="+mn-cs"/>
+      </a:defRPr>
+    </a:lvl3pPr>
+    <a:lvl4pPr marL="1371600" algn="l" defTabSz="914400" rtl="0" eaLnBrk="1" latinLnBrk="0" hangingPunct="1">
+      <a:defRPr sz="1200" kern="1200">
+        <a:solidFill>
+          <a:schemeClr val="tx1"/>
+        </a:solidFill>
+        <a:latin typeface="+mn-lt"/>
+        <a:ea typeface="+mn-ea"/>
+        <a:cs typeface="+mn-cs"/>
+      </a:defRPr>
+    </a:lvl4pPr>
+    <a:lvl5pPr marL="1828800" algn="l" defTabSz="914400" rtl="0" eaLnBrk="1" latinLnBrk="0" hangingPunct="1">
+      <a:defRPr sz="1200" kern="1200">
+        <a:solidFill>
+          <a:schemeClr val="tx1"/>
+        </a:solidFill>
+        <a:latin typeface="+mn-lt"/>
+        <a:ea typeface="+mn-ea"/>
+        <a:cs typeface="+mn-cs"/>
+      </a:defRPr>
+    </a:lvl5pPr>
+    <a:lvl6pPr marL="2286000" algn="l" defTabSz="914400" rtl="0" eaLnBrk="1" latinLnBrk="0" hangingPunct="1">
+      <a:defRPr sz="1200" kern="1200">
+        <a:solidFill>
+          <a:schemeClr val="tx1"/>
+        </a:solidFill>
+        <a:latin typeface="+mn-lt"/>
+        <a:ea typeface="+mn-ea"/>
+        <a:cs typeface="+mn-cs"/>
+      </a:defRPr>
+    </a:lvl6pPr>
+    <a:lvl7pPr marL="2743200" algn="l" defTabSz="914400" rtl="0" eaLnBrk="1" latinLnBrk="0" hangingPunct="1">
+      <a:defRPr sz="1200" kern="1200">
+        <a:solidFill>
+          <a:schemeClr val="tx1"/>
+        </a:solidFill>
+        <a:latin typeface="+mn-lt"/>
+        <a:ea typeface="+mn-ea"/>
+        <a:cs typeface="+mn-cs"/>
+      </a:defRPr>
+    </a:lvl7pPr>
+    <a:lvl8pPr marL="3200400" algn="l" defTabSz="914400" rtl="0" eaLnBrk="1" latinLnBrk="0" hangingPunct="1">
+      <a:defRPr sz="1200" kern="1200">
+        <a:solidFill>
+          <a:schemeClr val="tx1"/>
+        </a:solidFill>
+        <a:latin typeface="+mn-lt"/>
+        <a:ea typeface="+mn-ea"/>
+        <a:cs typeface="+mn-cs"/>
+      </a:defRPr>
+    </a:lvl8pPr>
+    <a:lvl9pPr marL="3657600" algn="l" defTabSz="914400" rtl="0" eaLnBrk="1" latinLnBrk="0" hangingPunct="1">
+      <a:defRPr sz="1200" kern="1200">
+        <a:solidFill>
+          <a:schemeClr val="tx1"/>
+        </a:solidFill>
+        <a:latin typeface="+mn-lt"/>
+        <a:ea typeface="+mn-ea"/>
+        <a:cs typeface="+mn-cs"/>
+      </a:defRPr>
+    </a:lvl9pPr>
+  </p:notesStyle>
+</p:notesMaster>
+</file>
+
 <file path=ppt/slideLayouts/slideLayout1.xml><?xml version="1.0" encoding="utf-8"?>
 <p:sldLayout xmlns:a="http://schemas.openxmlformats.org/drawingml/2006/main" xmlns:r="http://schemas.openxmlformats.org/officeDocument/2006/relationships" xmlns:p="http://schemas.openxmlformats.org/presentationml/2006/main" type="title" preserve="1">
   <p:cSld name="Title Slide">
@@ -312,7 +856,7 @@
           <a:p>
             <a:fld id="{5BCAD085-E8A6-8845-BD4E-CB4CCA059FC4}" type="datetimeFigureOut">
               <a:rPr lang="en-US" smtClean="0"/>
-              <a:t>8/28/2026</a:t>
+              <a:t>8/29/2026</a:t>
             </a:fld>
             <a:endParaRPr lang="en-US"/>
           </a:p>
@@ -480,7 +1024,7 @@
           <a:p>
             <a:fld id="{5BCAD085-E8A6-8845-BD4E-CB4CCA059FC4}" type="datetimeFigureOut">
               <a:rPr lang="en-US" smtClean="0"/>
-              <a:t>8/28/2026</a:t>
+              <a:t>8/29/2026</a:t>
             </a:fld>
             <a:endParaRPr lang="en-US"/>
           </a:p>
@@ -658,7 +1202,7 @@
           <a:p>
             <a:fld id="{5BCAD085-E8A6-8845-BD4E-CB4CCA059FC4}" type="datetimeFigureOut">
               <a:rPr lang="en-US" smtClean="0"/>
-              <a:t>8/28/2026</a:t>
+              <a:t>8/29/2026</a:t>
             </a:fld>
             <a:endParaRPr lang="en-US"/>
           </a:p>
@@ -826,7 +1370,7 @@
           <a:p>
             <a:fld id="{5BCAD085-E8A6-8845-BD4E-CB4CCA059FC4}" type="datetimeFigureOut">
               <a:rPr lang="en-US" smtClean="0"/>
-              <a:t>8/28/2026</a:t>
+              <a:t>8/29/2026</a:t>
             </a:fld>
             <a:endParaRPr lang="en-US"/>
           </a:p>
@@ -1071,7 +1615,7 @@
           <a:p>
             <a:fld id="{5BCAD085-E8A6-8845-BD4E-CB4CCA059FC4}" type="datetimeFigureOut">
               <a:rPr lang="en-US" smtClean="0"/>
-              <a:t>8/28/2026</a:t>
+              <a:t>8/29/2026</a:t>
             </a:fld>
             <a:endParaRPr lang="en-US"/>
           </a:p>
@@ -1356,7 +1900,7 @@
           <a:p>
             <a:fld id="{5BCAD085-E8A6-8845-BD4E-CB4CCA059FC4}" type="datetimeFigureOut">
               <a:rPr lang="en-US" smtClean="0"/>
-              <a:t>8/28/2026</a:t>
+              <a:t>8/29/2026</a:t>
             </a:fld>
             <a:endParaRPr lang="en-US"/>
           </a:p>
@@ -1775,7 +2319,7 @@
           <a:p>
             <a:fld id="{5BCAD085-E8A6-8845-BD4E-CB4CCA059FC4}" type="datetimeFigureOut">
               <a:rPr lang="en-US" smtClean="0"/>
-              <a:t>8/28/2026</a:t>
+              <a:t>8/29/2026</a:t>
             </a:fld>
             <a:endParaRPr lang="en-US"/>
           </a:p>
@@ -1892,7 +2436,7 @@
           <a:p>
             <a:fld id="{5BCAD085-E8A6-8845-BD4E-CB4CCA059FC4}" type="datetimeFigureOut">
               <a:rPr lang="en-US" smtClean="0"/>
-              <a:t>8/28/2026</a:t>
+              <a:t>8/29/2026</a:t>
             </a:fld>
             <a:endParaRPr lang="en-US"/>
           </a:p>
@@ -1987,7 +2531,7 @@
           <a:p>
             <a:fld id="{5BCAD085-E8A6-8845-BD4E-CB4CCA059FC4}" type="datetimeFigureOut">
               <a:rPr lang="en-US" smtClean="0"/>
-              <a:t>8/28/2026</a:t>
+              <a:t>8/29/2026</a:t>
             </a:fld>
             <a:endParaRPr lang="en-US"/>
           </a:p>
@@ -2262,7 +2806,7 @@
           <a:p>
             <a:fld id="{5BCAD085-E8A6-8845-BD4E-CB4CCA059FC4}" type="datetimeFigureOut">
               <a:rPr lang="en-US" smtClean="0"/>
-              <a:t>8/28/2026</a:t>
+              <a:t>8/29/2026</a:t>
             </a:fld>
             <a:endParaRPr lang="en-US"/>
           </a:p>
@@ -2514,7 +3058,7 @@
           <a:p>
             <a:fld id="{5BCAD085-E8A6-8845-BD4E-CB4CCA059FC4}" type="datetimeFigureOut">
               <a:rPr lang="en-US" smtClean="0"/>
-              <a:t>8/28/2026</a:t>
+              <a:t>8/29/2026</a:t>
             </a:fld>
             <a:endParaRPr lang="en-US"/>
           </a:p>
@@ -2725,7 +3269,7 @@
           <a:p>
             <a:fld id="{5BCAD085-E8A6-8845-BD4E-CB4CCA059FC4}" type="datetimeFigureOut">
               <a:rPr lang="en-US" smtClean="0"/>
-              <a:t>8/28/2026</a:t>
+              <a:t>8/29/2026</a:t>
             </a:fld>
             <a:endParaRPr lang="en-US"/>
           </a:p>
@@ -3140,7 +3684,7 @@
           <a:lstStyle/>
           <a:p>
             <a:pPr algn="ctr"/>
-            <a:endParaRPr/>
+            <a:endParaRPr dirty="0"/>
           </a:p>
         </p:txBody>
       </p:sp>
@@ -3600,1016 +4144,6 @@
 </p:sld>
 </file>
 
-<file path=ppt/slides/slide10.xml><?xml version="1.0" encoding="utf-8"?>
-<p:sld xmlns:a="http://schemas.openxmlformats.org/drawingml/2006/main" xmlns:r="http://schemas.openxmlformats.org/officeDocument/2006/relationships" xmlns:p="http://schemas.openxmlformats.org/presentationml/2006/main">
-  <p:cSld>
-    <p:spTree>
-      <p:nvGrpSpPr>
-        <p:cNvPr id="1" name=""/>
-        <p:cNvGrpSpPr/>
-        <p:nvPr/>
-      </p:nvGrpSpPr>
-      <p:grpSpPr>
-        <a:xfrm>
-          <a:off x="0" y="0"/>
-          <a:ext cx="0" cy="0"/>
-          <a:chOff x="0" y="0"/>
-          <a:chExt cx="0" cy="0"/>
-        </a:xfrm>
-      </p:grpSpPr>
-      <p:sp>
-        <p:nvSpPr>
-          <p:cNvPr id="2" name="Rectangle 1"/>
-          <p:cNvSpPr/>
-          <p:nvPr/>
-        </p:nvSpPr>
-        <p:spPr>
-          <a:xfrm>
-            <a:off x="0" y="0"/>
-            <a:ext cx="12191695" cy="6858000"/>
-          </a:xfrm>
-          <a:prstGeom prst="rect">
-            <a:avLst/>
-          </a:prstGeom>
-          <a:solidFill>
-            <a:srgbClr val="070A12"/>
-          </a:solidFill>
-          <a:ln>
-            <a:noFill/>
-          </a:ln>
-        </p:spPr>
-        <p:style>
-          <a:lnRef idx="1">
-            <a:schemeClr val="accent1"/>
-          </a:lnRef>
-          <a:fillRef idx="3">
-            <a:schemeClr val="accent1"/>
-          </a:fillRef>
-          <a:effectRef idx="2">
-            <a:schemeClr val="accent1"/>
-          </a:effectRef>
-          <a:fontRef idx="minor">
-            <a:schemeClr val="lt1"/>
-          </a:fontRef>
-        </p:style>
-        <p:txBody>
-          <a:bodyPr rtlCol="0" anchor="ctr"/>
-          <a:lstStyle/>
-          <a:p>
-            <a:pPr algn="ctr"/>
-            <a:endParaRPr/>
-          </a:p>
-        </p:txBody>
-      </p:sp>
-      <p:sp>
-        <p:nvSpPr>
-          <p:cNvPr id="3" name="TextBox 2"/>
-          <p:cNvSpPr txBox="1"/>
-          <p:nvPr/>
-        </p:nvSpPr>
-        <p:spPr>
-          <a:xfrm>
-            <a:off x="731520" y="365760"/>
-            <a:ext cx="10728655" cy="822960"/>
-          </a:xfrm>
-          <a:prstGeom prst="rect">
-            <a:avLst/>
-          </a:prstGeom>
-          <a:noFill/>
-        </p:spPr>
-        <p:txBody>
-          <a:bodyPr wrap="square" lIns="0" tIns="0" rIns="0" bIns="0">
-            <a:spAutoFit/>
-          </a:bodyPr>
-          <a:lstStyle/>
-          <a:p>
-            <a:pPr>
-              <a:defRPr sz="1300" b="1">
-                <a:solidFill>
-                  <a:srgbClr val="38BDF8"/>
-                </a:solidFill>
-              </a:defRPr>
-            </a:pPr>
-            <a:r>
-              <a:t>● LIVE DEMONSTRATION</a:t>
-            </a:r>
-          </a:p>
-          <a:p>
-            <a:pPr>
-              <a:defRPr sz="2400" b="1">
-                <a:solidFill>
-                  <a:srgbClr val="F8FAFC"/>
-                </a:solidFill>
-              </a:defRPr>
-            </a:pPr>
-            <a:r>
-              <a:t>實機錄影演示：雙題目 90 秒確定性攻防與 6P 閉環</a:t>
-            </a:r>
-          </a:p>
-        </p:txBody>
-      </p:sp>
-      <p:sp>
-        <p:nvSpPr>
-          <p:cNvPr id="4" name="Rounded Rectangle 3"/>
-          <p:cNvSpPr/>
-          <p:nvPr/>
-        </p:nvSpPr>
-        <p:spPr>
-          <a:xfrm>
-            <a:off x="731520" y="1280160"/>
-            <a:ext cx="10728655" cy="5029200"/>
-          </a:xfrm>
-          <a:prstGeom prst="roundRect">
-            <a:avLst/>
-          </a:prstGeom>
-          <a:solidFill>
-            <a:srgbClr val="0F172A"/>
-          </a:solidFill>
-          <a:ln w="19050">
-            <a:solidFill>
-              <a:srgbClr val="F87171"/>
-            </a:solidFill>
-          </a:ln>
-        </p:spPr>
-        <p:style>
-          <a:lnRef idx="1">
-            <a:schemeClr val="accent1"/>
-          </a:lnRef>
-          <a:fillRef idx="3">
-            <a:schemeClr val="accent1"/>
-          </a:fillRef>
-          <a:effectRef idx="2">
-            <a:schemeClr val="accent1"/>
-          </a:effectRef>
-          <a:fontRef idx="minor">
-            <a:schemeClr val="lt1"/>
-          </a:fontRef>
-        </p:style>
-        <p:txBody>
-          <a:bodyPr wrap="square" lIns="274320" tIns="228600" rIns="274320" bIns="182880" rtlCol="0" anchor="ctr"/>
-          <a:lstStyle/>
-          <a:p>
-            <a:pPr algn="ctr">
-              <a:defRPr sz="1900" b="1">
-                <a:solidFill>
-                  <a:srgbClr val="F87171"/>
-                </a:solidFill>
-              </a:defRPr>
-            </a:pPr>
-            <a:r>
-              <a:rPr sz="2400" dirty="0"/>
-              <a:t>🎥 【</a:t>
-            </a:r>
-            <a:r>
-              <a:rPr sz="2400" dirty="0" err="1"/>
-              <a:t>實機操作錄影播放區</a:t>
-            </a:r>
-            <a:r>
-              <a:rPr sz="2400" dirty="0"/>
-              <a:t> (Live Demo Video)】</a:t>
-            </a:r>
-            <a:endParaRPr lang="en-US" sz="2400" dirty="0"/>
-          </a:p>
-          <a:p>
-            <a:pPr algn="ctr">
-              <a:defRPr sz="1900" b="1">
-                <a:solidFill>
-                  <a:srgbClr val="F87171"/>
-                </a:solidFill>
-              </a:defRPr>
-            </a:pPr>
-            <a:endParaRPr dirty="0"/>
-          </a:p>
-          <a:p>
-            <a:pPr>
-              <a:defRPr sz="1400" b="1">
-                <a:solidFill>
-                  <a:srgbClr val="F8FAFC"/>
-                </a:solidFill>
-              </a:defRPr>
-            </a:pPr>
-            <a:r>
-              <a:rPr sz="1600" dirty="0"/>
-              <a:t>▶ [00:00 - 00:15] </a:t>
-            </a:r>
-            <a:r>
-              <a:rPr sz="1600" dirty="0" err="1"/>
-              <a:t>OpenShip</a:t>
-            </a:r>
-            <a:r>
-              <a:rPr sz="1600" dirty="0"/>
-              <a:t> </a:t>
-            </a:r>
-            <a:r>
-              <a:rPr sz="1600" dirty="0" err="1"/>
-              <a:t>主控發射台遙測</a:t>
-            </a:r>
-            <a:endParaRPr sz="1600" dirty="0"/>
-          </a:p>
-          <a:p>
-            <a:pPr>
-              <a:defRPr sz="1300">
-                <a:solidFill>
-                  <a:srgbClr val="CBD5E1"/>
-                </a:solidFill>
-              </a:defRPr>
-            </a:pPr>
-            <a:r>
-              <a:rPr sz="1600" dirty="0"/>
-              <a:t>   </a:t>
-            </a:r>
-            <a:r>
-              <a:rPr sz="1600" dirty="0" err="1"/>
-              <a:t>展示</a:t>
-            </a:r>
-            <a:r>
-              <a:rPr sz="1600" dirty="0"/>
-              <a:t> Multi-VEP </a:t>
-            </a:r>
-            <a:r>
-              <a:rPr sz="1600" dirty="0" err="1"/>
-              <a:t>跨機構星系圖，實時遙測穩定於</a:t>
-            </a:r>
-            <a:r>
-              <a:rPr sz="1600" dirty="0"/>
-              <a:t> 26.1 </a:t>
-            </a:r>
-            <a:r>
-              <a:rPr sz="1600" dirty="0" err="1"/>
-              <a:t>μs</a:t>
-            </a:r>
-            <a:r>
-              <a:rPr sz="1600" dirty="0"/>
-              <a:t> In-Band。</a:t>
-            </a:r>
-            <a:endParaRPr lang="en-US" sz="1600" dirty="0"/>
-          </a:p>
-          <a:p>
-            <a:pPr>
-              <a:defRPr sz="1300">
-                <a:solidFill>
-                  <a:srgbClr val="CBD5E1"/>
-                </a:solidFill>
-              </a:defRPr>
-            </a:pPr>
-            <a:endParaRPr sz="1600" dirty="0"/>
-          </a:p>
-          <a:p>
-            <a:pPr>
-              <a:defRPr sz="1400" b="1">
-                <a:solidFill>
-                  <a:srgbClr val="F8FAFC"/>
-                </a:solidFill>
-              </a:defRPr>
-            </a:pPr>
-            <a:r>
-              <a:rPr sz="1600" dirty="0"/>
-              <a:t>▶ [00:15 - 00:50] Track 03: </a:t>
-            </a:r>
-            <a:r>
-              <a:rPr sz="1600" dirty="0" err="1"/>
-              <a:t>醫療保險</a:t>
-            </a:r>
-            <a:r>
-              <a:rPr sz="1600" dirty="0"/>
-              <a:t> </a:t>
-            </a:r>
-            <a:r>
-              <a:rPr sz="1600" dirty="0" err="1"/>
-              <a:t>MediGuard</a:t>
-            </a:r>
-            <a:r>
-              <a:rPr sz="1600" dirty="0"/>
-              <a:t> VEP (按3個鈕)</a:t>
-            </a:r>
-          </a:p>
-          <a:p>
-            <a:pPr>
-              <a:defRPr sz="1300">
-                <a:solidFill>
-                  <a:srgbClr val="CBD5E1"/>
-                </a:solidFill>
-              </a:defRPr>
-            </a:pPr>
-            <a:r>
-              <a:rPr sz="1600" dirty="0"/>
-              <a:t>   ▶ </a:t>
-            </a:r>
-            <a:r>
-              <a:rPr sz="1600" dirty="0" err="1"/>
-              <a:t>一鍵合規理賠</a:t>
-            </a:r>
-            <a:r>
-              <a:rPr sz="1600" dirty="0"/>
-              <a:t> (18項PHI遮蔽) ➔ 💥 </a:t>
-            </a:r>
-            <a:r>
-              <a:rPr sz="1600" dirty="0" err="1"/>
-              <a:t>模擬越獄</a:t>
-            </a:r>
-            <a:r>
-              <a:rPr sz="1600" dirty="0"/>
-              <a:t> (26.1μs硬熔斷) ➔ 📜 </a:t>
-            </a:r>
-            <a:r>
-              <a:rPr sz="1600" dirty="0" err="1"/>
-              <a:t>Merkle收據</a:t>
-            </a:r>
-            <a:r>
-              <a:rPr sz="1600" dirty="0"/>
-              <a:t> + O(1) </a:t>
-            </a:r>
-            <a:r>
-              <a:rPr sz="1600" dirty="0" err="1"/>
-              <a:t>撤銷</a:t>
-            </a:r>
-            <a:r>
-              <a:rPr sz="1600" dirty="0"/>
-              <a:t>。</a:t>
-            </a:r>
-            <a:endParaRPr lang="en-US" sz="1600" dirty="0"/>
-          </a:p>
-          <a:p>
-            <a:pPr>
-              <a:defRPr sz="1300">
-                <a:solidFill>
-                  <a:srgbClr val="CBD5E1"/>
-                </a:solidFill>
-              </a:defRPr>
-            </a:pPr>
-            <a:endParaRPr sz="1600" dirty="0"/>
-          </a:p>
-          <a:p>
-            <a:pPr>
-              <a:defRPr sz="1400" b="1">
-                <a:solidFill>
-                  <a:srgbClr val="F8FAFC"/>
-                </a:solidFill>
-              </a:defRPr>
-            </a:pPr>
-            <a:r>
-              <a:rPr sz="1600" dirty="0"/>
-              <a:t>▶ [00:50 - 01:25] Track 04: </a:t>
-            </a:r>
-            <a:r>
-              <a:rPr sz="1600" dirty="0" err="1"/>
-              <a:t>政府跨機關代辦</a:t>
-            </a:r>
-            <a:r>
-              <a:rPr sz="1600" dirty="0"/>
-              <a:t> </a:t>
-            </a:r>
-            <a:r>
-              <a:rPr sz="1600" dirty="0" err="1"/>
-              <a:t>GovProxy</a:t>
-            </a:r>
-            <a:r>
-              <a:rPr sz="1600" dirty="0"/>
-              <a:t> VEP (按3個鈕)</a:t>
-            </a:r>
-          </a:p>
-          <a:p>
-            <a:pPr>
-              <a:defRPr sz="1300">
-                <a:solidFill>
-                  <a:srgbClr val="CBD5E1"/>
-                </a:solidFill>
-              </a:defRPr>
-            </a:pPr>
-            <a:r>
-              <a:rPr sz="1600" dirty="0"/>
-              <a:t>   ▶ </a:t>
-            </a:r>
-            <a:r>
-              <a:rPr sz="1600" dirty="0" err="1"/>
-              <a:t>跨機關合規代辦</a:t>
-            </a:r>
-            <a:r>
-              <a:rPr sz="1600" dirty="0"/>
-              <a:t> (</a:t>
-            </a:r>
-            <a:r>
-              <a:rPr sz="1600" dirty="0" err="1"/>
-              <a:t>MyData+vLEI</a:t>
-            </a:r>
-            <a:r>
-              <a:rPr sz="1600" dirty="0"/>
-              <a:t>) ➔ 💥 </a:t>
-            </a:r>
-            <a:r>
-              <a:rPr sz="1600" dirty="0" err="1"/>
-              <a:t>越權調閱全戶日誌</a:t>
-            </a:r>
-            <a:r>
-              <a:rPr sz="1600" dirty="0"/>
-              <a:t> (HTTP 403熔斷) ➔ 📜 W3C憑證 + </a:t>
-            </a:r>
-            <a:r>
-              <a:rPr sz="1600" dirty="0" err="1"/>
-              <a:t>廢止代理</a:t>
-            </a:r>
-            <a:r>
-              <a:rPr sz="1600" dirty="0"/>
-              <a:t>。</a:t>
-            </a:r>
-            <a:endParaRPr lang="en-US" sz="1600" dirty="0"/>
-          </a:p>
-          <a:p>
-            <a:pPr>
-              <a:defRPr sz="1300">
-                <a:solidFill>
-                  <a:srgbClr val="CBD5E1"/>
-                </a:solidFill>
-              </a:defRPr>
-            </a:pPr>
-            <a:endParaRPr sz="1600" dirty="0"/>
-          </a:p>
-          <a:p>
-            <a:pPr>
-              <a:defRPr sz="1400" b="1">
-                <a:solidFill>
-                  <a:srgbClr val="F8FAFC"/>
-                </a:solidFill>
-              </a:defRPr>
-            </a:pPr>
-            <a:r>
-              <a:rPr sz="1600" dirty="0"/>
-              <a:t>▶ [01:25 - 01:30] </a:t>
-            </a:r>
-            <a:r>
-              <a:rPr sz="1600" dirty="0" err="1"/>
-              <a:t>終端機極速單元測試驗證</a:t>
-            </a:r>
-            <a:endParaRPr sz="1600" dirty="0"/>
-          </a:p>
-          <a:p>
-            <a:pPr>
-              <a:defRPr sz="1300">
-                <a:solidFill>
-                  <a:srgbClr val="CBD5E1"/>
-                </a:solidFill>
-              </a:defRPr>
-            </a:pPr>
-            <a:r>
-              <a:rPr sz="1600" dirty="0"/>
-              <a:t>   </a:t>
-            </a:r>
-            <a:r>
-              <a:rPr lang="zh-TW" altLang="en-US" sz="1600" dirty="0"/>
-              <a:t>可</a:t>
-            </a:r>
-            <a:r>
-              <a:rPr sz="1600" dirty="0" err="1"/>
-              <a:t>執行</a:t>
-            </a:r>
-            <a:r>
-              <a:rPr sz="1600" dirty="0"/>
-              <a:t> </a:t>
-            </a:r>
-            <a:r>
-              <a:rPr sz="1600" dirty="0">
-                <a:solidFill>
-                  <a:srgbClr val="FFC000"/>
-                </a:solidFill>
-              </a:rPr>
-              <a:t>python test_verification_suite.py </a:t>
-            </a:r>
-            <a:r>
-              <a:rPr sz="1600" dirty="0"/>
-              <a:t>➔ 0.001 秒 5/5 </a:t>
-            </a:r>
-            <a:r>
-              <a:rPr lang="zh-TW" altLang="en-US" sz="1600" dirty="0"/>
-              <a:t>驗證</a:t>
-            </a:r>
-            <a:r>
-              <a:rPr sz="1600" dirty="0" err="1"/>
-              <a:t>斷言通過</a:t>
-            </a:r>
-            <a:r>
-              <a:rPr sz="1600" dirty="0"/>
-              <a:t>！</a:t>
-            </a:r>
-          </a:p>
-        </p:txBody>
-      </p:sp>
-    </p:spTree>
-  </p:cSld>
-  <p:clrMapOvr>
-    <a:masterClrMapping/>
-  </p:clrMapOvr>
-</p:sld>
-</file>
-
-<file path=ppt/slides/slide11.xml><?xml version="1.0" encoding="utf-8"?>
-<p:sld xmlns:a="http://schemas.openxmlformats.org/drawingml/2006/main" xmlns:r="http://schemas.openxmlformats.org/officeDocument/2006/relationships" xmlns:p="http://schemas.openxmlformats.org/presentationml/2006/main">
-  <p:cSld>
-    <p:spTree>
-      <p:nvGrpSpPr>
-        <p:cNvPr id="1" name=""/>
-        <p:cNvGrpSpPr/>
-        <p:nvPr/>
-      </p:nvGrpSpPr>
-      <p:grpSpPr>
-        <a:xfrm>
-          <a:off x="0" y="0"/>
-          <a:ext cx="0" cy="0"/>
-          <a:chOff x="0" y="0"/>
-          <a:chExt cx="0" cy="0"/>
-        </a:xfrm>
-      </p:grpSpPr>
-      <p:sp>
-        <p:nvSpPr>
-          <p:cNvPr id="2" name="Rectangle 1"/>
-          <p:cNvSpPr/>
-          <p:nvPr/>
-        </p:nvSpPr>
-        <p:spPr>
-          <a:xfrm>
-            <a:off x="0" y="0"/>
-            <a:ext cx="12191695" cy="6858000"/>
-          </a:xfrm>
-          <a:prstGeom prst="rect">
-            <a:avLst/>
-          </a:prstGeom>
-          <a:solidFill>
-            <a:srgbClr val="070A12"/>
-          </a:solidFill>
-          <a:ln>
-            <a:noFill/>
-          </a:ln>
-        </p:spPr>
-        <p:style>
-          <a:lnRef idx="1">
-            <a:schemeClr val="accent1"/>
-          </a:lnRef>
-          <a:fillRef idx="3">
-            <a:schemeClr val="accent1"/>
-          </a:fillRef>
-          <a:effectRef idx="2">
-            <a:schemeClr val="accent1"/>
-          </a:effectRef>
-          <a:fontRef idx="minor">
-            <a:schemeClr val="lt1"/>
-          </a:fontRef>
-        </p:style>
-        <p:txBody>
-          <a:bodyPr rtlCol="0" anchor="ctr"/>
-          <a:lstStyle/>
-          <a:p>
-            <a:pPr algn="ctr"/>
-            <a:endParaRPr/>
-          </a:p>
-        </p:txBody>
-      </p:sp>
-      <p:sp>
-        <p:nvSpPr>
-          <p:cNvPr id="3" name="TextBox 2"/>
-          <p:cNvSpPr txBox="1"/>
-          <p:nvPr/>
-        </p:nvSpPr>
-        <p:spPr>
-          <a:xfrm>
-            <a:off x="731520" y="365760"/>
-            <a:ext cx="10728655" cy="822960"/>
-          </a:xfrm>
-          <a:prstGeom prst="rect">
-            <a:avLst/>
-          </a:prstGeom>
-          <a:noFill/>
-        </p:spPr>
-        <p:txBody>
-          <a:bodyPr wrap="square" lIns="0" tIns="0" rIns="0" bIns="0">
-            <a:spAutoFit/>
-          </a:bodyPr>
-          <a:lstStyle/>
-          <a:p>
-            <a:pPr>
-              <a:defRPr sz="1300" b="1">
-                <a:solidFill>
-                  <a:srgbClr val="38BDF8"/>
-                </a:solidFill>
-              </a:defRPr>
-            </a:pPr>
-            <a:r>
-              <a:t>● CONCLUSION</a:t>
-            </a:r>
-          </a:p>
-          <a:p>
-            <a:pPr>
-              <a:defRPr sz="2400" b="1">
-                <a:solidFill>
-                  <a:srgbClr val="F8FAFC"/>
-                </a:solidFill>
-              </a:defRPr>
-            </a:pPr>
-            <a:r>
-              <a:t>範式轉移：從 Application Toolkit 到 Agent Operating System</a:t>
-            </a:r>
-          </a:p>
-        </p:txBody>
-      </p:sp>
-      <p:sp>
-        <p:nvSpPr>
-          <p:cNvPr id="4" name="Rounded Rectangle 3"/>
-          <p:cNvSpPr/>
-          <p:nvPr/>
-        </p:nvSpPr>
-        <p:spPr>
-          <a:xfrm>
-            <a:off x="731520" y="1188720"/>
-            <a:ext cx="10728655" cy="5212080"/>
-          </a:xfrm>
-          <a:prstGeom prst="roundRect">
-            <a:avLst/>
-          </a:prstGeom>
-          <a:solidFill>
-            <a:srgbClr val="0F172A"/>
-          </a:solidFill>
-          <a:ln w="19050">
-            <a:solidFill>
-              <a:srgbClr val="38BDF8"/>
-            </a:solidFill>
-          </a:ln>
-        </p:spPr>
-        <p:style>
-          <a:lnRef idx="1">
-            <a:schemeClr val="accent1"/>
-          </a:lnRef>
-          <a:fillRef idx="3">
-            <a:schemeClr val="accent1"/>
-          </a:fillRef>
-          <a:effectRef idx="2">
-            <a:schemeClr val="accent1"/>
-          </a:effectRef>
-          <a:fontRef idx="minor">
-            <a:schemeClr val="lt1"/>
-          </a:fontRef>
-        </p:style>
-        <p:txBody>
-          <a:bodyPr wrap="square" lIns="274320" tIns="228600" rIns="274320" bIns="182880" rtlCol="0" anchor="ctr"/>
-          <a:lstStyle/>
-          <a:p>
-            <a:pPr algn="ctr">
-              <a:defRPr sz="2200" b="1">
-                <a:solidFill>
-                  <a:srgbClr val="38BDF8"/>
-                </a:solidFill>
-              </a:defRPr>
-            </a:pPr>
-            <a:r>
-              <a:rPr sz="2800" dirty="0"/>
-              <a:t>🏆 DROS: </a:t>
-            </a:r>
-            <a:r>
-              <a:rPr lang="zh-TW" altLang="en-US" sz="2800" dirty="0"/>
-              <a:t>讓治理成為基建</a:t>
-            </a:r>
-            <a:r>
-              <a:rPr sz="2800" dirty="0"/>
-              <a:t>，</a:t>
-            </a:r>
-            <a:r>
-              <a:rPr lang="zh-TW" altLang="en-US" sz="2800" dirty="0"/>
-              <a:t>讓</a:t>
-            </a:r>
-            <a:r>
-              <a:rPr sz="2800" dirty="0"/>
-              <a:t> AI </a:t>
-            </a:r>
-            <a:r>
-              <a:rPr lang="zh-TW" altLang="en-US" sz="2800" dirty="0"/>
-              <a:t>應用海闊天空</a:t>
-            </a:r>
-            <a:endParaRPr lang="en-US" altLang="zh-TW" sz="2800" dirty="0"/>
-          </a:p>
-          <a:p>
-            <a:pPr algn="ctr">
-              <a:defRPr sz="2200" b="1">
-                <a:solidFill>
-                  <a:srgbClr val="38BDF8"/>
-                </a:solidFill>
-              </a:defRPr>
-            </a:pPr>
-            <a:endParaRPr lang="en-US" dirty="0"/>
-          </a:p>
-          <a:p>
-            <a:pPr algn="ctr">
-              <a:defRPr sz="2200" b="1">
-                <a:solidFill>
-                  <a:srgbClr val="38BDF8"/>
-                </a:solidFill>
-              </a:defRPr>
-            </a:pPr>
-            <a:endParaRPr dirty="0"/>
-          </a:p>
-          <a:p>
-            <a:pPr>
-              <a:defRPr sz="1600" b="1">
-                <a:solidFill>
-                  <a:srgbClr val="F8FAFC"/>
-                </a:solidFill>
-              </a:defRPr>
-            </a:pPr>
-            <a:r>
-              <a:rPr dirty="0"/>
-              <a:t>▶ </a:t>
-            </a:r>
-            <a:r>
-              <a:rPr dirty="0" err="1"/>
-              <a:t>我們不是再做一個</a:t>
-            </a:r>
-            <a:r>
-              <a:rPr dirty="0"/>
-              <a:t> </a:t>
-            </a:r>
-            <a:r>
-              <a:rPr dirty="0" err="1"/>
-              <a:t>Agent，也不是再做一套應用層安全工具</a:t>
-            </a:r>
-            <a:r>
-              <a:rPr dirty="0"/>
-              <a:t>。</a:t>
-            </a:r>
-            <a:endParaRPr lang="en-US" dirty="0"/>
-          </a:p>
-          <a:p>
-            <a:pPr>
-              <a:defRPr sz="1600" b="1">
-                <a:solidFill>
-                  <a:srgbClr val="F8FAFC"/>
-                </a:solidFill>
-              </a:defRPr>
-            </a:pPr>
-            <a:endParaRPr dirty="0"/>
-          </a:p>
-          <a:p>
-            <a:pPr>
-              <a:defRPr sz="1500" b="0">
-                <a:solidFill>
-                  <a:srgbClr val="4ADE80"/>
-                </a:solidFill>
-              </a:defRPr>
-            </a:pPr>
-            <a:r>
-              <a:rPr dirty="0"/>
-              <a:t>▶ </a:t>
-            </a:r>
-            <a:r>
-              <a:rPr dirty="0" err="1"/>
-              <a:t>我們做的是把</a:t>
-            </a:r>
-            <a:r>
-              <a:rPr dirty="0"/>
-              <a:t> Agent Governance </a:t>
-            </a:r>
-            <a:r>
-              <a:rPr dirty="0" err="1"/>
-              <a:t>從每個應用都必須重新解決的問題，收斂成一個共享的</a:t>
-            </a:r>
-            <a:r>
-              <a:rPr dirty="0"/>
-              <a:t> Execution Infrastructure。</a:t>
-            </a:r>
-            <a:endParaRPr lang="en-US" dirty="0"/>
-          </a:p>
-          <a:p>
-            <a:pPr>
-              <a:defRPr sz="1500" b="0">
-                <a:solidFill>
-                  <a:srgbClr val="4ADE80"/>
-                </a:solidFill>
-              </a:defRPr>
-            </a:pPr>
-            <a:endParaRPr dirty="0"/>
-          </a:p>
-          <a:p>
-            <a:pPr>
-              <a:defRPr sz="1500" b="0">
-                <a:solidFill>
-                  <a:srgbClr val="FBBF24"/>
-                </a:solidFill>
-              </a:defRPr>
-            </a:pPr>
-            <a:r>
-              <a:rPr dirty="0"/>
-              <a:t>▶ </a:t>
-            </a:r>
-            <a:r>
-              <a:rPr dirty="0">
-                <a:latin typeface="+mn-ea"/>
-              </a:rPr>
-              <a:t>讓</a:t>
-            </a:r>
-            <a:r>
-              <a:rPr lang="zh-TW" altLang="en-US" dirty="0">
-                <a:latin typeface="GenSenRounded JP M" panose="020B0600000000000000" pitchFamily="34" charset="-128"/>
-                <a:ea typeface="GenSenRounded JP M" panose="020B0600000000000000" pitchFamily="34" charset="-128"/>
-              </a:rPr>
-              <a:t>所有</a:t>
-            </a:r>
-            <a:r>
-              <a:rPr dirty="0" err="1">
-                <a:latin typeface="+mn-ea"/>
-              </a:rPr>
-              <a:t>開發者專注於</a:t>
-            </a:r>
-            <a:r>
-              <a:rPr dirty="0">
-                <a:latin typeface="+mn-ea"/>
-              </a:rPr>
-              <a:t>：「Agent </a:t>
-            </a:r>
-            <a:r>
-              <a:rPr dirty="0" err="1">
-                <a:latin typeface="+mn-ea"/>
-              </a:rPr>
-              <a:t>要完成什麼</a:t>
-            </a:r>
-            <a:r>
-              <a:rPr dirty="0">
-                <a:latin typeface="+mn-ea"/>
-              </a:rPr>
-              <a:t>」；</a:t>
-            </a:r>
-            <a:r>
-              <a:rPr dirty="0" err="1">
-                <a:latin typeface="+mn-ea"/>
-              </a:rPr>
-              <a:t>而不是每一次都重新思考</a:t>
-            </a:r>
-            <a:r>
-              <a:rPr dirty="0">
-                <a:latin typeface="+mn-ea"/>
-              </a:rPr>
-              <a:t>：「Agent </a:t>
-            </a:r>
-            <a:r>
-              <a:rPr dirty="0" err="1">
-                <a:latin typeface="+mn-ea"/>
-              </a:rPr>
-              <a:t>做錯了，我怎麼阻止它</a:t>
-            </a:r>
-            <a:r>
-              <a:rPr dirty="0">
-                <a:latin typeface="+mn-ea"/>
-              </a:rPr>
-              <a:t>」。</a:t>
-            </a:r>
-            <a:endParaRPr lang="en-US" dirty="0">
-              <a:latin typeface="+mn-ea"/>
-            </a:endParaRPr>
-          </a:p>
-          <a:p>
-            <a:pPr>
-              <a:defRPr sz="1500" b="0">
-                <a:solidFill>
-                  <a:srgbClr val="FBBF24"/>
-                </a:solidFill>
-              </a:defRPr>
-            </a:pPr>
-            <a:endParaRPr dirty="0"/>
-          </a:p>
-          <a:p>
-            <a:pPr>
-              <a:defRPr sz="1700" b="1">
-                <a:solidFill>
-                  <a:srgbClr val="F8FAFC"/>
-                </a:solidFill>
-              </a:defRPr>
-            </a:pPr>
-            <a:r>
-              <a:rPr dirty="0"/>
-              <a:t>▶ 「</a:t>
-            </a:r>
-            <a:r>
-              <a:rPr dirty="0" err="1"/>
-              <a:t>治理是前提，而不是補丁；唯有底層確定性閉環</a:t>
-            </a:r>
-            <a:r>
-              <a:rPr dirty="0"/>
-              <a:t>，</a:t>
-            </a:r>
-            <a:r>
-              <a:rPr lang="zh-TW" altLang="en-US" dirty="0">
-                <a:latin typeface="GenSenRounded JP M" panose="020B0600000000000000" pitchFamily="34" charset="-128"/>
-                <a:ea typeface="GenSenRounded JP M" panose="020B0600000000000000" pitchFamily="34" charset="-128"/>
-              </a:rPr>
-              <a:t>並能</a:t>
-            </a:r>
-            <a:r>
-              <a:rPr dirty="0" err="1"/>
-              <a:t>面對海量高頻穩健存活，上層應用才</a:t>
-            </a:r>
-            <a:r>
-              <a:rPr lang="zh-TW" altLang="en-US" dirty="0">
-                <a:latin typeface="GenSenRounded JP M" panose="020B0600000000000000" pitchFamily="34" charset="-128"/>
-                <a:ea typeface="GenSenRounded JP M" panose="020B0600000000000000" pitchFamily="34" charset="-128"/>
-              </a:rPr>
-              <a:t>有</a:t>
-            </a:r>
-            <a:r>
-              <a:rPr dirty="0" err="1"/>
-              <a:t>真正海闊天空</a:t>
-            </a:r>
-            <a:r>
-              <a:rPr dirty="0"/>
-              <a:t>！」</a:t>
-            </a:r>
-            <a:endParaRPr lang="en-US" dirty="0"/>
-          </a:p>
-          <a:p>
-            <a:pPr>
-              <a:defRPr sz="1700" b="1">
-                <a:solidFill>
-                  <a:srgbClr val="F8FAFC"/>
-                </a:solidFill>
-              </a:defRPr>
-            </a:pPr>
-            <a:endParaRPr lang="en-US" dirty="0"/>
-          </a:p>
-          <a:p>
-            <a:pPr algn="ctr">
-              <a:defRPr sz="1700" b="1">
-                <a:solidFill>
-                  <a:srgbClr val="F8FAFC"/>
-                </a:solidFill>
-              </a:defRPr>
-            </a:pPr>
-            <a:endParaRPr lang="en-US" dirty="0"/>
-          </a:p>
-          <a:p>
-            <a:pPr algn="ctr">
-              <a:defRPr sz="1700" b="1">
-                <a:solidFill>
-                  <a:srgbClr val="F8FAFC"/>
-                </a:solidFill>
-              </a:defRPr>
-            </a:pPr>
-            <a:r>
-              <a:rPr lang="en-US" sz="3200" dirty="0">
-                <a:solidFill>
-                  <a:srgbClr val="FFC000"/>
-                </a:solidFill>
-              </a:rPr>
-              <a:t>DROS</a:t>
-            </a:r>
-            <a:r>
-              <a:rPr lang="zh-TW" altLang="en-US" sz="3200" dirty="0">
-                <a:solidFill>
-                  <a:srgbClr val="FFC000"/>
-                </a:solidFill>
-              </a:rPr>
-              <a:t> 是 </a:t>
-            </a:r>
-            <a:r>
-              <a:rPr lang="en-US" altLang="zh-TW" sz="3200" dirty="0">
-                <a:solidFill>
-                  <a:srgbClr val="FFC000"/>
-                </a:solidFill>
-              </a:rPr>
-              <a:t>Agentic Era</a:t>
-            </a:r>
-            <a:r>
-              <a:rPr lang="zh-TW" altLang="en-US" sz="3200" dirty="0">
-                <a:solidFill>
-                  <a:srgbClr val="FFC000"/>
-                </a:solidFill>
-              </a:rPr>
-              <a:t> 的 </a:t>
-            </a:r>
-            <a:r>
-              <a:rPr lang="en-US" altLang="zh-TW" sz="3200" dirty="0">
-                <a:solidFill>
-                  <a:srgbClr val="FFC000"/>
-                </a:solidFill>
-              </a:rPr>
-              <a:t>Infrastructure</a:t>
-            </a:r>
-            <a:r>
-              <a:rPr lang="zh-TW" altLang="en-US" sz="3200" dirty="0">
-                <a:solidFill>
-                  <a:srgbClr val="FFC000"/>
-                </a:solidFill>
-              </a:rPr>
-              <a:t> ～</a:t>
-            </a:r>
-            <a:endParaRPr sz="3200" dirty="0">
-              <a:solidFill>
-                <a:srgbClr val="FFC000"/>
-              </a:solidFill>
-            </a:endParaRPr>
-          </a:p>
-        </p:txBody>
-      </p:sp>
-    </p:spTree>
-  </p:cSld>
-  <p:clrMapOvr>
-    <a:masterClrMapping/>
-  </p:clrMapOvr>
-</p:sld>
-</file>
-
 <file path=ppt/slides/slide2.xml><?xml version="1.0" encoding="utf-8"?>
 <p:sld xmlns:a="http://schemas.openxmlformats.org/drawingml/2006/main" xmlns:r="http://schemas.openxmlformats.org/officeDocument/2006/relationships" xmlns:p="http://schemas.openxmlformats.org/presentationml/2006/main">
   <p:cSld>
@@ -5484,8 +5018,8 @@
         </p:nvSpPr>
         <p:spPr>
           <a:xfrm>
-            <a:off x="731520" y="1280160"/>
-            <a:ext cx="3413455" cy="3171767"/>
+            <a:off x="731520" y="1557240"/>
+            <a:ext cx="3413455" cy="4298604"/>
           </a:xfrm>
           <a:prstGeom prst="roundRect">
             <a:avLst/>
@@ -5757,8 +5291,8 @@
         </p:nvSpPr>
         <p:spPr>
           <a:xfrm>
-            <a:off x="4389120" y="1280160"/>
-            <a:ext cx="3413455" cy="3171767"/>
+            <a:off x="4389120" y="1557240"/>
+            <a:ext cx="3413455" cy="4298604"/>
           </a:xfrm>
           <a:prstGeom prst="roundRect">
             <a:avLst/>
@@ -5823,6 +5357,23 @@
               <a:rPr dirty="0"/>
               <a:t>Policy Gate</a:t>
             </a:r>
+            <a:r>
+              <a:rPr lang="zh-TW" altLang="en-US" dirty="0"/>
+              <a:t> </a:t>
+            </a:r>
+            <a:r>
+              <a:rPr lang="en-US" altLang="zh-TW" dirty="0"/>
+              <a:t>–</a:t>
+            </a:r>
+            <a:r>
+              <a:rPr lang="zh-TW" altLang="en-US" dirty="0"/>
+              <a:t> </a:t>
+            </a:r>
+            <a:r>
+              <a:rPr lang="en-US" altLang="zh-TW" dirty="0"/>
+              <a:t>C-ABI</a:t>
+            </a:r>
+            <a:endParaRPr dirty="0"/>
           </a:p>
           <a:p>
             <a:pPr>
@@ -6002,8 +5553,8 @@
         </p:nvSpPr>
         <p:spPr>
           <a:xfrm>
-            <a:off x="8046720" y="1280160"/>
-            <a:ext cx="3413455" cy="3171767"/>
+            <a:off x="8046720" y="1557240"/>
+            <a:ext cx="3413455" cy="4298604"/>
           </a:xfrm>
           <a:prstGeom prst="roundRect">
             <a:avLst/>
@@ -6220,716 +5771,6 @@
               <a:rPr dirty="0"/>
               <a:t>。</a:t>
             </a:r>
-          </a:p>
-        </p:txBody>
-      </p:sp>
-      <p:sp>
-        <p:nvSpPr>
-          <p:cNvPr id="7" name="文字方塊 6">
-            <a:extLst>
-              <a:ext uri="{FF2B5EF4-FFF2-40B4-BE49-F238E27FC236}">
-                <a16:creationId xmlns:a16="http://schemas.microsoft.com/office/drawing/2014/main" id="{A87B8A39-51D7-E72A-60F7-32BB87BD18BC}"/>
-              </a:ext>
-            </a:extLst>
-          </p:cNvPr>
-          <p:cNvSpPr txBox="1"/>
-          <p:nvPr/>
-        </p:nvSpPr>
-        <p:spPr>
-          <a:xfrm>
-            <a:off x="731520" y="4791679"/>
-            <a:ext cx="3413455" cy="1384995"/>
-          </a:xfrm>
-          <a:prstGeom prst="rect">
-            <a:avLst/>
-          </a:prstGeom>
-          <a:noFill/>
-        </p:spPr>
-        <p:txBody>
-          <a:bodyPr wrap="square" rtlCol="0">
-            <a:spAutoFit/>
-          </a:bodyPr>
-          <a:lstStyle/>
-          <a:p>
-            <a:pPr marL="171450" indent="-171450" algn="l">
-              <a:buFont typeface="Arial" panose="020B0604020202020204" pitchFamily="34" charset="0"/>
-              <a:buChar char="•"/>
-            </a:pPr>
-            <a:r>
-              <a:rPr lang="zh-TW" altLang="en-US" sz="1200" b="0" i="0" dirty="0">
-                <a:solidFill>
-                  <a:srgbClr val="F8F8F2"/>
-                </a:solidFill>
-                <a:effectLst/>
-                <a:latin typeface="system-ui"/>
-              </a:rPr>
-              <a:t>每個 </a:t>
-            </a:r>
-            <a:r>
-              <a:rPr lang="en-US" altLang="zh-TW" sz="1200" b="0" i="0" dirty="0">
-                <a:solidFill>
-                  <a:srgbClr val="F8F8F2"/>
-                </a:solidFill>
-                <a:effectLst/>
-                <a:latin typeface="system-ui"/>
-              </a:rPr>
-              <a:t>AI Agent </a:t>
-            </a:r>
-            <a:r>
-              <a:rPr lang="zh-TW" altLang="en-US" sz="1200" b="0" i="0" dirty="0">
-                <a:solidFill>
-                  <a:srgbClr val="F8F8F2"/>
-                </a:solidFill>
-                <a:effectLst/>
-                <a:latin typeface="system-ui"/>
-              </a:rPr>
-              <a:t>啟動時，系統自動注入一組不可偽造的加密身分憑證。</a:t>
-            </a:r>
-            <a:endParaRPr lang="en-US" altLang="zh-TW" sz="1200" b="0" i="0" dirty="0">
-              <a:solidFill>
-                <a:srgbClr val="F8F8F2"/>
-              </a:solidFill>
-              <a:effectLst/>
-              <a:latin typeface="system-ui"/>
-            </a:endParaRPr>
-          </a:p>
-          <a:p>
-            <a:pPr algn="l">
-              <a:buFont typeface="Arial" panose="020B0604020202020204" pitchFamily="34" charset="0"/>
-              <a:buChar char="•"/>
-            </a:pPr>
-            <a:endParaRPr lang="zh-TW" altLang="en-US" sz="1200" b="0" i="0" dirty="0">
-              <a:solidFill>
-                <a:srgbClr val="F8F8F2"/>
-              </a:solidFill>
-              <a:effectLst/>
-              <a:latin typeface="system-ui"/>
-            </a:endParaRPr>
-          </a:p>
-          <a:p>
-            <a:pPr marL="171450" indent="-171450" algn="l">
-              <a:buFont typeface="Arial" panose="020B0604020202020204" pitchFamily="34" charset="0"/>
-              <a:buChar char="•"/>
-            </a:pPr>
-            <a:r>
-              <a:rPr lang="zh-TW" altLang="en-US" sz="1200" b="0" i="0" dirty="0">
-                <a:solidFill>
-                  <a:srgbClr val="F8F8F2"/>
-                </a:solidFill>
-                <a:effectLst/>
-                <a:latin typeface="system-ui"/>
-              </a:rPr>
-              <a:t>憑證強綁定：</a:t>
-            </a:r>
-            <a:r>
-              <a:rPr lang="zh-TW" altLang="en-US" sz="1200" b="1" i="0" dirty="0">
-                <a:solidFill>
-                  <a:srgbClr val="F8F8F2"/>
-                </a:solidFill>
-                <a:effectLst/>
-                <a:latin typeface="system-ui"/>
-              </a:rPr>
-              <a:t>「誰（</a:t>
-            </a:r>
-            <a:r>
-              <a:rPr lang="en-US" altLang="zh-TW" sz="1200" b="1" i="0" dirty="0">
-                <a:solidFill>
-                  <a:srgbClr val="F8F8F2"/>
-                </a:solidFill>
-                <a:effectLst/>
-                <a:latin typeface="system-ui"/>
-              </a:rPr>
-              <a:t>Agent ID / </a:t>
-            </a:r>
-            <a:r>
-              <a:rPr lang="zh-TW" altLang="en-US" sz="1200" b="1" i="0" dirty="0">
-                <a:solidFill>
-                  <a:srgbClr val="F8F8F2"/>
-                </a:solidFill>
-                <a:effectLst/>
-                <a:latin typeface="system-ui"/>
-              </a:rPr>
-              <a:t>法人 </a:t>
-            </a:r>
-            <a:r>
-              <a:rPr lang="en-US" altLang="zh-TW" sz="1200" b="1" i="0" dirty="0" err="1">
-                <a:solidFill>
-                  <a:srgbClr val="F8F8F2"/>
-                </a:solidFill>
-                <a:effectLst/>
-                <a:latin typeface="system-ui"/>
-              </a:rPr>
-              <a:t>vLEI</a:t>
-            </a:r>
-            <a:r>
-              <a:rPr lang="en-US" altLang="zh-TW" sz="1200" b="1" i="0" dirty="0">
-                <a:solidFill>
-                  <a:srgbClr val="F8F8F2"/>
-                </a:solidFill>
-                <a:effectLst/>
-                <a:latin typeface="system-ui"/>
-              </a:rPr>
-              <a:t> / </a:t>
-            </a:r>
-            <a:r>
-              <a:rPr lang="zh-TW" altLang="en-US" sz="1200" b="1" i="0" dirty="0">
-                <a:solidFill>
-                  <a:srgbClr val="F8F8F2"/>
-                </a:solidFill>
-                <a:effectLst/>
-                <a:latin typeface="system-ui"/>
-              </a:rPr>
-              <a:t>自然人 </a:t>
-            </a:r>
-            <a:r>
-              <a:rPr lang="en-US" altLang="zh-TW" sz="1200" b="1" i="0" dirty="0" err="1">
-                <a:solidFill>
-                  <a:srgbClr val="F8F8F2"/>
-                </a:solidFill>
-                <a:effectLst/>
-                <a:latin typeface="system-ui"/>
-              </a:rPr>
-              <a:t>MyData</a:t>
-            </a:r>
-            <a:r>
-              <a:rPr lang="zh-TW" altLang="en-US" sz="1200" b="1" i="0" dirty="0">
-                <a:solidFill>
-                  <a:srgbClr val="F8F8F2"/>
-                </a:solidFill>
-                <a:effectLst/>
-                <a:latin typeface="system-ui"/>
-              </a:rPr>
-              <a:t>）＋ 被授權做什麼（</a:t>
-            </a:r>
-            <a:r>
-              <a:rPr lang="en-US" altLang="zh-TW" sz="1200" b="1" i="0" dirty="0">
-                <a:solidFill>
-                  <a:srgbClr val="F8F8F2"/>
-                </a:solidFill>
-                <a:effectLst/>
-                <a:latin typeface="system-ui"/>
-              </a:rPr>
-              <a:t>Scope </a:t>
-            </a:r>
-            <a:r>
-              <a:rPr lang="zh-TW" altLang="en-US" sz="1200" b="1" i="0" dirty="0">
-                <a:solidFill>
-                  <a:srgbClr val="F8F8F2"/>
-                </a:solidFill>
-                <a:effectLst/>
-                <a:latin typeface="system-ui"/>
-              </a:rPr>
-              <a:t>位元圖）＋ 到期時間」</a:t>
-            </a:r>
-            <a:r>
-              <a:rPr lang="zh-TW" altLang="en-US" sz="1200" b="0" i="0" dirty="0">
-                <a:solidFill>
-                  <a:srgbClr val="F8F8F2"/>
-                </a:solidFill>
-                <a:effectLst/>
-                <a:latin typeface="system-ui"/>
-              </a:rPr>
-              <a:t>。</a:t>
-            </a:r>
-          </a:p>
-          <a:p>
-            <a:endParaRPr lang="zh-TW" altLang="en-US" sz="1200" dirty="0"/>
-          </a:p>
-        </p:txBody>
-      </p:sp>
-      <p:sp>
-        <p:nvSpPr>
-          <p:cNvPr id="8" name="文字方塊 7">
-            <a:extLst>
-              <a:ext uri="{FF2B5EF4-FFF2-40B4-BE49-F238E27FC236}">
-                <a16:creationId xmlns:a16="http://schemas.microsoft.com/office/drawing/2014/main" id="{52406008-68AB-B00F-9108-1CDB0D1D7B5B}"/>
-              </a:ext>
-            </a:extLst>
-          </p:cNvPr>
-          <p:cNvSpPr txBox="1"/>
-          <p:nvPr/>
-        </p:nvSpPr>
-        <p:spPr>
-          <a:xfrm>
-            <a:off x="4389120" y="4791679"/>
-            <a:ext cx="3413455" cy="1938992"/>
-          </a:xfrm>
-          <a:prstGeom prst="rect">
-            <a:avLst/>
-          </a:prstGeom>
-          <a:noFill/>
-        </p:spPr>
-        <p:txBody>
-          <a:bodyPr wrap="square" rtlCol="0">
-            <a:spAutoFit/>
-          </a:bodyPr>
-          <a:lstStyle/>
-          <a:p>
-            <a:pPr marL="171450" indent="-171450" algn="l">
-              <a:buFont typeface="Arial" panose="020B0604020202020204" pitchFamily="34" charset="0"/>
-              <a:buChar char="•"/>
-            </a:pPr>
-            <a:r>
-              <a:rPr lang="en-US" altLang="zh-TW" sz="1200" b="0" i="0" dirty="0">
-                <a:solidFill>
-                  <a:srgbClr val="F8F8F2"/>
-                </a:solidFill>
-                <a:effectLst/>
-                <a:latin typeface="system-ui"/>
-              </a:rPr>
-              <a:t>Agent </a:t>
-            </a:r>
-            <a:r>
-              <a:rPr lang="zh-TW" altLang="en-US" sz="1200" b="0" i="0" dirty="0">
-                <a:solidFill>
-                  <a:srgbClr val="F8F8F2"/>
-                </a:solidFill>
-                <a:effectLst/>
-                <a:latin typeface="system-ui"/>
-              </a:rPr>
-              <a:t>每次發起 </a:t>
-            </a:r>
-            <a:r>
-              <a:rPr lang="en-US" altLang="zh-TW" sz="1200" b="0" i="0" dirty="0">
-                <a:solidFill>
-                  <a:srgbClr val="F8F8F2"/>
-                </a:solidFill>
-                <a:effectLst/>
-                <a:latin typeface="system-ui"/>
-              </a:rPr>
-              <a:t>API / Tool </a:t>
-            </a:r>
-            <a:r>
-              <a:rPr lang="zh-TW" altLang="en-US" sz="1200" b="0" i="0" dirty="0">
-                <a:solidFill>
-                  <a:srgbClr val="F8F8F2"/>
-                </a:solidFill>
-                <a:effectLst/>
-                <a:latin typeface="system-ui"/>
-              </a:rPr>
-              <a:t>呼叫時，物理上必須先通過此閘門。</a:t>
-            </a:r>
-          </a:p>
-          <a:p>
-            <a:pPr marL="171450" indent="-171450" algn="l">
-              <a:buFont typeface="Arial" panose="020B0604020202020204" pitchFamily="34" charset="0"/>
-              <a:buChar char="•"/>
-            </a:pPr>
-            <a:r>
-              <a:rPr lang="zh-TW" altLang="en-US" sz="1200" b="0" i="0" dirty="0">
-                <a:solidFill>
-                  <a:srgbClr val="F8F8F2"/>
-                </a:solidFill>
-                <a:effectLst/>
-                <a:latin typeface="system-ui"/>
-              </a:rPr>
-              <a:t>閘門在二進位層比對 </a:t>
-            </a:r>
-            <a:r>
-              <a:rPr lang="en-US" altLang="zh-TW" sz="1200" b="0" i="0" dirty="0">
-                <a:solidFill>
-                  <a:srgbClr val="F8F8F2"/>
-                </a:solidFill>
-                <a:effectLst/>
-                <a:latin typeface="system-ui"/>
-              </a:rPr>
-              <a:t>DIT Token </a:t>
-            </a:r>
-            <a:r>
-              <a:rPr lang="zh-TW" altLang="en-US" sz="1200" b="0" i="0" dirty="0">
-                <a:solidFill>
-                  <a:srgbClr val="F8F8F2"/>
-                </a:solidFill>
-                <a:effectLst/>
-                <a:latin typeface="system-ui"/>
-              </a:rPr>
-              <a:t>的 </a:t>
-            </a:r>
-            <a:r>
-              <a:rPr lang="en-US" altLang="zh-TW" sz="1200" b="0" i="0" dirty="0">
-                <a:solidFill>
-                  <a:srgbClr val="F8F8F2"/>
-                </a:solidFill>
-                <a:effectLst/>
-                <a:latin typeface="system-ui"/>
-              </a:rPr>
-              <a:t>Scope </a:t>
-            </a:r>
-            <a:r>
-              <a:rPr lang="zh-TW" altLang="en-US" sz="1200" b="0" i="0" dirty="0">
-                <a:solidFill>
-                  <a:srgbClr val="F8F8F2"/>
-                </a:solidFill>
-                <a:effectLst/>
-                <a:latin typeface="system-ui"/>
-              </a:rPr>
-              <a:t>與本次動作是否吻合：</a:t>
-            </a:r>
-          </a:p>
-          <a:p>
-            <a:pPr marL="171450" indent="-171450">
-              <a:buFont typeface="Arial" panose="020B0604020202020204" pitchFamily="34" charset="0"/>
-              <a:buChar char="•"/>
-            </a:pPr>
-            <a:endParaRPr lang="en-US" altLang="zh-TW" sz="1200" b="1" i="0" dirty="0">
-              <a:solidFill>
-                <a:srgbClr val="F8F8F2"/>
-              </a:solidFill>
-              <a:effectLst/>
-              <a:latin typeface="system-ui"/>
-            </a:endParaRPr>
-          </a:p>
-          <a:p>
-            <a:pPr marL="228600" indent="-228600">
-              <a:buFont typeface="+mj-lt"/>
-              <a:buAutoNum type="arabicPeriod"/>
-            </a:pPr>
-            <a:r>
-              <a:rPr lang="zh-TW" altLang="en-US" sz="1200" b="1" i="0" dirty="0">
-                <a:solidFill>
-                  <a:srgbClr val="F8F8F2"/>
-                </a:solidFill>
-                <a:effectLst/>
-                <a:latin typeface="system-ui"/>
-              </a:rPr>
-              <a:t>不吻合</a:t>
-            </a:r>
-            <a:r>
-              <a:rPr lang="zh-TW" altLang="en-US" sz="1200" b="0" i="0" dirty="0">
-                <a:solidFill>
-                  <a:srgbClr val="F8F8F2"/>
-                </a:solidFill>
-                <a:effectLst/>
-                <a:latin typeface="system-ui"/>
-              </a:rPr>
-              <a:t> ➔ </a:t>
-            </a:r>
-            <a:r>
-              <a:rPr lang="en-US" altLang="zh-TW" sz="1200" b="1" i="0" dirty="0">
-                <a:solidFill>
-                  <a:srgbClr val="F8F8F2"/>
-                </a:solidFill>
-                <a:effectLst/>
-                <a:latin typeface="system-ui"/>
-              </a:rPr>
-              <a:t>26.1 </a:t>
-            </a:r>
-            <a:r>
-              <a:rPr lang="en-US" altLang="zh-TW" sz="1200" b="1" i="0" dirty="0" err="1">
-                <a:solidFill>
-                  <a:srgbClr val="F8F8F2"/>
-                </a:solidFill>
-                <a:effectLst/>
-                <a:latin typeface="system-ui"/>
-              </a:rPr>
-              <a:t>μs</a:t>
-            </a:r>
-            <a:r>
-              <a:rPr lang="en-US" altLang="zh-TW" sz="1200" b="1" i="0" dirty="0">
-                <a:solidFill>
-                  <a:srgbClr val="F8F8F2"/>
-                </a:solidFill>
-                <a:effectLst/>
-                <a:latin typeface="system-ui"/>
-              </a:rPr>
-              <a:t> </a:t>
-            </a:r>
-            <a:r>
-              <a:rPr lang="zh-TW" altLang="en-US" sz="1200" b="1" i="0" dirty="0">
-                <a:solidFill>
-                  <a:srgbClr val="F8F8F2"/>
-                </a:solidFill>
-                <a:effectLst/>
-                <a:latin typeface="system-ui"/>
-              </a:rPr>
-              <a:t>內在 </a:t>
-            </a:r>
-            <a:r>
-              <a:rPr lang="en-US" altLang="zh-TW" sz="1200" b="1" i="0" dirty="0">
-                <a:solidFill>
-                  <a:srgbClr val="F8F8F2"/>
-                </a:solidFill>
-                <a:effectLst/>
-                <a:latin typeface="system-ui"/>
-              </a:rPr>
-              <a:t>C-ABI </a:t>
-            </a:r>
-            <a:r>
-              <a:rPr lang="zh-TW" altLang="en-US" sz="1200" b="1" i="0" dirty="0">
-                <a:solidFill>
-                  <a:srgbClr val="F8F8F2"/>
-                </a:solidFill>
-                <a:effectLst/>
-                <a:latin typeface="system-ui"/>
-              </a:rPr>
-              <a:t>層硬性熔斷</a:t>
-            </a:r>
-            <a:r>
-              <a:rPr lang="zh-TW" altLang="en-US" sz="1200" b="0" i="0" dirty="0">
-                <a:solidFill>
-                  <a:srgbClr val="F8F8F2"/>
-                </a:solidFill>
-                <a:effectLst/>
-                <a:latin typeface="system-ui"/>
-              </a:rPr>
-              <a:t>，拋出 </a:t>
-            </a:r>
-            <a:r>
-              <a:rPr lang="en-US" altLang="zh-TW" sz="1200" b="0" i="0" dirty="0">
-                <a:solidFill>
-                  <a:srgbClr val="F8F8F2"/>
-                </a:solidFill>
-                <a:effectLst/>
-                <a:latin typeface="system-ui"/>
-              </a:rPr>
-              <a:t>HTTP 403 FORBIDDEN</a:t>
-            </a:r>
-            <a:r>
-              <a:rPr lang="zh-TW" altLang="en-US" sz="1200" b="0" i="0" dirty="0">
-                <a:solidFill>
-                  <a:srgbClr val="F8F8F2"/>
-                </a:solidFill>
-                <a:effectLst/>
-                <a:latin typeface="system-ui"/>
-              </a:rPr>
-              <a:t>，</a:t>
-            </a:r>
-            <a:r>
-              <a:rPr lang="en-US" altLang="zh-TW" sz="1200" b="0" i="0" dirty="0">
-                <a:solidFill>
-                  <a:srgbClr val="F8F8F2"/>
-                </a:solidFill>
-                <a:effectLst/>
-                <a:latin typeface="system-ui"/>
-              </a:rPr>
-              <a:t>AI </a:t>
-            </a:r>
-            <a:r>
-              <a:rPr lang="zh-TW" altLang="en-US" sz="1200" b="0" i="0" dirty="0">
-                <a:solidFill>
-                  <a:srgbClr val="F8F8F2"/>
-                </a:solidFill>
-                <a:effectLst/>
-                <a:latin typeface="system-ui"/>
-              </a:rPr>
-              <a:t>完全無法繞過。</a:t>
-            </a:r>
-          </a:p>
-          <a:p>
-            <a:pPr marL="228600" indent="-228600">
-              <a:buFont typeface="+mj-lt"/>
-              <a:buAutoNum type="arabicPeriod"/>
-            </a:pPr>
-            <a:r>
-              <a:rPr lang="zh-TW" altLang="en-US" sz="1200" b="1" i="0" dirty="0">
-                <a:solidFill>
-                  <a:srgbClr val="F8F8F2"/>
-                </a:solidFill>
-                <a:effectLst/>
-                <a:latin typeface="system-ui"/>
-              </a:rPr>
-              <a:t>高風險動作</a:t>
-            </a:r>
-            <a:r>
-              <a:rPr lang="zh-TW" altLang="en-US" sz="1200" b="0" i="0" dirty="0">
-                <a:solidFill>
-                  <a:srgbClr val="F8F8F2"/>
-                </a:solidFill>
-                <a:effectLst/>
-                <a:latin typeface="system-ui"/>
-              </a:rPr>
-              <a:t> ➔ 自動掛起交易，觸發人類雙重簽署（</a:t>
-            </a:r>
-            <a:r>
-              <a:rPr lang="en-US" altLang="zh-TW" sz="1200" b="0" i="0" dirty="0">
-                <a:solidFill>
-                  <a:srgbClr val="F8F8F2"/>
-                </a:solidFill>
-                <a:effectLst/>
-                <a:latin typeface="system-ui"/>
-              </a:rPr>
-              <a:t>Human-in-the-Loop</a:t>
-            </a:r>
-            <a:r>
-              <a:rPr lang="zh-TW" altLang="en-US" sz="1200" b="0" i="0" dirty="0">
-                <a:solidFill>
-                  <a:srgbClr val="F8F8F2"/>
-                </a:solidFill>
-                <a:effectLst/>
-                <a:latin typeface="system-ui"/>
-              </a:rPr>
-              <a:t>）。</a:t>
-            </a:r>
-          </a:p>
-          <a:p>
-            <a:endParaRPr lang="zh-TW" altLang="en-US" sz="1200" dirty="0"/>
-          </a:p>
-        </p:txBody>
-      </p:sp>
-      <p:sp>
-        <p:nvSpPr>
-          <p:cNvPr id="9" name="文字方塊 8">
-            <a:extLst>
-              <a:ext uri="{FF2B5EF4-FFF2-40B4-BE49-F238E27FC236}">
-                <a16:creationId xmlns:a16="http://schemas.microsoft.com/office/drawing/2014/main" id="{46E35AFC-0093-7C14-9F22-719C22EE5DF8}"/>
-              </a:ext>
-            </a:extLst>
-          </p:cNvPr>
-          <p:cNvSpPr txBox="1"/>
-          <p:nvPr/>
-        </p:nvSpPr>
-        <p:spPr>
-          <a:xfrm>
-            <a:off x="8046720" y="4858321"/>
-            <a:ext cx="3413455" cy="1384995"/>
-          </a:xfrm>
-          <a:prstGeom prst="rect">
-            <a:avLst/>
-          </a:prstGeom>
-          <a:noFill/>
-        </p:spPr>
-        <p:txBody>
-          <a:bodyPr wrap="square" rtlCol="0">
-            <a:spAutoFit/>
-          </a:bodyPr>
-          <a:lstStyle/>
-          <a:p>
-            <a:pPr marL="171450" indent="-171450" algn="l">
-              <a:buFont typeface="Arial" panose="020B0604020202020204" pitchFamily="34" charset="0"/>
-              <a:buChar char="•"/>
-            </a:pPr>
-            <a:r>
-              <a:rPr lang="zh-TW" altLang="en-US" sz="1200" b="0" i="0" dirty="0">
-                <a:solidFill>
-                  <a:srgbClr val="F8F8F2"/>
-                </a:solidFill>
-                <a:effectLst/>
-                <a:latin typeface="system-ui"/>
-              </a:rPr>
-              <a:t>每次執行決策（放行 </a:t>
-            </a:r>
-            <a:r>
-              <a:rPr lang="en-US" altLang="zh-TW" sz="1200" b="0" i="0" dirty="0">
-                <a:solidFill>
-                  <a:srgbClr val="F8F8F2"/>
-                </a:solidFill>
-                <a:effectLst/>
-                <a:latin typeface="system-ui"/>
-              </a:rPr>
-              <a:t>/ </a:t>
-            </a:r>
-            <a:r>
-              <a:rPr lang="zh-TW" altLang="en-US" sz="1200" b="0" i="0" dirty="0">
-                <a:solidFill>
-                  <a:srgbClr val="F8F8F2"/>
-                </a:solidFill>
-                <a:effectLst/>
-                <a:latin typeface="system-ui"/>
-              </a:rPr>
-              <a:t>熔斷 </a:t>
-            </a:r>
-            <a:r>
-              <a:rPr lang="en-US" altLang="zh-TW" sz="1200" b="0" i="0" dirty="0">
-                <a:solidFill>
-                  <a:srgbClr val="F8F8F2"/>
-                </a:solidFill>
-                <a:effectLst/>
-                <a:latin typeface="system-ui"/>
-              </a:rPr>
-              <a:t>/ </a:t>
-            </a:r>
-            <a:r>
-              <a:rPr lang="zh-TW" altLang="en-US" sz="1200" b="0" i="0" dirty="0">
-                <a:solidFill>
-                  <a:srgbClr val="F8F8F2"/>
-                </a:solidFill>
-                <a:effectLst/>
-                <a:latin typeface="system-ui"/>
-              </a:rPr>
-              <a:t>掛起）都即時寫入帶有 </a:t>
-            </a:r>
-            <a:r>
-              <a:rPr lang="en-US" altLang="zh-TW" sz="1200" b="1" i="0" dirty="0">
-                <a:solidFill>
-                  <a:srgbClr val="F8F8F2"/>
-                </a:solidFill>
-                <a:effectLst/>
-                <a:latin typeface="system-ui"/>
-              </a:rPr>
-              <a:t>SHA-256 </a:t>
-            </a:r>
-            <a:r>
-              <a:rPr lang="zh-TW" altLang="en-US" sz="1200" b="1" i="0" dirty="0">
-                <a:solidFill>
-                  <a:srgbClr val="F8F8F2"/>
-                </a:solidFill>
-                <a:effectLst/>
-                <a:latin typeface="system-ui"/>
-              </a:rPr>
-              <a:t>雜湊的 </a:t>
-            </a:r>
-            <a:r>
-              <a:rPr lang="en-US" altLang="zh-TW" sz="1200" b="1" i="0" dirty="0">
-                <a:solidFill>
-                  <a:srgbClr val="F8F8F2"/>
-                </a:solidFill>
-                <a:effectLst/>
-                <a:latin typeface="system-ui"/>
-              </a:rPr>
-              <a:t>Merkle </a:t>
-            </a:r>
-            <a:r>
-              <a:rPr lang="zh-TW" altLang="en-US" sz="1200" b="1" i="0" dirty="0">
-                <a:solidFill>
-                  <a:srgbClr val="F8F8F2"/>
-                </a:solidFill>
-                <a:effectLst/>
-                <a:latin typeface="system-ui"/>
-              </a:rPr>
-              <a:t>稽核鏈</a:t>
-            </a:r>
-            <a:r>
-              <a:rPr lang="zh-TW" altLang="en-US" sz="1200" b="0" i="0" dirty="0">
-                <a:solidFill>
-                  <a:srgbClr val="F8F8F2"/>
-                </a:solidFill>
-                <a:effectLst/>
-                <a:latin typeface="system-ui"/>
-              </a:rPr>
-              <a:t>。</a:t>
-            </a:r>
-          </a:p>
-          <a:p>
-            <a:pPr marL="171450" indent="-171450" algn="l">
-              <a:buFont typeface="Arial" panose="020B0604020202020204" pitchFamily="34" charset="0"/>
-              <a:buChar char="•"/>
-            </a:pPr>
-            <a:endParaRPr lang="en-US" altLang="zh-TW" sz="1200" b="0" i="0" dirty="0">
-              <a:solidFill>
-                <a:srgbClr val="F8F8F2"/>
-              </a:solidFill>
-              <a:effectLst/>
-              <a:latin typeface="system-ui"/>
-            </a:endParaRPr>
-          </a:p>
-          <a:p>
-            <a:pPr marL="171450" indent="-171450" algn="l">
-              <a:buFont typeface="Arial" panose="020B0604020202020204" pitchFamily="34" charset="0"/>
-              <a:buChar char="•"/>
-            </a:pPr>
-            <a:r>
-              <a:rPr lang="zh-TW" altLang="en-US" sz="1200" b="0" i="0" dirty="0">
-                <a:solidFill>
-                  <a:srgbClr val="F8F8F2"/>
-                </a:solidFill>
-                <a:effectLst/>
-                <a:latin typeface="system-ui"/>
-              </a:rPr>
-              <a:t>前後雜湊嚴密鏈結，任何單一節點被竄改都會使整條鏈失效，產出具備法庭採信力的密碼學存證收據。</a:t>
-            </a:r>
-          </a:p>
-          <a:p>
-            <a:endParaRPr lang="zh-TW" altLang="en-US" sz="1200" dirty="0"/>
           </a:p>
         </p:txBody>
       </p:sp>
@@ -10202,6 +9043,921 @@
             </a:pPr>
             <a:r>
               <a:rPr dirty="0"/>
+              <a:t>● CROSS-INDUSTRY MAPPING</a:t>
+            </a:r>
+          </a:p>
+          <a:p>
+            <a:pPr>
+              <a:defRPr sz="2400" b="1">
+                <a:solidFill>
+                  <a:srgbClr val="F8FAFC"/>
+                </a:solidFill>
+              </a:defRPr>
+            </a:pPr>
+            <a:r>
+              <a:rPr lang="zh-TW" altLang="en-US" dirty="0"/>
+              <a:t>一底兜百業</a:t>
+            </a:r>
+            <a:r>
+              <a:rPr dirty="0"/>
+              <a:t>：</a:t>
+            </a:r>
+            <a:r>
+              <a:rPr lang="zh-TW" altLang="en-US" dirty="0"/>
+              <a:t>六大產業痛點的</a:t>
+            </a:r>
+            <a:r>
+              <a:rPr dirty="0"/>
+              <a:t> Ingress / Egress </a:t>
+            </a:r>
+            <a:r>
+              <a:rPr lang="zh-TW" altLang="en-US" dirty="0"/>
+              <a:t>統一對照機制</a:t>
+            </a:r>
+            <a:endParaRPr dirty="0"/>
+          </a:p>
+        </p:txBody>
+      </p:sp>
+      <p:sp>
+        <p:nvSpPr>
+          <p:cNvPr id="4" name="Rounded Rectangle 3"/>
+          <p:cNvSpPr/>
+          <p:nvPr/>
+        </p:nvSpPr>
+        <p:spPr>
+          <a:xfrm>
+            <a:off x="731520" y="1280160"/>
+            <a:ext cx="5212080" cy="1554480"/>
+          </a:xfrm>
+          <a:prstGeom prst="roundRect">
+            <a:avLst/>
+          </a:prstGeom>
+          <a:solidFill>
+            <a:srgbClr val="0F172A"/>
+          </a:solidFill>
+          <a:ln w="19050">
+            <a:solidFill>
+              <a:srgbClr val="38BDF8"/>
+            </a:solidFill>
+          </a:ln>
+        </p:spPr>
+        <p:style>
+          <a:lnRef idx="1">
+            <a:schemeClr val="accent1"/>
+          </a:lnRef>
+          <a:fillRef idx="3">
+            <a:schemeClr val="accent1"/>
+          </a:fillRef>
+          <a:effectRef idx="2">
+            <a:schemeClr val="accent1"/>
+          </a:effectRef>
+          <a:fontRef idx="minor">
+            <a:schemeClr val="lt1"/>
+          </a:fontRef>
+        </p:style>
+        <p:txBody>
+          <a:bodyPr wrap="square" lIns="274320" tIns="228600" rIns="274320" bIns="182880" rtlCol="0" anchor="ctr"/>
+          <a:lstStyle/>
+          <a:p>
+            <a:pPr algn="ctr">
+              <a:defRPr sz="1300" b="1">
+                <a:solidFill>
+                  <a:srgbClr val="38BDF8"/>
+                </a:solidFill>
+              </a:defRPr>
+            </a:pPr>
+            <a:r>
+              <a:rPr sz="1400" dirty="0"/>
+              <a:t>🏭 Track 01 </a:t>
+            </a:r>
+            <a:r>
+              <a:rPr sz="1400" dirty="0" err="1"/>
+              <a:t>製造碳護照</a:t>
+            </a:r>
+            <a:endParaRPr sz="1400" dirty="0"/>
+          </a:p>
+          <a:p>
+            <a:pPr>
+              <a:defRPr sz="1100">
+                <a:solidFill>
+                  <a:srgbClr val="F8FAFC"/>
+                </a:solidFill>
+              </a:defRPr>
+            </a:pPr>
+            <a:r>
+              <a:rPr sz="1400" dirty="0"/>
+              <a:t>📥 Ingress: </a:t>
+            </a:r>
+            <a:r>
+              <a:rPr sz="1400" dirty="0" err="1"/>
+              <a:t>動態</a:t>
+            </a:r>
+            <a:r>
+              <a:rPr sz="1400" dirty="0"/>
+              <a:t> </a:t>
+            </a:r>
+            <a:r>
+              <a:rPr sz="1400" dirty="0" err="1"/>
+              <a:t>Redact：隔離</a:t>
+            </a:r>
+            <a:r>
+              <a:rPr sz="1400" dirty="0"/>
+              <a:t> BOM </a:t>
+            </a:r>
+            <a:r>
+              <a:rPr sz="1400" dirty="0" err="1"/>
+              <a:t>原料成本</a:t>
+            </a:r>
+            <a:r>
+              <a:rPr sz="1400" dirty="0"/>
+              <a:t>/</a:t>
+            </a:r>
+            <a:r>
+              <a:rPr sz="1400" dirty="0" err="1"/>
+              <a:t>良率，僅輸入碳排係數</a:t>
+            </a:r>
+            <a:r>
+              <a:rPr sz="1400" dirty="0"/>
+              <a:t>。</a:t>
+            </a:r>
+          </a:p>
+          <a:p>
+            <a:pPr>
+              <a:defRPr sz="1100">
+                <a:solidFill>
+                  <a:srgbClr val="CBD5E1"/>
+                </a:solidFill>
+              </a:defRPr>
+            </a:pPr>
+            <a:r>
+              <a:rPr sz="1400" dirty="0"/>
+              <a:t>📤 Egress: CBAM </a:t>
+            </a:r>
+            <a:r>
+              <a:rPr sz="1400" dirty="0" err="1"/>
+              <a:t>門閥：輸出機密瞬間熔斷，僅放行</a:t>
+            </a:r>
+            <a:r>
+              <a:rPr sz="1400" dirty="0"/>
+              <a:t> ZKP </a:t>
+            </a:r>
+            <a:r>
+              <a:rPr sz="1400" dirty="0" err="1"/>
+              <a:t>碳排憑證</a:t>
+            </a:r>
+            <a:r>
+              <a:rPr sz="1400" dirty="0"/>
+              <a:t>。</a:t>
+            </a:r>
+          </a:p>
+        </p:txBody>
+      </p:sp>
+      <p:sp>
+        <p:nvSpPr>
+          <p:cNvPr id="5" name="Rounded Rectangle 4"/>
+          <p:cNvSpPr/>
+          <p:nvPr/>
+        </p:nvSpPr>
+        <p:spPr>
+          <a:xfrm>
+            <a:off x="6248095" y="1280160"/>
+            <a:ext cx="5212080" cy="1554480"/>
+          </a:xfrm>
+          <a:prstGeom prst="roundRect">
+            <a:avLst/>
+          </a:prstGeom>
+          <a:solidFill>
+            <a:srgbClr val="0F172A"/>
+          </a:solidFill>
+          <a:ln w="19050">
+            <a:solidFill>
+              <a:srgbClr val="4ADE80"/>
+            </a:solidFill>
+          </a:ln>
+        </p:spPr>
+        <p:style>
+          <a:lnRef idx="1">
+            <a:schemeClr val="accent1"/>
+          </a:lnRef>
+          <a:fillRef idx="3">
+            <a:schemeClr val="accent1"/>
+          </a:fillRef>
+          <a:effectRef idx="2">
+            <a:schemeClr val="accent1"/>
+          </a:effectRef>
+          <a:fontRef idx="minor">
+            <a:schemeClr val="lt1"/>
+          </a:fontRef>
+        </p:style>
+        <p:txBody>
+          <a:bodyPr wrap="square" lIns="274320" tIns="228600" rIns="274320" bIns="182880" rtlCol="0" anchor="ctr"/>
+          <a:lstStyle/>
+          <a:p>
+            <a:pPr algn="ctr">
+              <a:defRPr sz="1300" b="1">
+                <a:solidFill>
+                  <a:srgbClr val="4ADE80"/>
+                </a:solidFill>
+              </a:defRPr>
+            </a:pPr>
+            <a:r>
+              <a:rPr sz="1400" dirty="0"/>
+              <a:t>🏭 Track 02 </a:t>
+            </a:r>
+            <a:r>
+              <a:rPr sz="1400" dirty="0" err="1"/>
+              <a:t>電支</a:t>
+            </a:r>
+            <a:r>
+              <a:rPr sz="1400" dirty="0"/>
+              <a:t> AML </a:t>
+            </a:r>
+            <a:r>
+              <a:rPr sz="1400" dirty="0" err="1"/>
+              <a:t>風控</a:t>
+            </a:r>
+            <a:endParaRPr sz="1400" dirty="0"/>
+          </a:p>
+          <a:p>
+            <a:pPr>
+              <a:defRPr sz="1100">
+                <a:solidFill>
+                  <a:srgbClr val="F8FAFC"/>
+                </a:solidFill>
+              </a:defRPr>
+            </a:pPr>
+            <a:r>
+              <a:rPr sz="1400" dirty="0"/>
+              <a:t>📥 Ingress: </a:t>
+            </a:r>
+            <a:r>
+              <a:rPr sz="1400" dirty="0" err="1"/>
+              <a:t>去識別化密態特徵：遮蔽姓名</a:t>
+            </a:r>
+            <a:r>
+              <a:rPr sz="1400" dirty="0"/>
+              <a:t>/</a:t>
+            </a:r>
+            <a:r>
+              <a:rPr sz="1400" dirty="0" err="1"/>
+              <a:t>身分證</a:t>
+            </a:r>
+            <a:r>
+              <a:rPr sz="1400" dirty="0"/>
+              <a:t>/</a:t>
+            </a:r>
+            <a:r>
+              <a:rPr sz="1400" dirty="0" err="1"/>
+              <a:t>帳戶明細，提供圖向量</a:t>
+            </a:r>
+            <a:r>
+              <a:rPr sz="1400" dirty="0"/>
+              <a:t>。</a:t>
+            </a:r>
+          </a:p>
+          <a:p>
+            <a:pPr>
+              <a:defRPr sz="1100">
+                <a:solidFill>
+                  <a:srgbClr val="CBD5E1"/>
+                </a:solidFill>
+              </a:defRPr>
+            </a:pPr>
+            <a:r>
+              <a:rPr sz="1400" dirty="0"/>
+              <a:t>📤 Egress: </a:t>
+            </a:r>
+            <a:r>
+              <a:rPr sz="1400" dirty="0" err="1"/>
+              <a:t>微秒支付阻斷：洗錢特徵瞬間</a:t>
+            </a:r>
+            <a:r>
+              <a:rPr sz="1400" dirty="0"/>
+              <a:t> C-ABI </a:t>
+            </a:r>
+            <a:r>
+              <a:rPr sz="1400" dirty="0" err="1"/>
+              <a:t>懸停，觸發雙簽</a:t>
+            </a:r>
+            <a:r>
+              <a:rPr sz="1400" dirty="0"/>
+              <a:t>。</a:t>
+            </a:r>
+          </a:p>
+        </p:txBody>
+      </p:sp>
+      <p:sp>
+        <p:nvSpPr>
+          <p:cNvPr id="6" name="Rounded Rectangle 5"/>
+          <p:cNvSpPr/>
+          <p:nvPr/>
+        </p:nvSpPr>
+        <p:spPr>
+          <a:xfrm>
+            <a:off x="731520" y="2971800"/>
+            <a:ext cx="5212080" cy="1554480"/>
+          </a:xfrm>
+          <a:prstGeom prst="roundRect">
+            <a:avLst/>
+          </a:prstGeom>
+          <a:solidFill>
+            <a:srgbClr val="0F172A"/>
+          </a:solidFill>
+          <a:ln w="19050">
+            <a:solidFill>
+              <a:srgbClr val="F87171"/>
+            </a:solidFill>
+          </a:ln>
+        </p:spPr>
+        <p:style>
+          <a:lnRef idx="1">
+            <a:schemeClr val="accent1"/>
+          </a:lnRef>
+          <a:fillRef idx="3">
+            <a:schemeClr val="accent1"/>
+          </a:fillRef>
+          <a:effectRef idx="2">
+            <a:schemeClr val="accent1"/>
+          </a:effectRef>
+          <a:fontRef idx="minor">
+            <a:schemeClr val="lt1"/>
+          </a:fontRef>
+        </p:style>
+        <p:txBody>
+          <a:bodyPr wrap="square" lIns="274320" tIns="228600" rIns="274320" bIns="182880" rtlCol="0" anchor="ctr"/>
+          <a:lstStyle/>
+          <a:p>
+            <a:pPr algn="ctr">
+              <a:defRPr sz="1300" b="1">
+                <a:solidFill>
+                  <a:srgbClr val="F87171"/>
+                </a:solidFill>
+              </a:defRPr>
+            </a:pPr>
+            <a:r>
+              <a:rPr sz="1400" dirty="0"/>
+              <a:t>🏭 Track 03 </a:t>
+            </a:r>
+            <a:r>
+              <a:rPr sz="1400" dirty="0" err="1"/>
+              <a:t>醫療保險理賠</a:t>
+            </a:r>
+            <a:endParaRPr sz="1400" dirty="0"/>
+          </a:p>
+          <a:p>
+            <a:pPr>
+              <a:defRPr sz="1100">
+                <a:solidFill>
+                  <a:srgbClr val="F8FAFC"/>
+                </a:solidFill>
+              </a:defRPr>
+            </a:pPr>
+            <a:r>
+              <a:rPr sz="1400" dirty="0"/>
+              <a:t>📥 Ingress: 18項 PHI </a:t>
+            </a:r>
+            <a:r>
+              <a:rPr sz="1400" dirty="0" err="1"/>
+              <a:t>自動遮蔽：病歷與基因嚴密隔離，輸入診斷碼</a:t>
+            </a:r>
+            <a:r>
+              <a:rPr sz="1400" dirty="0"/>
+              <a:t>/</a:t>
+            </a:r>
+            <a:r>
+              <a:rPr sz="1400" dirty="0" err="1"/>
+              <a:t>金額</a:t>
+            </a:r>
+            <a:r>
+              <a:rPr sz="1400" dirty="0"/>
+              <a:t>。</a:t>
+            </a:r>
+          </a:p>
+          <a:p>
+            <a:pPr>
+              <a:defRPr sz="1100">
+                <a:solidFill>
+                  <a:srgbClr val="CBD5E1"/>
+                </a:solidFill>
+              </a:defRPr>
+            </a:pPr>
+            <a:r>
+              <a:rPr sz="1400" dirty="0"/>
+              <a:t>📤 Egress: </a:t>
+            </a:r>
+            <a:r>
+              <a:rPr sz="1400" dirty="0" err="1"/>
+              <a:t>保險聯盟鏈對接：越權調閱</a:t>
+            </a:r>
+            <a:r>
+              <a:rPr sz="1400" dirty="0"/>
+              <a:t> 26.1μs </a:t>
+            </a:r>
+            <a:r>
+              <a:rPr sz="1400" dirty="0" err="1"/>
+              <a:t>硬熔斷，放行出具</a:t>
+            </a:r>
+            <a:r>
+              <a:rPr sz="1400" dirty="0"/>
+              <a:t> Merkle。</a:t>
+            </a:r>
+          </a:p>
+        </p:txBody>
+      </p:sp>
+      <p:sp>
+        <p:nvSpPr>
+          <p:cNvPr id="7" name="Rounded Rectangle 6"/>
+          <p:cNvSpPr/>
+          <p:nvPr/>
+        </p:nvSpPr>
+        <p:spPr>
+          <a:xfrm>
+            <a:off x="6248095" y="2971800"/>
+            <a:ext cx="5212080" cy="1554480"/>
+          </a:xfrm>
+          <a:prstGeom prst="roundRect">
+            <a:avLst/>
+          </a:prstGeom>
+          <a:solidFill>
+            <a:srgbClr val="0F172A"/>
+          </a:solidFill>
+          <a:ln w="19050">
+            <a:solidFill>
+              <a:srgbClr val="FBBF24"/>
+            </a:solidFill>
+          </a:ln>
+        </p:spPr>
+        <p:style>
+          <a:lnRef idx="1">
+            <a:schemeClr val="accent1"/>
+          </a:lnRef>
+          <a:fillRef idx="3">
+            <a:schemeClr val="accent1"/>
+          </a:fillRef>
+          <a:effectRef idx="2">
+            <a:schemeClr val="accent1"/>
+          </a:effectRef>
+          <a:fontRef idx="minor">
+            <a:schemeClr val="lt1"/>
+          </a:fontRef>
+        </p:style>
+        <p:txBody>
+          <a:bodyPr wrap="square" lIns="274320" tIns="228600" rIns="274320" bIns="182880" rtlCol="0" anchor="ctr"/>
+          <a:lstStyle/>
+          <a:p>
+            <a:pPr algn="ctr">
+              <a:defRPr sz="1300" b="1">
+                <a:solidFill>
+                  <a:srgbClr val="FBBF24"/>
+                </a:solidFill>
+              </a:defRPr>
+            </a:pPr>
+            <a:r>
+              <a:rPr sz="1400" dirty="0"/>
+              <a:t>🏭 Track 04 </a:t>
+            </a:r>
+            <a:r>
+              <a:rPr sz="1400" dirty="0" err="1"/>
+              <a:t>政府跨機關代辦</a:t>
+            </a:r>
+            <a:endParaRPr sz="1400" dirty="0"/>
+          </a:p>
+          <a:p>
+            <a:pPr>
+              <a:defRPr sz="1100">
+                <a:solidFill>
+                  <a:srgbClr val="F8FAFC"/>
+                </a:solidFill>
+              </a:defRPr>
+            </a:pPr>
+            <a:r>
+              <a:rPr sz="1400" dirty="0"/>
+              <a:t>📥 Ingress: </a:t>
+            </a:r>
+            <a:r>
+              <a:rPr sz="1400" dirty="0" err="1"/>
+              <a:t>三層代理過濾：事務所</a:t>
+            </a:r>
+            <a:r>
+              <a:rPr sz="1400" dirty="0"/>
+              <a:t> </a:t>
+            </a:r>
+            <a:r>
+              <a:rPr sz="1400" dirty="0" err="1"/>
+              <a:t>vLEI</a:t>
+            </a:r>
+            <a:r>
+              <a:rPr sz="1400" dirty="0"/>
+              <a:t> </a:t>
+            </a:r>
+            <a:r>
+              <a:rPr sz="1400" dirty="0" err="1"/>
+              <a:t>僅取所得級距，隔離完整稅籍</a:t>
+            </a:r>
+            <a:r>
+              <a:rPr sz="1400" dirty="0"/>
+              <a:t>。</a:t>
+            </a:r>
+          </a:p>
+          <a:p>
+            <a:pPr>
+              <a:defRPr sz="1100">
+                <a:solidFill>
+                  <a:srgbClr val="CBD5E1"/>
+                </a:solidFill>
+              </a:defRPr>
+            </a:pPr>
+            <a:r>
+              <a:rPr sz="1400" dirty="0"/>
+              <a:t>📤 Egress: </a:t>
+            </a:r>
+            <a:r>
+              <a:rPr sz="1400" dirty="0" err="1"/>
+              <a:t>代送件越權阻斷：越權調閱戶政瞬間攔截，出具</a:t>
+            </a:r>
+            <a:r>
+              <a:rPr sz="1400" dirty="0"/>
+              <a:t> W3C VC </a:t>
+            </a:r>
+            <a:r>
+              <a:rPr sz="1400" dirty="0" err="1"/>
+              <a:t>收據</a:t>
+            </a:r>
+            <a:r>
+              <a:rPr sz="1400" dirty="0"/>
+              <a:t>。</a:t>
+            </a:r>
+          </a:p>
+        </p:txBody>
+      </p:sp>
+      <p:sp>
+        <p:nvSpPr>
+          <p:cNvPr id="8" name="Rounded Rectangle 7"/>
+          <p:cNvSpPr/>
+          <p:nvPr/>
+        </p:nvSpPr>
+        <p:spPr>
+          <a:xfrm>
+            <a:off x="731520" y="4663440"/>
+            <a:ext cx="5212080" cy="1554480"/>
+          </a:xfrm>
+          <a:prstGeom prst="roundRect">
+            <a:avLst/>
+          </a:prstGeom>
+          <a:solidFill>
+            <a:srgbClr val="0F172A"/>
+          </a:solidFill>
+          <a:ln w="19050">
+            <a:solidFill>
+              <a:srgbClr val="C084FC"/>
+            </a:solidFill>
+          </a:ln>
+        </p:spPr>
+        <p:style>
+          <a:lnRef idx="1">
+            <a:schemeClr val="accent1"/>
+          </a:lnRef>
+          <a:fillRef idx="3">
+            <a:schemeClr val="accent1"/>
+          </a:fillRef>
+          <a:effectRef idx="2">
+            <a:schemeClr val="accent1"/>
+          </a:effectRef>
+          <a:fontRef idx="minor">
+            <a:schemeClr val="lt1"/>
+          </a:fontRef>
+        </p:style>
+        <p:txBody>
+          <a:bodyPr wrap="square" lIns="274320" tIns="228600" rIns="274320" bIns="182880" rtlCol="0" anchor="ctr"/>
+          <a:lstStyle/>
+          <a:p>
+            <a:pPr algn="ctr">
+              <a:defRPr sz="1300" b="1">
+                <a:solidFill>
+                  <a:srgbClr val="C084FC"/>
+                </a:solidFill>
+              </a:defRPr>
+            </a:pPr>
+            <a:r>
+              <a:rPr sz="1400" dirty="0"/>
+              <a:t>🏭 Track 05 </a:t>
+            </a:r>
+            <a:r>
+              <a:rPr sz="1400" dirty="0" err="1"/>
+              <a:t>移工普惠金融</a:t>
+            </a:r>
+            <a:endParaRPr sz="1400" dirty="0"/>
+          </a:p>
+          <a:p>
+            <a:pPr>
+              <a:defRPr sz="1100">
+                <a:solidFill>
+                  <a:srgbClr val="F8FAFC"/>
+                </a:solidFill>
+              </a:defRPr>
+            </a:pPr>
+            <a:r>
+              <a:rPr sz="1400" dirty="0"/>
+              <a:t>📥 Ingress: 1:1:1 </a:t>
+            </a:r>
+            <a:r>
+              <a:rPr sz="1400" dirty="0" err="1"/>
+              <a:t>複合身分綁定：護照+居留證+門號為</a:t>
+            </a:r>
+            <a:r>
+              <a:rPr sz="1400" dirty="0"/>
+              <a:t> </a:t>
+            </a:r>
+            <a:r>
+              <a:rPr sz="1400" dirty="0" err="1"/>
+              <a:t>DIT，隱匿密碼</a:t>
+            </a:r>
+            <a:r>
+              <a:rPr sz="1400" dirty="0"/>
+              <a:t>。</a:t>
+            </a:r>
+          </a:p>
+          <a:p>
+            <a:pPr>
+              <a:defRPr sz="1100">
+                <a:solidFill>
+                  <a:srgbClr val="CBD5E1"/>
+                </a:solidFill>
+              </a:defRPr>
+            </a:pPr>
+            <a:r>
+              <a:rPr sz="1400" dirty="0"/>
+              <a:t>📤 Egress: SIM Swap </a:t>
+            </a:r>
+            <a:r>
+              <a:rPr sz="1400" dirty="0" err="1"/>
+              <a:t>連鎖凍結：換卡</a:t>
+            </a:r>
+            <a:r>
+              <a:rPr sz="1400" dirty="0"/>
+              <a:t>/</a:t>
+            </a:r>
+            <a:r>
+              <a:rPr sz="1400" dirty="0" err="1"/>
+              <a:t>異常轉帳</a:t>
+            </a:r>
+            <a:r>
+              <a:rPr sz="1400" dirty="0"/>
+              <a:t> O(1) </a:t>
+            </a:r>
+            <a:r>
+              <a:rPr sz="1400" dirty="0" err="1"/>
+              <a:t>原子指針秒凍結</a:t>
+            </a:r>
+            <a:r>
+              <a:rPr sz="1400" dirty="0"/>
+              <a:t>。</a:t>
+            </a:r>
+          </a:p>
+        </p:txBody>
+      </p:sp>
+      <p:sp>
+        <p:nvSpPr>
+          <p:cNvPr id="9" name="Rounded Rectangle 8"/>
+          <p:cNvSpPr/>
+          <p:nvPr/>
+        </p:nvSpPr>
+        <p:spPr>
+          <a:xfrm>
+            <a:off x="6248095" y="4663440"/>
+            <a:ext cx="5212080" cy="1554480"/>
+          </a:xfrm>
+          <a:prstGeom prst="roundRect">
+            <a:avLst/>
+          </a:prstGeom>
+          <a:solidFill>
+            <a:srgbClr val="0F172A"/>
+          </a:solidFill>
+          <a:ln w="19050">
+            <a:solidFill>
+              <a:srgbClr val="38BDF8"/>
+            </a:solidFill>
+          </a:ln>
+        </p:spPr>
+        <p:style>
+          <a:lnRef idx="1">
+            <a:schemeClr val="accent1"/>
+          </a:lnRef>
+          <a:fillRef idx="3">
+            <a:schemeClr val="accent1"/>
+          </a:fillRef>
+          <a:effectRef idx="2">
+            <a:schemeClr val="accent1"/>
+          </a:effectRef>
+          <a:fontRef idx="minor">
+            <a:schemeClr val="lt1"/>
+          </a:fontRef>
+        </p:style>
+        <p:txBody>
+          <a:bodyPr wrap="square" lIns="274320" tIns="228600" rIns="274320" bIns="182880" rtlCol="0" anchor="ctr"/>
+          <a:lstStyle/>
+          <a:p>
+            <a:pPr algn="ctr">
+              <a:defRPr sz="1300" b="1">
+                <a:solidFill>
+                  <a:srgbClr val="38BDF8"/>
+                </a:solidFill>
+              </a:defRPr>
+            </a:pPr>
+            <a:r>
+              <a:rPr sz="1400" dirty="0"/>
+              <a:t>🏭 Track 06 </a:t>
+            </a:r>
+            <a:r>
+              <a:rPr sz="1400" dirty="0" err="1"/>
+              <a:t>供應鏈</a:t>
+            </a:r>
+            <a:r>
+              <a:rPr sz="1400" dirty="0"/>
+              <a:t> RBA </a:t>
+            </a:r>
+            <a:r>
+              <a:rPr sz="1400" dirty="0" err="1"/>
+              <a:t>稽核</a:t>
+            </a:r>
+            <a:endParaRPr sz="1400" dirty="0"/>
+          </a:p>
+          <a:p>
+            <a:pPr>
+              <a:defRPr sz="1100">
+                <a:solidFill>
+                  <a:srgbClr val="F8FAFC"/>
+                </a:solidFill>
+              </a:defRPr>
+            </a:pPr>
+            <a:r>
+              <a:rPr sz="1400" dirty="0"/>
+              <a:t>📥 Ingress: </a:t>
+            </a:r>
+            <a:r>
+              <a:rPr sz="1400" dirty="0" err="1"/>
+              <a:t>選擇性揭露</a:t>
+            </a:r>
+            <a:r>
+              <a:rPr sz="1400" dirty="0"/>
+              <a:t> </a:t>
+            </a:r>
+            <a:r>
+              <a:rPr sz="1400" dirty="0" err="1"/>
+              <a:t>ZKP-Lite：採購</a:t>
+            </a:r>
+            <a:r>
+              <a:rPr sz="1400" dirty="0"/>
+              <a:t> AI </a:t>
+            </a:r>
+            <a:r>
+              <a:rPr sz="1400" dirty="0" err="1"/>
+              <a:t>僅讀合規</a:t>
+            </a:r>
+            <a:r>
+              <a:rPr sz="1400" dirty="0"/>
+              <a:t> </a:t>
+            </a:r>
+            <a:r>
+              <a:rPr sz="1400" dirty="0" err="1"/>
+              <a:t>TRUE，無法讀薪資</a:t>
+            </a:r>
+            <a:r>
+              <a:rPr sz="1400" dirty="0"/>
+              <a:t>。</a:t>
+            </a:r>
+          </a:p>
+          <a:p>
+            <a:pPr>
+              <a:defRPr sz="1100">
+                <a:solidFill>
+                  <a:srgbClr val="CBD5E1"/>
+                </a:solidFill>
+              </a:defRPr>
+            </a:pPr>
+            <a:r>
+              <a:rPr sz="1400" dirty="0"/>
+              <a:t>📤 Egress: </a:t>
+            </a:r>
+            <a:r>
+              <a:rPr sz="1400" dirty="0" err="1"/>
+              <a:t>雇主付費存證：物理鎖定採購</a:t>
+            </a:r>
+            <a:r>
+              <a:rPr sz="1400" dirty="0"/>
+              <a:t> </a:t>
+            </a:r>
+            <a:r>
+              <a:rPr sz="1400" dirty="0" err="1"/>
+              <a:t>Tool，越權即熔斷產出收據</a:t>
+            </a:r>
+            <a:r>
+              <a:rPr sz="1400" dirty="0"/>
+              <a:t>。</a:t>
+            </a:r>
+          </a:p>
+        </p:txBody>
+      </p:sp>
+    </p:spTree>
+  </p:cSld>
+  <p:clrMapOvr>
+    <a:masterClrMapping/>
+  </p:clrMapOvr>
+</p:sld>
+</file>
+
+<file path=ppt/slides/slide8.xml><?xml version="1.0" encoding="utf-8"?>
+<p:sld xmlns:a="http://schemas.openxmlformats.org/drawingml/2006/main" xmlns:r="http://schemas.openxmlformats.org/officeDocument/2006/relationships" xmlns:p="http://schemas.openxmlformats.org/presentationml/2006/main">
+  <p:cSld>
+    <p:spTree>
+      <p:nvGrpSpPr>
+        <p:cNvPr id="1" name=""/>
+        <p:cNvGrpSpPr/>
+        <p:nvPr/>
+      </p:nvGrpSpPr>
+      <p:grpSpPr>
+        <a:xfrm>
+          <a:off x="0" y="0"/>
+          <a:ext cx="0" cy="0"/>
+          <a:chOff x="0" y="0"/>
+          <a:chExt cx="0" cy="0"/>
+        </a:xfrm>
+      </p:grpSpPr>
+      <p:sp>
+        <p:nvSpPr>
+          <p:cNvPr id="2" name="Rectangle 1"/>
+          <p:cNvSpPr/>
+          <p:nvPr/>
+        </p:nvSpPr>
+        <p:spPr>
+          <a:xfrm>
+            <a:off x="0" y="0"/>
+            <a:ext cx="12191695" cy="6858000"/>
+          </a:xfrm>
+          <a:prstGeom prst="rect">
+            <a:avLst/>
+          </a:prstGeom>
+          <a:solidFill>
+            <a:srgbClr val="070A12"/>
+          </a:solidFill>
+          <a:ln>
+            <a:noFill/>
+          </a:ln>
+        </p:spPr>
+        <p:style>
+          <a:lnRef idx="1">
+            <a:schemeClr val="accent1"/>
+          </a:lnRef>
+          <a:fillRef idx="3">
+            <a:schemeClr val="accent1"/>
+          </a:fillRef>
+          <a:effectRef idx="2">
+            <a:schemeClr val="accent1"/>
+          </a:effectRef>
+          <a:fontRef idx="minor">
+            <a:schemeClr val="lt1"/>
+          </a:fontRef>
+        </p:style>
+        <p:txBody>
+          <a:bodyPr rtlCol="0" anchor="ctr"/>
+          <a:lstStyle/>
+          <a:p>
+            <a:pPr algn="ctr"/>
+            <a:endParaRPr/>
+          </a:p>
+        </p:txBody>
+      </p:sp>
+      <p:sp>
+        <p:nvSpPr>
+          <p:cNvPr id="3" name="TextBox 2"/>
+          <p:cNvSpPr txBox="1"/>
+          <p:nvPr/>
+        </p:nvSpPr>
+        <p:spPr>
+          <a:xfrm>
+            <a:off x="731520" y="365760"/>
+            <a:ext cx="10728655" cy="569387"/>
+          </a:xfrm>
+          <a:prstGeom prst="rect">
+            <a:avLst/>
+          </a:prstGeom>
+          <a:noFill/>
+        </p:spPr>
+        <p:txBody>
+          <a:bodyPr wrap="square" lIns="0" tIns="0" rIns="0" bIns="0">
+            <a:spAutoFit/>
+          </a:bodyPr>
+          <a:lstStyle/>
+          <a:p>
+            <a:pPr>
+              <a:defRPr sz="1300" b="1">
+                <a:solidFill>
+                  <a:srgbClr val="38BDF8"/>
+                </a:solidFill>
+              </a:defRPr>
+            </a:pPr>
+            <a:r>
+              <a:rPr dirty="0"/>
               <a:t>● ACADEMIC &amp; ENGINEERING BASE</a:t>
             </a:r>
           </a:p>
@@ -10881,921 +10637,6 @@
                 <a:schemeClr val="bg1"/>
               </a:solidFill>
             </a:endParaRPr>
-          </a:p>
-        </p:txBody>
-      </p:sp>
-    </p:spTree>
-  </p:cSld>
-  <p:clrMapOvr>
-    <a:masterClrMapping/>
-  </p:clrMapOvr>
-</p:sld>
-</file>
-
-<file path=ppt/slides/slide8.xml><?xml version="1.0" encoding="utf-8"?>
-<p:sld xmlns:a="http://schemas.openxmlformats.org/drawingml/2006/main" xmlns:r="http://schemas.openxmlformats.org/officeDocument/2006/relationships" xmlns:p="http://schemas.openxmlformats.org/presentationml/2006/main">
-  <p:cSld>
-    <p:spTree>
-      <p:nvGrpSpPr>
-        <p:cNvPr id="1" name=""/>
-        <p:cNvGrpSpPr/>
-        <p:nvPr/>
-      </p:nvGrpSpPr>
-      <p:grpSpPr>
-        <a:xfrm>
-          <a:off x="0" y="0"/>
-          <a:ext cx="0" cy="0"/>
-          <a:chOff x="0" y="0"/>
-          <a:chExt cx="0" cy="0"/>
-        </a:xfrm>
-      </p:grpSpPr>
-      <p:sp>
-        <p:nvSpPr>
-          <p:cNvPr id="2" name="Rectangle 1"/>
-          <p:cNvSpPr/>
-          <p:nvPr/>
-        </p:nvSpPr>
-        <p:spPr>
-          <a:xfrm>
-            <a:off x="0" y="0"/>
-            <a:ext cx="12191695" cy="6858000"/>
-          </a:xfrm>
-          <a:prstGeom prst="rect">
-            <a:avLst/>
-          </a:prstGeom>
-          <a:solidFill>
-            <a:srgbClr val="070A12"/>
-          </a:solidFill>
-          <a:ln>
-            <a:noFill/>
-          </a:ln>
-        </p:spPr>
-        <p:style>
-          <a:lnRef idx="1">
-            <a:schemeClr val="accent1"/>
-          </a:lnRef>
-          <a:fillRef idx="3">
-            <a:schemeClr val="accent1"/>
-          </a:fillRef>
-          <a:effectRef idx="2">
-            <a:schemeClr val="accent1"/>
-          </a:effectRef>
-          <a:fontRef idx="minor">
-            <a:schemeClr val="lt1"/>
-          </a:fontRef>
-        </p:style>
-        <p:txBody>
-          <a:bodyPr rtlCol="0" anchor="ctr"/>
-          <a:lstStyle/>
-          <a:p>
-            <a:pPr algn="ctr"/>
-            <a:endParaRPr/>
-          </a:p>
-        </p:txBody>
-      </p:sp>
-      <p:sp>
-        <p:nvSpPr>
-          <p:cNvPr id="3" name="TextBox 2"/>
-          <p:cNvSpPr txBox="1"/>
-          <p:nvPr/>
-        </p:nvSpPr>
-        <p:spPr>
-          <a:xfrm>
-            <a:off x="731520" y="365760"/>
-            <a:ext cx="10728655" cy="569387"/>
-          </a:xfrm>
-          <a:prstGeom prst="rect">
-            <a:avLst/>
-          </a:prstGeom>
-          <a:noFill/>
-        </p:spPr>
-        <p:txBody>
-          <a:bodyPr wrap="square" lIns="0" tIns="0" rIns="0" bIns="0">
-            <a:spAutoFit/>
-          </a:bodyPr>
-          <a:lstStyle/>
-          <a:p>
-            <a:pPr>
-              <a:defRPr sz="1300" b="1">
-                <a:solidFill>
-                  <a:srgbClr val="38BDF8"/>
-                </a:solidFill>
-              </a:defRPr>
-            </a:pPr>
-            <a:r>
-              <a:rPr dirty="0"/>
-              <a:t>● CROSS-INDUSTRY MAPPING</a:t>
-            </a:r>
-          </a:p>
-          <a:p>
-            <a:pPr>
-              <a:defRPr sz="2400" b="1">
-                <a:solidFill>
-                  <a:srgbClr val="F8FAFC"/>
-                </a:solidFill>
-              </a:defRPr>
-            </a:pPr>
-            <a:r>
-              <a:rPr lang="zh-TW" altLang="en-US" dirty="0"/>
-              <a:t>一底兜百業</a:t>
-            </a:r>
-            <a:r>
-              <a:rPr dirty="0"/>
-              <a:t>：</a:t>
-            </a:r>
-            <a:r>
-              <a:rPr lang="zh-TW" altLang="en-US" dirty="0"/>
-              <a:t>六大產業痛點的</a:t>
-            </a:r>
-            <a:r>
-              <a:rPr dirty="0"/>
-              <a:t> Ingress / Egress </a:t>
-            </a:r>
-            <a:r>
-              <a:rPr lang="zh-TW" altLang="en-US" dirty="0"/>
-              <a:t>統一對照機制</a:t>
-            </a:r>
-            <a:endParaRPr dirty="0"/>
-          </a:p>
-        </p:txBody>
-      </p:sp>
-      <p:sp>
-        <p:nvSpPr>
-          <p:cNvPr id="4" name="Rounded Rectangle 3"/>
-          <p:cNvSpPr/>
-          <p:nvPr/>
-        </p:nvSpPr>
-        <p:spPr>
-          <a:xfrm>
-            <a:off x="731520" y="1280160"/>
-            <a:ext cx="5212080" cy="1554480"/>
-          </a:xfrm>
-          <a:prstGeom prst="roundRect">
-            <a:avLst/>
-          </a:prstGeom>
-          <a:solidFill>
-            <a:srgbClr val="0F172A"/>
-          </a:solidFill>
-          <a:ln w="19050">
-            <a:solidFill>
-              <a:srgbClr val="38BDF8"/>
-            </a:solidFill>
-          </a:ln>
-        </p:spPr>
-        <p:style>
-          <a:lnRef idx="1">
-            <a:schemeClr val="accent1"/>
-          </a:lnRef>
-          <a:fillRef idx="3">
-            <a:schemeClr val="accent1"/>
-          </a:fillRef>
-          <a:effectRef idx="2">
-            <a:schemeClr val="accent1"/>
-          </a:effectRef>
-          <a:fontRef idx="minor">
-            <a:schemeClr val="lt1"/>
-          </a:fontRef>
-        </p:style>
-        <p:txBody>
-          <a:bodyPr wrap="square" lIns="274320" tIns="228600" rIns="274320" bIns="182880" rtlCol="0" anchor="ctr"/>
-          <a:lstStyle/>
-          <a:p>
-            <a:pPr algn="ctr">
-              <a:defRPr sz="1300" b="1">
-                <a:solidFill>
-                  <a:srgbClr val="38BDF8"/>
-                </a:solidFill>
-              </a:defRPr>
-            </a:pPr>
-            <a:r>
-              <a:rPr sz="1400" dirty="0"/>
-              <a:t>🏭 Track 01 </a:t>
-            </a:r>
-            <a:r>
-              <a:rPr sz="1400" dirty="0" err="1"/>
-              <a:t>製造碳護照</a:t>
-            </a:r>
-            <a:endParaRPr sz="1400" dirty="0"/>
-          </a:p>
-          <a:p>
-            <a:pPr>
-              <a:defRPr sz="1100">
-                <a:solidFill>
-                  <a:srgbClr val="F8FAFC"/>
-                </a:solidFill>
-              </a:defRPr>
-            </a:pPr>
-            <a:r>
-              <a:rPr sz="1400" dirty="0"/>
-              <a:t>📥 Ingress: </a:t>
-            </a:r>
-            <a:r>
-              <a:rPr sz="1400" dirty="0" err="1"/>
-              <a:t>動態</a:t>
-            </a:r>
-            <a:r>
-              <a:rPr sz="1400" dirty="0"/>
-              <a:t> </a:t>
-            </a:r>
-            <a:r>
-              <a:rPr sz="1400" dirty="0" err="1"/>
-              <a:t>Redact：隔離</a:t>
-            </a:r>
-            <a:r>
-              <a:rPr sz="1400" dirty="0"/>
-              <a:t> BOM </a:t>
-            </a:r>
-            <a:r>
-              <a:rPr sz="1400" dirty="0" err="1"/>
-              <a:t>原料成本</a:t>
-            </a:r>
-            <a:r>
-              <a:rPr sz="1400" dirty="0"/>
-              <a:t>/</a:t>
-            </a:r>
-            <a:r>
-              <a:rPr sz="1400" dirty="0" err="1"/>
-              <a:t>良率，僅輸入碳排係數</a:t>
-            </a:r>
-            <a:r>
-              <a:rPr sz="1400" dirty="0"/>
-              <a:t>。</a:t>
-            </a:r>
-          </a:p>
-          <a:p>
-            <a:pPr>
-              <a:defRPr sz="1100">
-                <a:solidFill>
-                  <a:srgbClr val="CBD5E1"/>
-                </a:solidFill>
-              </a:defRPr>
-            </a:pPr>
-            <a:r>
-              <a:rPr sz="1400" dirty="0"/>
-              <a:t>📤 Egress: CBAM </a:t>
-            </a:r>
-            <a:r>
-              <a:rPr sz="1400" dirty="0" err="1"/>
-              <a:t>門閥：輸出機密瞬間熔斷，僅放行</a:t>
-            </a:r>
-            <a:r>
-              <a:rPr sz="1400" dirty="0"/>
-              <a:t> ZKP </a:t>
-            </a:r>
-            <a:r>
-              <a:rPr sz="1400" dirty="0" err="1"/>
-              <a:t>碳排憑證</a:t>
-            </a:r>
-            <a:r>
-              <a:rPr sz="1400" dirty="0"/>
-              <a:t>。</a:t>
-            </a:r>
-          </a:p>
-        </p:txBody>
-      </p:sp>
-      <p:sp>
-        <p:nvSpPr>
-          <p:cNvPr id="5" name="Rounded Rectangle 4"/>
-          <p:cNvSpPr/>
-          <p:nvPr/>
-        </p:nvSpPr>
-        <p:spPr>
-          <a:xfrm>
-            <a:off x="6248095" y="1280160"/>
-            <a:ext cx="5212080" cy="1554480"/>
-          </a:xfrm>
-          <a:prstGeom prst="roundRect">
-            <a:avLst/>
-          </a:prstGeom>
-          <a:solidFill>
-            <a:srgbClr val="0F172A"/>
-          </a:solidFill>
-          <a:ln w="19050">
-            <a:solidFill>
-              <a:srgbClr val="4ADE80"/>
-            </a:solidFill>
-          </a:ln>
-        </p:spPr>
-        <p:style>
-          <a:lnRef idx="1">
-            <a:schemeClr val="accent1"/>
-          </a:lnRef>
-          <a:fillRef idx="3">
-            <a:schemeClr val="accent1"/>
-          </a:fillRef>
-          <a:effectRef idx="2">
-            <a:schemeClr val="accent1"/>
-          </a:effectRef>
-          <a:fontRef idx="minor">
-            <a:schemeClr val="lt1"/>
-          </a:fontRef>
-        </p:style>
-        <p:txBody>
-          <a:bodyPr wrap="square" lIns="274320" tIns="228600" rIns="274320" bIns="182880" rtlCol="0" anchor="ctr"/>
-          <a:lstStyle/>
-          <a:p>
-            <a:pPr algn="ctr">
-              <a:defRPr sz="1300" b="1">
-                <a:solidFill>
-                  <a:srgbClr val="4ADE80"/>
-                </a:solidFill>
-              </a:defRPr>
-            </a:pPr>
-            <a:r>
-              <a:rPr sz="1400" dirty="0"/>
-              <a:t>🏭 Track 02 </a:t>
-            </a:r>
-            <a:r>
-              <a:rPr sz="1400" dirty="0" err="1"/>
-              <a:t>電支</a:t>
-            </a:r>
-            <a:r>
-              <a:rPr sz="1400" dirty="0"/>
-              <a:t> AML </a:t>
-            </a:r>
-            <a:r>
-              <a:rPr sz="1400" dirty="0" err="1"/>
-              <a:t>風控</a:t>
-            </a:r>
-            <a:endParaRPr sz="1400" dirty="0"/>
-          </a:p>
-          <a:p>
-            <a:pPr>
-              <a:defRPr sz="1100">
-                <a:solidFill>
-                  <a:srgbClr val="F8FAFC"/>
-                </a:solidFill>
-              </a:defRPr>
-            </a:pPr>
-            <a:r>
-              <a:rPr sz="1400" dirty="0"/>
-              <a:t>📥 Ingress: </a:t>
-            </a:r>
-            <a:r>
-              <a:rPr sz="1400" dirty="0" err="1"/>
-              <a:t>去識別化密態特徵：遮蔽姓名</a:t>
-            </a:r>
-            <a:r>
-              <a:rPr sz="1400" dirty="0"/>
-              <a:t>/</a:t>
-            </a:r>
-            <a:r>
-              <a:rPr sz="1400" dirty="0" err="1"/>
-              <a:t>身分證</a:t>
-            </a:r>
-            <a:r>
-              <a:rPr sz="1400" dirty="0"/>
-              <a:t>/</a:t>
-            </a:r>
-            <a:r>
-              <a:rPr sz="1400" dirty="0" err="1"/>
-              <a:t>帳戶明細，提供圖向量</a:t>
-            </a:r>
-            <a:r>
-              <a:rPr sz="1400" dirty="0"/>
-              <a:t>。</a:t>
-            </a:r>
-          </a:p>
-          <a:p>
-            <a:pPr>
-              <a:defRPr sz="1100">
-                <a:solidFill>
-                  <a:srgbClr val="CBD5E1"/>
-                </a:solidFill>
-              </a:defRPr>
-            </a:pPr>
-            <a:r>
-              <a:rPr sz="1400" dirty="0"/>
-              <a:t>📤 Egress: </a:t>
-            </a:r>
-            <a:r>
-              <a:rPr sz="1400" dirty="0" err="1"/>
-              <a:t>微秒支付阻斷：洗錢特徵瞬間</a:t>
-            </a:r>
-            <a:r>
-              <a:rPr sz="1400" dirty="0"/>
-              <a:t> C-ABI </a:t>
-            </a:r>
-            <a:r>
-              <a:rPr sz="1400" dirty="0" err="1"/>
-              <a:t>懸停，觸發雙簽</a:t>
-            </a:r>
-            <a:r>
-              <a:rPr sz="1400" dirty="0"/>
-              <a:t>。</a:t>
-            </a:r>
-          </a:p>
-        </p:txBody>
-      </p:sp>
-      <p:sp>
-        <p:nvSpPr>
-          <p:cNvPr id="6" name="Rounded Rectangle 5"/>
-          <p:cNvSpPr/>
-          <p:nvPr/>
-        </p:nvSpPr>
-        <p:spPr>
-          <a:xfrm>
-            <a:off x="731520" y="2971800"/>
-            <a:ext cx="5212080" cy="1554480"/>
-          </a:xfrm>
-          <a:prstGeom prst="roundRect">
-            <a:avLst/>
-          </a:prstGeom>
-          <a:solidFill>
-            <a:srgbClr val="0F172A"/>
-          </a:solidFill>
-          <a:ln w="19050">
-            <a:solidFill>
-              <a:srgbClr val="F87171"/>
-            </a:solidFill>
-          </a:ln>
-        </p:spPr>
-        <p:style>
-          <a:lnRef idx="1">
-            <a:schemeClr val="accent1"/>
-          </a:lnRef>
-          <a:fillRef idx="3">
-            <a:schemeClr val="accent1"/>
-          </a:fillRef>
-          <a:effectRef idx="2">
-            <a:schemeClr val="accent1"/>
-          </a:effectRef>
-          <a:fontRef idx="minor">
-            <a:schemeClr val="lt1"/>
-          </a:fontRef>
-        </p:style>
-        <p:txBody>
-          <a:bodyPr wrap="square" lIns="274320" tIns="228600" rIns="274320" bIns="182880" rtlCol="0" anchor="ctr"/>
-          <a:lstStyle/>
-          <a:p>
-            <a:pPr algn="ctr">
-              <a:defRPr sz="1300" b="1">
-                <a:solidFill>
-                  <a:srgbClr val="F87171"/>
-                </a:solidFill>
-              </a:defRPr>
-            </a:pPr>
-            <a:r>
-              <a:rPr sz="1400" dirty="0"/>
-              <a:t>🏭 Track 03 </a:t>
-            </a:r>
-            <a:r>
-              <a:rPr sz="1400" dirty="0" err="1"/>
-              <a:t>醫療保險理賠</a:t>
-            </a:r>
-            <a:endParaRPr sz="1400" dirty="0"/>
-          </a:p>
-          <a:p>
-            <a:pPr>
-              <a:defRPr sz="1100">
-                <a:solidFill>
-                  <a:srgbClr val="F8FAFC"/>
-                </a:solidFill>
-              </a:defRPr>
-            </a:pPr>
-            <a:r>
-              <a:rPr sz="1400" dirty="0"/>
-              <a:t>📥 Ingress: 18項 PHI </a:t>
-            </a:r>
-            <a:r>
-              <a:rPr sz="1400" dirty="0" err="1"/>
-              <a:t>自動遮蔽：病歷與基因嚴密隔離，輸入診斷碼</a:t>
-            </a:r>
-            <a:r>
-              <a:rPr sz="1400" dirty="0"/>
-              <a:t>/</a:t>
-            </a:r>
-            <a:r>
-              <a:rPr sz="1400" dirty="0" err="1"/>
-              <a:t>金額</a:t>
-            </a:r>
-            <a:r>
-              <a:rPr sz="1400" dirty="0"/>
-              <a:t>。</a:t>
-            </a:r>
-          </a:p>
-          <a:p>
-            <a:pPr>
-              <a:defRPr sz="1100">
-                <a:solidFill>
-                  <a:srgbClr val="CBD5E1"/>
-                </a:solidFill>
-              </a:defRPr>
-            </a:pPr>
-            <a:r>
-              <a:rPr sz="1400" dirty="0"/>
-              <a:t>📤 Egress: </a:t>
-            </a:r>
-            <a:r>
-              <a:rPr sz="1400" dirty="0" err="1"/>
-              <a:t>保險聯盟鏈對接：越權調閱</a:t>
-            </a:r>
-            <a:r>
-              <a:rPr sz="1400" dirty="0"/>
-              <a:t> 26.1μs </a:t>
-            </a:r>
-            <a:r>
-              <a:rPr sz="1400" dirty="0" err="1"/>
-              <a:t>硬熔斷，放行出具</a:t>
-            </a:r>
-            <a:r>
-              <a:rPr sz="1400" dirty="0"/>
-              <a:t> Merkle。</a:t>
-            </a:r>
-          </a:p>
-        </p:txBody>
-      </p:sp>
-      <p:sp>
-        <p:nvSpPr>
-          <p:cNvPr id="7" name="Rounded Rectangle 6"/>
-          <p:cNvSpPr/>
-          <p:nvPr/>
-        </p:nvSpPr>
-        <p:spPr>
-          <a:xfrm>
-            <a:off x="6248095" y="2971800"/>
-            <a:ext cx="5212080" cy="1554480"/>
-          </a:xfrm>
-          <a:prstGeom prst="roundRect">
-            <a:avLst/>
-          </a:prstGeom>
-          <a:solidFill>
-            <a:srgbClr val="0F172A"/>
-          </a:solidFill>
-          <a:ln w="19050">
-            <a:solidFill>
-              <a:srgbClr val="FBBF24"/>
-            </a:solidFill>
-          </a:ln>
-        </p:spPr>
-        <p:style>
-          <a:lnRef idx="1">
-            <a:schemeClr val="accent1"/>
-          </a:lnRef>
-          <a:fillRef idx="3">
-            <a:schemeClr val="accent1"/>
-          </a:fillRef>
-          <a:effectRef idx="2">
-            <a:schemeClr val="accent1"/>
-          </a:effectRef>
-          <a:fontRef idx="minor">
-            <a:schemeClr val="lt1"/>
-          </a:fontRef>
-        </p:style>
-        <p:txBody>
-          <a:bodyPr wrap="square" lIns="274320" tIns="228600" rIns="274320" bIns="182880" rtlCol="0" anchor="ctr"/>
-          <a:lstStyle/>
-          <a:p>
-            <a:pPr algn="ctr">
-              <a:defRPr sz="1300" b="1">
-                <a:solidFill>
-                  <a:srgbClr val="FBBF24"/>
-                </a:solidFill>
-              </a:defRPr>
-            </a:pPr>
-            <a:r>
-              <a:rPr sz="1400" dirty="0"/>
-              <a:t>🏭 Track 04 </a:t>
-            </a:r>
-            <a:r>
-              <a:rPr sz="1400" dirty="0" err="1"/>
-              <a:t>政府跨機關代辦</a:t>
-            </a:r>
-            <a:endParaRPr sz="1400" dirty="0"/>
-          </a:p>
-          <a:p>
-            <a:pPr>
-              <a:defRPr sz="1100">
-                <a:solidFill>
-                  <a:srgbClr val="F8FAFC"/>
-                </a:solidFill>
-              </a:defRPr>
-            </a:pPr>
-            <a:r>
-              <a:rPr sz="1400" dirty="0"/>
-              <a:t>📥 Ingress: </a:t>
-            </a:r>
-            <a:r>
-              <a:rPr sz="1400" dirty="0" err="1"/>
-              <a:t>三層代理過濾：事務所</a:t>
-            </a:r>
-            <a:r>
-              <a:rPr sz="1400" dirty="0"/>
-              <a:t> </a:t>
-            </a:r>
-            <a:r>
-              <a:rPr sz="1400" dirty="0" err="1"/>
-              <a:t>vLEI</a:t>
-            </a:r>
-            <a:r>
-              <a:rPr sz="1400" dirty="0"/>
-              <a:t> </a:t>
-            </a:r>
-            <a:r>
-              <a:rPr sz="1400" dirty="0" err="1"/>
-              <a:t>僅取所得級距，隔離完整稅籍</a:t>
-            </a:r>
-            <a:r>
-              <a:rPr sz="1400" dirty="0"/>
-              <a:t>。</a:t>
-            </a:r>
-          </a:p>
-          <a:p>
-            <a:pPr>
-              <a:defRPr sz="1100">
-                <a:solidFill>
-                  <a:srgbClr val="CBD5E1"/>
-                </a:solidFill>
-              </a:defRPr>
-            </a:pPr>
-            <a:r>
-              <a:rPr sz="1400" dirty="0"/>
-              <a:t>📤 Egress: </a:t>
-            </a:r>
-            <a:r>
-              <a:rPr sz="1400" dirty="0" err="1"/>
-              <a:t>代送件越權阻斷：越權調閱戶政瞬間攔截，出具</a:t>
-            </a:r>
-            <a:r>
-              <a:rPr sz="1400" dirty="0"/>
-              <a:t> W3C VC </a:t>
-            </a:r>
-            <a:r>
-              <a:rPr sz="1400" dirty="0" err="1"/>
-              <a:t>收據</a:t>
-            </a:r>
-            <a:r>
-              <a:rPr sz="1400" dirty="0"/>
-              <a:t>。</a:t>
-            </a:r>
-          </a:p>
-        </p:txBody>
-      </p:sp>
-      <p:sp>
-        <p:nvSpPr>
-          <p:cNvPr id="8" name="Rounded Rectangle 7"/>
-          <p:cNvSpPr/>
-          <p:nvPr/>
-        </p:nvSpPr>
-        <p:spPr>
-          <a:xfrm>
-            <a:off x="731520" y="4663440"/>
-            <a:ext cx="5212080" cy="1554480"/>
-          </a:xfrm>
-          <a:prstGeom prst="roundRect">
-            <a:avLst/>
-          </a:prstGeom>
-          <a:solidFill>
-            <a:srgbClr val="0F172A"/>
-          </a:solidFill>
-          <a:ln w="19050">
-            <a:solidFill>
-              <a:srgbClr val="C084FC"/>
-            </a:solidFill>
-          </a:ln>
-        </p:spPr>
-        <p:style>
-          <a:lnRef idx="1">
-            <a:schemeClr val="accent1"/>
-          </a:lnRef>
-          <a:fillRef idx="3">
-            <a:schemeClr val="accent1"/>
-          </a:fillRef>
-          <a:effectRef idx="2">
-            <a:schemeClr val="accent1"/>
-          </a:effectRef>
-          <a:fontRef idx="minor">
-            <a:schemeClr val="lt1"/>
-          </a:fontRef>
-        </p:style>
-        <p:txBody>
-          <a:bodyPr wrap="square" lIns="274320" tIns="228600" rIns="274320" bIns="182880" rtlCol="0" anchor="ctr"/>
-          <a:lstStyle/>
-          <a:p>
-            <a:pPr algn="ctr">
-              <a:defRPr sz="1300" b="1">
-                <a:solidFill>
-                  <a:srgbClr val="C084FC"/>
-                </a:solidFill>
-              </a:defRPr>
-            </a:pPr>
-            <a:r>
-              <a:rPr sz="1400" dirty="0"/>
-              <a:t>🏭 Track 05 </a:t>
-            </a:r>
-            <a:r>
-              <a:rPr sz="1400" dirty="0" err="1"/>
-              <a:t>移工普惠金融</a:t>
-            </a:r>
-            <a:endParaRPr sz="1400" dirty="0"/>
-          </a:p>
-          <a:p>
-            <a:pPr>
-              <a:defRPr sz="1100">
-                <a:solidFill>
-                  <a:srgbClr val="F8FAFC"/>
-                </a:solidFill>
-              </a:defRPr>
-            </a:pPr>
-            <a:r>
-              <a:rPr sz="1400" dirty="0"/>
-              <a:t>📥 Ingress: 1:1:1 </a:t>
-            </a:r>
-            <a:r>
-              <a:rPr sz="1400" dirty="0" err="1"/>
-              <a:t>複合身分綁定：護照+居留證+門號為</a:t>
-            </a:r>
-            <a:r>
-              <a:rPr sz="1400" dirty="0"/>
-              <a:t> </a:t>
-            </a:r>
-            <a:r>
-              <a:rPr sz="1400" dirty="0" err="1"/>
-              <a:t>DIT，隱匿密碼</a:t>
-            </a:r>
-            <a:r>
-              <a:rPr sz="1400" dirty="0"/>
-              <a:t>。</a:t>
-            </a:r>
-          </a:p>
-          <a:p>
-            <a:pPr>
-              <a:defRPr sz="1100">
-                <a:solidFill>
-                  <a:srgbClr val="CBD5E1"/>
-                </a:solidFill>
-              </a:defRPr>
-            </a:pPr>
-            <a:r>
-              <a:rPr sz="1400" dirty="0"/>
-              <a:t>📤 Egress: SIM Swap </a:t>
-            </a:r>
-            <a:r>
-              <a:rPr sz="1400" dirty="0" err="1"/>
-              <a:t>連鎖凍結：換卡</a:t>
-            </a:r>
-            <a:r>
-              <a:rPr sz="1400" dirty="0"/>
-              <a:t>/</a:t>
-            </a:r>
-            <a:r>
-              <a:rPr sz="1400" dirty="0" err="1"/>
-              <a:t>異常轉帳</a:t>
-            </a:r>
-            <a:r>
-              <a:rPr sz="1400" dirty="0"/>
-              <a:t> O(1) </a:t>
-            </a:r>
-            <a:r>
-              <a:rPr sz="1400" dirty="0" err="1"/>
-              <a:t>原子指針秒凍結</a:t>
-            </a:r>
-            <a:r>
-              <a:rPr sz="1400" dirty="0"/>
-              <a:t>。</a:t>
-            </a:r>
-          </a:p>
-        </p:txBody>
-      </p:sp>
-      <p:sp>
-        <p:nvSpPr>
-          <p:cNvPr id="9" name="Rounded Rectangle 8"/>
-          <p:cNvSpPr/>
-          <p:nvPr/>
-        </p:nvSpPr>
-        <p:spPr>
-          <a:xfrm>
-            <a:off x="6248095" y="4663440"/>
-            <a:ext cx="5212080" cy="1554480"/>
-          </a:xfrm>
-          <a:prstGeom prst="roundRect">
-            <a:avLst/>
-          </a:prstGeom>
-          <a:solidFill>
-            <a:srgbClr val="0F172A"/>
-          </a:solidFill>
-          <a:ln w="19050">
-            <a:solidFill>
-              <a:srgbClr val="38BDF8"/>
-            </a:solidFill>
-          </a:ln>
-        </p:spPr>
-        <p:style>
-          <a:lnRef idx="1">
-            <a:schemeClr val="accent1"/>
-          </a:lnRef>
-          <a:fillRef idx="3">
-            <a:schemeClr val="accent1"/>
-          </a:fillRef>
-          <a:effectRef idx="2">
-            <a:schemeClr val="accent1"/>
-          </a:effectRef>
-          <a:fontRef idx="minor">
-            <a:schemeClr val="lt1"/>
-          </a:fontRef>
-        </p:style>
-        <p:txBody>
-          <a:bodyPr wrap="square" lIns="274320" tIns="228600" rIns="274320" bIns="182880" rtlCol="0" anchor="ctr"/>
-          <a:lstStyle/>
-          <a:p>
-            <a:pPr algn="ctr">
-              <a:defRPr sz="1300" b="1">
-                <a:solidFill>
-                  <a:srgbClr val="38BDF8"/>
-                </a:solidFill>
-              </a:defRPr>
-            </a:pPr>
-            <a:r>
-              <a:rPr sz="1400" dirty="0"/>
-              <a:t>🏭 Track 06 </a:t>
-            </a:r>
-            <a:r>
-              <a:rPr sz="1400" dirty="0" err="1"/>
-              <a:t>供應鏈</a:t>
-            </a:r>
-            <a:r>
-              <a:rPr sz="1400" dirty="0"/>
-              <a:t> RBA </a:t>
-            </a:r>
-            <a:r>
-              <a:rPr sz="1400" dirty="0" err="1"/>
-              <a:t>稽核</a:t>
-            </a:r>
-            <a:endParaRPr sz="1400" dirty="0"/>
-          </a:p>
-          <a:p>
-            <a:pPr>
-              <a:defRPr sz="1100">
-                <a:solidFill>
-                  <a:srgbClr val="F8FAFC"/>
-                </a:solidFill>
-              </a:defRPr>
-            </a:pPr>
-            <a:r>
-              <a:rPr sz="1400" dirty="0"/>
-              <a:t>📥 Ingress: </a:t>
-            </a:r>
-            <a:r>
-              <a:rPr sz="1400" dirty="0" err="1"/>
-              <a:t>選擇性揭露</a:t>
-            </a:r>
-            <a:r>
-              <a:rPr sz="1400" dirty="0"/>
-              <a:t> </a:t>
-            </a:r>
-            <a:r>
-              <a:rPr sz="1400" dirty="0" err="1"/>
-              <a:t>ZKP-Lite：採購</a:t>
-            </a:r>
-            <a:r>
-              <a:rPr sz="1400" dirty="0"/>
-              <a:t> AI </a:t>
-            </a:r>
-            <a:r>
-              <a:rPr sz="1400" dirty="0" err="1"/>
-              <a:t>僅讀合規</a:t>
-            </a:r>
-            <a:r>
-              <a:rPr sz="1400" dirty="0"/>
-              <a:t> </a:t>
-            </a:r>
-            <a:r>
-              <a:rPr sz="1400" dirty="0" err="1"/>
-              <a:t>TRUE，無法讀薪資</a:t>
-            </a:r>
-            <a:r>
-              <a:rPr sz="1400" dirty="0"/>
-              <a:t>。</a:t>
-            </a:r>
-          </a:p>
-          <a:p>
-            <a:pPr>
-              <a:defRPr sz="1100">
-                <a:solidFill>
-                  <a:srgbClr val="CBD5E1"/>
-                </a:solidFill>
-              </a:defRPr>
-            </a:pPr>
-            <a:r>
-              <a:rPr sz="1400" dirty="0"/>
-              <a:t>📤 Egress: </a:t>
-            </a:r>
-            <a:r>
-              <a:rPr sz="1400" dirty="0" err="1"/>
-              <a:t>雇主付費存證：物理鎖定採購</a:t>
-            </a:r>
-            <a:r>
-              <a:rPr sz="1400" dirty="0"/>
-              <a:t> </a:t>
-            </a:r>
-            <a:r>
-              <a:rPr sz="1400" dirty="0" err="1"/>
-              <a:t>Tool，越權即熔斷產出收據</a:t>
-            </a:r>
-            <a:r>
-              <a:rPr sz="1400" dirty="0"/>
-              <a:t>。</a:t>
-            </a:r>
           </a:p>
         </p:txBody>
       </p:sp>
@@ -12847,4 +11688,634 @@
   </a:objectDefaults>
   <a:extraClrSchemeLst/>
 </a:theme>
+</file>
+
+<file path=ppt/theme/theme2.xml><?xml version="1.0" encoding="utf-8"?>
+<a:theme xmlns:a="http://schemas.openxmlformats.org/drawingml/2006/main" name="Office 佈景主題">
+  <a:themeElements>
+    <a:clrScheme name="Office">
+      <a:dk1>
+        <a:sysClr val="windowText" lastClr="000000"/>
+      </a:dk1>
+      <a:lt1>
+        <a:sysClr val="window" lastClr="FFFFFF"/>
+      </a:lt1>
+      <a:dk2>
+        <a:srgbClr val="0E2841"/>
+      </a:dk2>
+      <a:lt2>
+        <a:srgbClr val="E8E8E8"/>
+      </a:lt2>
+      <a:accent1>
+        <a:srgbClr val="156082"/>
+      </a:accent1>
+      <a:accent2>
+        <a:srgbClr val="E97132"/>
+      </a:accent2>
+      <a:accent3>
+        <a:srgbClr val="196B24"/>
+      </a:accent3>
+      <a:accent4>
+        <a:srgbClr val="0F9ED5"/>
+      </a:accent4>
+      <a:accent5>
+        <a:srgbClr val="A02B93"/>
+      </a:accent5>
+      <a:accent6>
+        <a:srgbClr val="4EA72E"/>
+      </a:accent6>
+      <a:hlink>
+        <a:srgbClr val="467886"/>
+      </a:hlink>
+      <a:folHlink>
+        <a:srgbClr val="96607D"/>
+      </a:folHlink>
+    </a:clrScheme>
+    <a:fontScheme name="Office">
+      <a:majorFont>
+        <a:latin typeface="Aptos Display" panose="02110004020202020204"/>
+        <a:ea typeface=""/>
+        <a:cs typeface=""/>
+        <a:font script="Jpan" typeface="游ゴシック Light"/>
+        <a:font script="Hang" typeface="맑은 고딕"/>
+        <a:font script="Hans" typeface="等线 Light"/>
+        <a:font script="Hant" typeface="新細明體"/>
+        <a:font script="Arab" typeface="Times New Roman"/>
+        <a:font script="Hebr" typeface="Times New Roman"/>
+        <a:font script="Thai" typeface="Angsana New"/>
+        <a:font script="Ethi" typeface="Nyala"/>
+        <a:font script="Beng" typeface="Vrinda"/>
+        <a:font script="Gujr" typeface="Shruti"/>
+        <a:font script="Khmr" typeface="MoolBoran"/>
+        <a:font script="Knda" typeface="Tunga"/>
+        <a:font script="Guru" typeface="Raavi"/>
+        <a:font script="Cans" typeface="Euphemia"/>
+        <a:font script="Cher" typeface="Plantagenet Cherokee"/>
+        <a:font script="Yiii" typeface="Microsoft Yi Baiti"/>
+        <a:font script="Tibt" typeface="Microsoft Himalaya"/>
+        <a:font script="Thaa" typeface="MV Boli"/>
+        <a:font script="Deva" typeface="Mangal"/>
+        <a:font script="Telu" typeface="Gautami"/>
+        <a:font script="Taml" typeface="Latha"/>
+        <a:font script="Syrc" typeface="Estrangelo Edessa"/>
+        <a:font script="Orya" typeface="Kalinga"/>
+        <a:font script="Mlym" typeface="Kartika"/>
+        <a:font script="Laoo" typeface="DokChampa"/>
+        <a:font script="Sinh" typeface="Iskoola Pota"/>
+        <a:font script="Mong" typeface="Mongolian Baiti"/>
+        <a:font script="Viet" typeface="Times New Roman"/>
+        <a:font script="Uigh" typeface="Microsoft Uighur"/>
+        <a:font script="Geor" typeface="Sylfaen"/>
+        <a:font script="Armn" typeface="Arial"/>
+        <a:font script="Bugi" typeface="Leelawadee UI"/>
+        <a:font script="Bopo" typeface="Microsoft JhengHei"/>
+        <a:font script="Java" typeface="Javanese Text"/>
+        <a:font script="Lisu" typeface="Segoe UI"/>
+        <a:font script="Mymr" typeface="Myanmar Text"/>
+        <a:font script="Nkoo" typeface="Ebrima"/>
+        <a:font script="Olck" typeface="Nirmala UI"/>
+        <a:font script="Osma" typeface="Ebrima"/>
+        <a:font script="Phag" typeface="Phagspa"/>
+        <a:font script="Syrn" typeface="Estrangelo Edessa"/>
+        <a:font script="Syrj" typeface="Estrangelo Edessa"/>
+        <a:font script="Syre" typeface="Estrangelo Edessa"/>
+        <a:font script="Sora" typeface="Nirmala UI"/>
+        <a:font script="Tale" typeface="Microsoft Tai Le"/>
+        <a:font script="Talu" typeface="Microsoft New Tai Lue"/>
+        <a:font script="Tfng" typeface="Ebrima"/>
+      </a:majorFont>
+      <a:minorFont>
+        <a:latin typeface="Aptos" panose="02110004020202020204"/>
+        <a:ea typeface=""/>
+        <a:cs typeface=""/>
+        <a:font script="Jpan" typeface="游ゴシック"/>
+        <a:font script="Hang" typeface="맑은 고딕"/>
+        <a:font script="Hans" typeface="等线"/>
+        <a:font script="Hant" typeface="新細明體"/>
+        <a:font script="Arab" typeface="Arial"/>
+        <a:font script="Hebr" typeface="Arial"/>
+        <a:font script="Thai" typeface="Cordia New"/>
+        <a:font script="Ethi" typeface="Nyala"/>
+        <a:font script="Beng" typeface="Vrinda"/>
+        <a:font script="Gujr" typeface="Shruti"/>
+        <a:font script="Khmr" typeface="DaunPenh"/>
+        <a:font script="Knda" typeface="Tunga"/>
+        <a:font script="Guru" typeface="Raavi"/>
+        <a:font script="Cans" typeface="Euphemia"/>
+        <a:font script="Cher" typeface="Plantagenet Cherokee"/>
+        <a:font script="Yiii" typeface="Microsoft Yi Baiti"/>
+        <a:font script="Tibt" typeface="Microsoft Himalaya"/>
+        <a:font script="Thaa" typeface="MV Boli"/>
+        <a:font script="Deva" typeface="Mangal"/>
+        <a:font script="Telu" typeface="Gautami"/>
+        <a:font script="Taml" typeface="Latha"/>
+        <a:font script="Syrc" typeface="Estrangelo Edessa"/>
+        <a:font script="Orya" typeface="Kalinga"/>
+        <a:font script="Mlym" typeface="Kartika"/>
+        <a:font script="Laoo" typeface="DokChampa"/>
+        <a:font script="Sinh" typeface="Iskoola Pota"/>
+        <a:font script="Mong" typeface="Mongolian Baiti"/>
+        <a:font script="Viet" typeface="Arial"/>
+        <a:font script="Uigh" typeface="Microsoft Uighur"/>
+        <a:font script="Geor" typeface="Sylfaen"/>
+        <a:font script="Armn" typeface="Arial"/>
+        <a:font script="Bugi" typeface="Leelawadee UI"/>
+        <a:font script="Bopo" typeface="Microsoft JhengHei"/>
+        <a:font script="Java" typeface="Javanese Text"/>
+        <a:font script="Lisu" typeface="Segoe UI"/>
+        <a:font script="Mymr" typeface="Myanmar Text"/>
+        <a:font script="Nkoo" typeface="Ebrima"/>
+        <a:font script="Olck" typeface="Nirmala UI"/>
+        <a:font script="Osma" typeface="Ebrima"/>
+        <a:font script="Phag" typeface="Phagspa"/>
+        <a:font script="Syrn" typeface="Estrangelo Edessa"/>
+        <a:font script="Syrj" typeface="Estrangelo Edessa"/>
+        <a:font script="Syre" typeface="Estrangelo Edessa"/>
+        <a:font script="Sora" typeface="Nirmala UI"/>
+        <a:font script="Tale" typeface="Microsoft Tai Le"/>
+        <a:font script="Talu" typeface="Microsoft New Tai Lue"/>
+        <a:font script="Tfng" typeface="Ebrima"/>
+      </a:minorFont>
+    </a:fontScheme>
+    <a:fmtScheme name="Office">
+      <a:fillStyleLst>
+        <a:solidFill>
+          <a:schemeClr val="phClr"/>
+        </a:solidFill>
+        <a:gradFill rotWithShape="1">
+          <a:gsLst>
+            <a:gs pos="0">
+              <a:schemeClr val="phClr">
+                <a:lumMod val="110000"/>
+                <a:satMod val="105000"/>
+                <a:tint val="67000"/>
+              </a:schemeClr>
+            </a:gs>
+            <a:gs pos="50000">
+              <a:schemeClr val="phClr">
+                <a:lumMod val="105000"/>
+                <a:satMod val="103000"/>
+                <a:tint val="73000"/>
+              </a:schemeClr>
+            </a:gs>
+            <a:gs pos="100000">
+              <a:schemeClr val="phClr">
+                <a:lumMod val="105000"/>
+                <a:satMod val="109000"/>
+                <a:tint val="81000"/>
+              </a:schemeClr>
+            </a:gs>
+          </a:gsLst>
+          <a:lin ang="5400000" scaled="0"/>
+        </a:gradFill>
+        <a:gradFill rotWithShape="1">
+          <a:gsLst>
+            <a:gs pos="0">
+              <a:schemeClr val="phClr">
+                <a:satMod val="103000"/>
+                <a:lumMod val="102000"/>
+                <a:tint val="94000"/>
+              </a:schemeClr>
+            </a:gs>
+            <a:gs pos="50000">
+              <a:schemeClr val="phClr">
+                <a:satMod val="110000"/>
+                <a:lumMod val="100000"/>
+                <a:shade val="100000"/>
+              </a:schemeClr>
+            </a:gs>
+            <a:gs pos="100000">
+              <a:schemeClr val="phClr">
+                <a:lumMod val="99000"/>
+                <a:satMod val="120000"/>
+                <a:shade val="78000"/>
+              </a:schemeClr>
+            </a:gs>
+          </a:gsLst>
+          <a:lin ang="5400000" scaled="0"/>
+        </a:gradFill>
+      </a:fillStyleLst>
+      <a:lnStyleLst>
+        <a:ln w="12700" cap="flat" cmpd="sng" algn="ctr">
+          <a:solidFill>
+            <a:schemeClr val="phClr"/>
+          </a:solidFill>
+          <a:prstDash val="solid"/>
+          <a:miter lim="800000"/>
+        </a:ln>
+        <a:ln w="19050" cap="flat" cmpd="sng" algn="ctr">
+          <a:solidFill>
+            <a:schemeClr val="phClr"/>
+          </a:solidFill>
+          <a:prstDash val="solid"/>
+          <a:miter lim="800000"/>
+        </a:ln>
+        <a:ln w="25400" cap="flat" cmpd="sng" algn="ctr">
+          <a:solidFill>
+            <a:schemeClr val="phClr"/>
+          </a:solidFill>
+          <a:prstDash val="solid"/>
+          <a:miter lim="800000"/>
+        </a:ln>
+      </a:lnStyleLst>
+      <a:effectStyleLst>
+        <a:effectStyle>
+          <a:effectLst/>
+        </a:effectStyle>
+        <a:effectStyle>
+          <a:effectLst/>
+        </a:effectStyle>
+        <a:effectStyle>
+          <a:effectLst>
+            <a:outerShdw blurRad="57150" dist="19050" dir="5400000" algn="ctr" rotWithShape="0">
+              <a:srgbClr val="000000">
+                <a:alpha val="63000"/>
+              </a:srgbClr>
+            </a:outerShdw>
+          </a:effectLst>
+        </a:effectStyle>
+      </a:effectStyleLst>
+      <a:bgFillStyleLst>
+        <a:solidFill>
+          <a:schemeClr val="phClr"/>
+        </a:solidFill>
+        <a:solidFill>
+          <a:schemeClr val="phClr">
+            <a:tint val="95000"/>
+            <a:satMod val="170000"/>
+          </a:schemeClr>
+        </a:solidFill>
+        <a:gradFill rotWithShape="1">
+          <a:gsLst>
+            <a:gs pos="0">
+              <a:schemeClr val="phClr">
+                <a:tint val="93000"/>
+                <a:satMod val="150000"/>
+                <a:shade val="98000"/>
+                <a:lumMod val="102000"/>
+              </a:schemeClr>
+            </a:gs>
+            <a:gs pos="50000">
+              <a:schemeClr val="phClr">
+                <a:tint val="98000"/>
+                <a:satMod val="130000"/>
+                <a:shade val="90000"/>
+                <a:lumMod val="103000"/>
+              </a:schemeClr>
+            </a:gs>
+            <a:gs pos="100000">
+              <a:schemeClr val="phClr">
+                <a:shade val="63000"/>
+                <a:satMod val="120000"/>
+              </a:schemeClr>
+            </a:gs>
+          </a:gsLst>
+          <a:lin ang="5400000" scaled="0"/>
+        </a:gradFill>
+      </a:bgFillStyleLst>
+    </a:fmtScheme>
+  </a:themeElements>
+  <a:objectDefaults>
+    <a:lnDef>
+      <a:spPr/>
+      <a:bodyPr/>
+      <a:lstStyle/>
+      <a:style>
+        <a:lnRef idx="2">
+          <a:schemeClr val="accent1"/>
+        </a:lnRef>
+        <a:fillRef idx="0">
+          <a:schemeClr val="accent1"/>
+        </a:fillRef>
+        <a:effectRef idx="1">
+          <a:schemeClr val="accent1"/>
+        </a:effectRef>
+        <a:fontRef idx="minor">
+          <a:schemeClr val="tx1"/>
+        </a:fontRef>
+      </a:style>
+    </a:lnDef>
+  </a:objectDefaults>
+  <a:extraClrSchemeLst/>
+  <a:extLst>
+    <a:ext uri="{05A4C25C-085E-4340-85A3-A5531E510DB2}">
+      <thm15:themeFamily xmlns:thm15="http://schemas.microsoft.com/office/thememl/2012/main" name="Office Theme" id="{2E142A2C-CD16-42D6-873A-C26D2A0506FA}" vid="{1BDDFF52-6CD6-40A5-AB3C-68EB2F1E4D0A}"/>
+    </a:ext>
+  </a:extLst>
+</a:theme>
+</file>
+
+<file path=ppt/theme/theme3.xml><?xml version="1.0" encoding="utf-8"?>
+<a:theme xmlns:a="http://schemas.openxmlformats.org/drawingml/2006/main" name="Office 佈景主題">
+  <a:themeElements>
+    <a:clrScheme name="Office">
+      <a:dk1>
+        <a:sysClr val="windowText" lastClr="000000"/>
+      </a:dk1>
+      <a:lt1>
+        <a:sysClr val="window" lastClr="FFFFFF"/>
+      </a:lt1>
+      <a:dk2>
+        <a:srgbClr val="0E2841"/>
+      </a:dk2>
+      <a:lt2>
+        <a:srgbClr val="E8E8E8"/>
+      </a:lt2>
+      <a:accent1>
+        <a:srgbClr val="156082"/>
+      </a:accent1>
+      <a:accent2>
+        <a:srgbClr val="E97132"/>
+      </a:accent2>
+      <a:accent3>
+        <a:srgbClr val="196B24"/>
+      </a:accent3>
+      <a:accent4>
+        <a:srgbClr val="0F9ED5"/>
+      </a:accent4>
+      <a:accent5>
+        <a:srgbClr val="A02B93"/>
+      </a:accent5>
+      <a:accent6>
+        <a:srgbClr val="4EA72E"/>
+      </a:accent6>
+      <a:hlink>
+        <a:srgbClr val="467886"/>
+      </a:hlink>
+      <a:folHlink>
+        <a:srgbClr val="96607D"/>
+      </a:folHlink>
+    </a:clrScheme>
+    <a:fontScheme name="Office">
+      <a:majorFont>
+        <a:latin typeface="Aptos Display" panose="02110004020202020204"/>
+        <a:ea typeface=""/>
+        <a:cs typeface=""/>
+        <a:font script="Jpan" typeface="游ゴシック Light"/>
+        <a:font script="Hang" typeface="맑은 고딕"/>
+        <a:font script="Hans" typeface="等线 Light"/>
+        <a:font script="Hant" typeface="新細明體"/>
+        <a:font script="Arab" typeface="Times New Roman"/>
+        <a:font script="Hebr" typeface="Times New Roman"/>
+        <a:font script="Thai" typeface="Angsana New"/>
+        <a:font script="Ethi" typeface="Nyala"/>
+        <a:font script="Beng" typeface="Vrinda"/>
+        <a:font script="Gujr" typeface="Shruti"/>
+        <a:font script="Khmr" typeface="MoolBoran"/>
+        <a:font script="Knda" typeface="Tunga"/>
+        <a:font script="Guru" typeface="Raavi"/>
+        <a:font script="Cans" typeface="Euphemia"/>
+        <a:font script="Cher" typeface="Plantagenet Cherokee"/>
+        <a:font script="Yiii" typeface="Microsoft Yi Baiti"/>
+        <a:font script="Tibt" typeface="Microsoft Himalaya"/>
+        <a:font script="Thaa" typeface="MV Boli"/>
+        <a:font script="Deva" typeface="Mangal"/>
+        <a:font script="Telu" typeface="Gautami"/>
+        <a:font script="Taml" typeface="Latha"/>
+        <a:font script="Syrc" typeface="Estrangelo Edessa"/>
+        <a:font script="Orya" typeface="Kalinga"/>
+        <a:font script="Mlym" typeface="Kartika"/>
+        <a:font script="Laoo" typeface="DokChampa"/>
+        <a:font script="Sinh" typeface="Iskoola Pota"/>
+        <a:font script="Mong" typeface="Mongolian Baiti"/>
+        <a:font script="Viet" typeface="Times New Roman"/>
+        <a:font script="Uigh" typeface="Microsoft Uighur"/>
+        <a:font script="Geor" typeface="Sylfaen"/>
+        <a:font script="Armn" typeface="Arial"/>
+        <a:font script="Bugi" typeface="Leelawadee UI"/>
+        <a:font script="Bopo" typeface="Microsoft JhengHei"/>
+        <a:font script="Java" typeface="Javanese Text"/>
+        <a:font script="Lisu" typeface="Segoe UI"/>
+        <a:font script="Mymr" typeface="Myanmar Text"/>
+        <a:font script="Nkoo" typeface="Ebrima"/>
+        <a:font script="Olck" typeface="Nirmala UI"/>
+        <a:font script="Osma" typeface="Ebrima"/>
+        <a:font script="Phag" typeface="Phagspa"/>
+        <a:font script="Syrn" typeface="Estrangelo Edessa"/>
+        <a:font script="Syrj" typeface="Estrangelo Edessa"/>
+        <a:font script="Syre" typeface="Estrangelo Edessa"/>
+        <a:font script="Sora" typeface="Nirmala UI"/>
+        <a:font script="Tale" typeface="Microsoft Tai Le"/>
+        <a:font script="Talu" typeface="Microsoft New Tai Lue"/>
+        <a:font script="Tfng" typeface="Ebrima"/>
+      </a:majorFont>
+      <a:minorFont>
+        <a:latin typeface="Aptos" panose="02110004020202020204"/>
+        <a:ea typeface=""/>
+        <a:cs typeface=""/>
+        <a:font script="Jpan" typeface="游ゴシック"/>
+        <a:font script="Hang" typeface="맑은 고딕"/>
+        <a:font script="Hans" typeface="等线"/>
+        <a:font script="Hant" typeface="新細明體"/>
+        <a:font script="Arab" typeface="Arial"/>
+        <a:font script="Hebr" typeface="Arial"/>
+        <a:font script="Thai" typeface="Cordia New"/>
+        <a:font script="Ethi" typeface="Nyala"/>
+        <a:font script="Beng" typeface="Vrinda"/>
+        <a:font script="Gujr" typeface="Shruti"/>
+        <a:font script="Khmr" typeface="DaunPenh"/>
+        <a:font script="Knda" typeface="Tunga"/>
+        <a:font script="Guru" typeface="Raavi"/>
+        <a:font script="Cans" typeface="Euphemia"/>
+        <a:font script="Cher" typeface="Plantagenet Cherokee"/>
+        <a:font script="Yiii" typeface="Microsoft Yi Baiti"/>
+        <a:font script="Tibt" typeface="Microsoft Himalaya"/>
+        <a:font script="Thaa" typeface="MV Boli"/>
+        <a:font script="Deva" typeface="Mangal"/>
+        <a:font script="Telu" typeface="Gautami"/>
+        <a:font script="Taml" typeface="Latha"/>
+        <a:font script="Syrc" typeface="Estrangelo Edessa"/>
+        <a:font script="Orya" typeface="Kalinga"/>
+        <a:font script="Mlym" typeface="Kartika"/>
+        <a:font script="Laoo" typeface="DokChampa"/>
+        <a:font script="Sinh" typeface="Iskoola Pota"/>
+        <a:font script="Mong" typeface="Mongolian Baiti"/>
+        <a:font script="Viet" typeface="Arial"/>
+        <a:font script="Uigh" typeface="Microsoft Uighur"/>
+        <a:font script="Geor" typeface="Sylfaen"/>
+        <a:font script="Armn" typeface="Arial"/>
+        <a:font script="Bugi" typeface="Leelawadee UI"/>
+        <a:font script="Bopo" typeface="Microsoft JhengHei"/>
+        <a:font script="Java" typeface="Javanese Text"/>
+        <a:font script="Lisu" typeface="Segoe UI"/>
+        <a:font script="Mymr" typeface="Myanmar Text"/>
+        <a:font script="Nkoo" typeface="Ebrima"/>
+        <a:font script="Olck" typeface="Nirmala UI"/>
+        <a:font script="Osma" typeface="Ebrima"/>
+        <a:font script="Phag" typeface="Phagspa"/>
+        <a:font script="Syrn" typeface="Estrangelo Edessa"/>
+        <a:font script="Syrj" typeface="Estrangelo Edessa"/>
+        <a:font script="Syre" typeface="Estrangelo Edessa"/>
+        <a:font script="Sora" typeface="Nirmala UI"/>
+        <a:font script="Tale" typeface="Microsoft Tai Le"/>
+        <a:font script="Talu" typeface="Microsoft New Tai Lue"/>
+        <a:font script="Tfng" typeface="Ebrima"/>
+      </a:minorFont>
+    </a:fontScheme>
+    <a:fmtScheme name="Office">
+      <a:fillStyleLst>
+        <a:solidFill>
+          <a:schemeClr val="phClr"/>
+        </a:solidFill>
+        <a:gradFill rotWithShape="1">
+          <a:gsLst>
+            <a:gs pos="0">
+              <a:schemeClr val="phClr">
+                <a:lumMod val="110000"/>
+                <a:satMod val="105000"/>
+                <a:tint val="67000"/>
+              </a:schemeClr>
+            </a:gs>
+            <a:gs pos="50000">
+              <a:schemeClr val="phClr">
+                <a:lumMod val="105000"/>
+                <a:satMod val="103000"/>
+                <a:tint val="73000"/>
+              </a:schemeClr>
+            </a:gs>
+            <a:gs pos="100000">
+              <a:schemeClr val="phClr">
+                <a:lumMod val="105000"/>
+                <a:satMod val="109000"/>
+                <a:tint val="81000"/>
+              </a:schemeClr>
+            </a:gs>
+          </a:gsLst>
+          <a:lin ang="5400000" scaled="0"/>
+        </a:gradFill>
+        <a:gradFill rotWithShape="1">
+          <a:gsLst>
+            <a:gs pos="0">
+              <a:schemeClr val="phClr">
+                <a:satMod val="103000"/>
+                <a:lumMod val="102000"/>
+                <a:tint val="94000"/>
+              </a:schemeClr>
+            </a:gs>
+            <a:gs pos="50000">
+              <a:schemeClr val="phClr">
+                <a:satMod val="110000"/>
+                <a:lumMod val="100000"/>
+                <a:shade val="100000"/>
+              </a:schemeClr>
+            </a:gs>
+            <a:gs pos="100000">
+              <a:schemeClr val="phClr">
+                <a:lumMod val="99000"/>
+                <a:satMod val="120000"/>
+                <a:shade val="78000"/>
+              </a:schemeClr>
+            </a:gs>
+          </a:gsLst>
+          <a:lin ang="5400000" scaled="0"/>
+        </a:gradFill>
+      </a:fillStyleLst>
+      <a:lnStyleLst>
+        <a:ln w="12700" cap="flat" cmpd="sng" algn="ctr">
+          <a:solidFill>
+            <a:schemeClr val="phClr"/>
+          </a:solidFill>
+          <a:prstDash val="solid"/>
+          <a:miter lim="800000"/>
+        </a:ln>
+        <a:ln w="19050" cap="flat" cmpd="sng" algn="ctr">
+          <a:solidFill>
+            <a:schemeClr val="phClr"/>
+          </a:solidFill>
+          <a:prstDash val="solid"/>
+          <a:miter lim="800000"/>
+        </a:ln>
+        <a:ln w="25400" cap="flat" cmpd="sng" algn="ctr">
+          <a:solidFill>
+            <a:schemeClr val="phClr"/>
+          </a:solidFill>
+          <a:prstDash val="solid"/>
+          <a:miter lim="800000"/>
+        </a:ln>
+      </a:lnStyleLst>
+      <a:effectStyleLst>
+        <a:effectStyle>
+          <a:effectLst/>
+        </a:effectStyle>
+        <a:effectStyle>
+          <a:effectLst/>
+        </a:effectStyle>
+        <a:effectStyle>
+          <a:effectLst>
+            <a:outerShdw blurRad="57150" dist="19050" dir="5400000" algn="ctr" rotWithShape="0">
+              <a:srgbClr val="000000">
+                <a:alpha val="63000"/>
+              </a:srgbClr>
+            </a:outerShdw>
+          </a:effectLst>
+        </a:effectStyle>
+      </a:effectStyleLst>
+      <a:bgFillStyleLst>
+        <a:solidFill>
+          <a:schemeClr val="phClr"/>
+        </a:solidFill>
+        <a:solidFill>
+          <a:schemeClr val="phClr">
+            <a:tint val="95000"/>
+            <a:satMod val="170000"/>
+          </a:schemeClr>
+        </a:solidFill>
+        <a:gradFill rotWithShape="1">
+          <a:gsLst>
+            <a:gs pos="0">
+              <a:schemeClr val="phClr">
+                <a:tint val="93000"/>
+                <a:satMod val="150000"/>
+                <a:shade val="98000"/>
+                <a:lumMod val="102000"/>
+              </a:schemeClr>
+            </a:gs>
+            <a:gs pos="50000">
+              <a:schemeClr val="phClr">
+                <a:tint val="98000"/>
+                <a:satMod val="130000"/>
+                <a:shade val="90000"/>
+                <a:lumMod val="103000"/>
+              </a:schemeClr>
+            </a:gs>
+            <a:gs pos="100000">
+              <a:schemeClr val="phClr">
+                <a:shade val="63000"/>
+                <a:satMod val="120000"/>
+              </a:schemeClr>
+            </a:gs>
+          </a:gsLst>
+          <a:lin ang="5400000" scaled="0"/>
+        </a:gradFill>
+      </a:bgFillStyleLst>
+    </a:fmtScheme>
+  </a:themeElements>
+  <a:objectDefaults>
+    <a:lnDef>
+      <a:spPr/>
+      <a:bodyPr/>
+      <a:lstStyle/>
+      <a:style>
+        <a:lnRef idx="2">
+          <a:schemeClr val="accent1"/>
+        </a:lnRef>
+        <a:fillRef idx="0">
+          <a:schemeClr val="accent1"/>
+        </a:fillRef>
+        <a:effectRef idx="1">
+          <a:schemeClr val="accent1"/>
+        </a:effectRef>
+        <a:fontRef idx="minor">
+          <a:schemeClr val="tx1"/>
+        </a:fontRef>
+      </a:style>
+    </a:lnDef>
+  </a:objectDefaults>
+  <a:extraClrSchemeLst/>
+  <a:extLst>
+    <a:ext uri="{05A4C25C-085E-4340-85A3-A5531E510DB2}">
+      <thm15:themeFamily xmlns:thm15="http://schemas.microsoft.com/office/thememl/2012/main" name="Office Theme" id="{2E142A2C-CD16-42D6-873A-C26D2A0506FA}" vid="{1BDDFF52-6CD6-40A5-AB3C-68EB2F1E4D0A}"/>
+    </a:ext>
+  </a:extLst>
+</a:theme>
 </file>
</xml_diff>

<commit_message>
docs: finalize showcase submission with PDF only, PPTX, MP4 and double-click instructions
</commit_message>
<xml_diff>
--- a/B1_12_DROS(DeterministicRuntimeOS).pptx
+++ b/B1_12_DROS(DeterministicRuntimeOS).pptx
@@ -856,7 +856,7 @@
           <a:p>
             <a:fld id="{5BCAD085-E8A6-8845-BD4E-CB4CCA059FC4}" type="datetimeFigureOut">
               <a:rPr lang="en-US" smtClean="0"/>
-              <a:t>8/29/2026</a:t>
+              <a:t>8/30/2026</a:t>
             </a:fld>
             <a:endParaRPr lang="en-US"/>
           </a:p>
@@ -1024,7 +1024,7 @@
           <a:p>
             <a:fld id="{5BCAD085-E8A6-8845-BD4E-CB4CCA059FC4}" type="datetimeFigureOut">
               <a:rPr lang="en-US" smtClean="0"/>
-              <a:t>8/29/2026</a:t>
+              <a:t>8/30/2026</a:t>
             </a:fld>
             <a:endParaRPr lang="en-US"/>
           </a:p>
@@ -1202,7 +1202,7 @@
           <a:p>
             <a:fld id="{5BCAD085-E8A6-8845-BD4E-CB4CCA059FC4}" type="datetimeFigureOut">
               <a:rPr lang="en-US" smtClean="0"/>
-              <a:t>8/29/2026</a:t>
+              <a:t>8/30/2026</a:t>
             </a:fld>
             <a:endParaRPr lang="en-US"/>
           </a:p>
@@ -1370,7 +1370,7 @@
           <a:p>
             <a:fld id="{5BCAD085-E8A6-8845-BD4E-CB4CCA059FC4}" type="datetimeFigureOut">
               <a:rPr lang="en-US" smtClean="0"/>
-              <a:t>8/29/2026</a:t>
+              <a:t>8/30/2026</a:t>
             </a:fld>
             <a:endParaRPr lang="en-US"/>
           </a:p>
@@ -1615,7 +1615,7 @@
           <a:p>
             <a:fld id="{5BCAD085-E8A6-8845-BD4E-CB4CCA059FC4}" type="datetimeFigureOut">
               <a:rPr lang="en-US" smtClean="0"/>
-              <a:t>8/29/2026</a:t>
+              <a:t>8/30/2026</a:t>
             </a:fld>
             <a:endParaRPr lang="en-US"/>
           </a:p>
@@ -1900,7 +1900,7 @@
           <a:p>
             <a:fld id="{5BCAD085-E8A6-8845-BD4E-CB4CCA059FC4}" type="datetimeFigureOut">
               <a:rPr lang="en-US" smtClean="0"/>
-              <a:t>8/29/2026</a:t>
+              <a:t>8/30/2026</a:t>
             </a:fld>
             <a:endParaRPr lang="en-US"/>
           </a:p>
@@ -2319,7 +2319,7 @@
           <a:p>
             <a:fld id="{5BCAD085-E8A6-8845-BD4E-CB4CCA059FC4}" type="datetimeFigureOut">
               <a:rPr lang="en-US" smtClean="0"/>
-              <a:t>8/29/2026</a:t>
+              <a:t>8/30/2026</a:t>
             </a:fld>
             <a:endParaRPr lang="en-US"/>
           </a:p>
@@ -2436,7 +2436,7 @@
           <a:p>
             <a:fld id="{5BCAD085-E8A6-8845-BD4E-CB4CCA059FC4}" type="datetimeFigureOut">
               <a:rPr lang="en-US" smtClean="0"/>
-              <a:t>8/29/2026</a:t>
+              <a:t>8/30/2026</a:t>
             </a:fld>
             <a:endParaRPr lang="en-US"/>
           </a:p>
@@ -2531,7 +2531,7 @@
           <a:p>
             <a:fld id="{5BCAD085-E8A6-8845-BD4E-CB4CCA059FC4}" type="datetimeFigureOut">
               <a:rPr lang="en-US" smtClean="0"/>
-              <a:t>8/29/2026</a:t>
+              <a:t>8/30/2026</a:t>
             </a:fld>
             <a:endParaRPr lang="en-US"/>
           </a:p>
@@ -2806,7 +2806,7 @@
           <a:p>
             <a:fld id="{5BCAD085-E8A6-8845-BD4E-CB4CCA059FC4}" type="datetimeFigureOut">
               <a:rPr lang="en-US" smtClean="0"/>
-              <a:t>8/29/2026</a:t>
+              <a:t>8/30/2026</a:t>
             </a:fld>
             <a:endParaRPr lang="en-US"/>
           </a:p>
@@ -3058,7 +3058,7 @@
           <a:p>
             <a:fld id="{5BCAD085-E8A6-8845-BD4E-CB4CCA059FC4}" type="datetimeFigureOut">
               <a:rPr lang="en-US" smtClean="0"/>
-              <a:t>8/29/2026</a:t>
+              <a:t>8/30/2026</a:t>
             </a:fld>
             <a:endParaRPr lang="en-US"/>
           </a:p>
@@ -3269,7 +3269,7 @@
           <a:p>
             <a:fld id="{5BCAD085-E8A6-8845-BD4E-CB4CCA059FC4}" type="datetimeFigureOut">
               <a:rPr lang="en-US" smtClean="0"/>
-              <a:t>8/29/2026</a:t>
+              <a:t>8/30/2026</a:t>
             </a:fld>
             <a:endParaRPr lang="en-US"/>
           </a:p>
@@ -5899,7 +5899,7 @@
           <p:nvPr>
             <p:extLst>
               <p:ext uri="{D42A27DB-BD31-4B8C-83A1-F6EECF244321}">
-                <p14:modId xmlns:p14="http://schemas.microsoft.com/office/powerpoint/2010/main" val="3551374924"/>
+                <p14:modId xmlns:p14="http://schemas.microsoft.com/office/powerpoint/2010/main" val="4125843569"/>
               </p:ext>
             </p:extLst>
           </p:nvPr>
@@ -5915,14 +5915,14 @@
                 <a:tableStyleId>{5C22544A-7EE6-4342-B048-85BDC9FD1C3A}</a:tableStyleId>
               </a:tblPr>
               <a:tblGrid>
-                <a:gridCol w="1188720">
+                <a:gridCol w="985313">
                   <a:extLst>
                     <a:ext uri="{9D8B030D-6E8A-4147-A177-3AD203B41FA5}">
                       <a16:colId xmlns:a16="http://schemas.microsoft.com/office/drawing/2014/main" val="20000"/>
                     </a:ext>
                   </a:extLst>
                 </a:gridCol>
-                <a:gridCol w="2377440">
+                <a:gridCol w="2580847">
                   <a:extLst>
                     <a:ext uri="{9D8B030D-6E8A-4147-A177-3AD203B41FA5}">
                       <a16:colId xmlns:a16="http://schemas.microsoft.com/office/drawing/2014/main" val="20001"/>
@@ -5965,10 +5965,24 @@
                         </a:defRPr>
                       </a:pPr>
                       <a:r>
-                        <a:rPr dirty="0" err="1"/>
-                        <a:t>邊界維度</a:t>
+                        <a:rPr sz="1600" dirty="0" err="1"/>
+                        <a:t>邊界</a:t>
                       </a:r>
-                      <a:endParaRPr dirty="0"/>
+                      <a:endParaRPr lang="en-US" sz="1600" dirty="0"/>
+                    </a:p>
+                    <a:p>
+                      <a:pPr algn="ctr">
+                        <a:defRPr sz="1350" b="1">
+                          <a:solidFill>
+                            <a:srgbClr val="38BDF8"/>
+                          </a:solidFill>
+                        </a:defRPr>
+                      </a:pPr>
+                      <a:r>
+                        <a:rPr sz="1600" dirty="0" err="1"/>
+                        <a:t>維度</a:t>
+                      </a:r>
+                      <a:endParaRPr sz="1600" dirty="0"/>
                     </a:p>
                   </a:txBody>
                   <a:tcPr anchor="ctr">
@@ -5990,14 +6004,14 @@
                         </a:defRPr>
                       </a:pPr>
                       <a:r>
-                        <a:rPr dirty="0"/>
-                        <a:t>🧩 DROS </a:t>
+                        <a:rPr sz="1600" dirty="0"/>
+                        <a:t>ROS </a:t>
                       </a:r>
                       <a:r>
-                        <a:rPr dirty="0" err="1"/>
+                        <a:rPr sz="1600" dirty="0" err="1"/>
                         <a:t>關鍵部件名稱</a:t>
                       </a:r>
-                      <a:endParaRPr dirty="0"/>
+                      <a:endParaRPr sz="1600" dirty="0"/>
                     </a:p>
                   </a:txBody>
                   <a:tcPr anchor="ctr">
@@ -6019,18 +6033,18 @@
                         </a:defRPr>
                       </a:pPr>
                       <a:r>
-                        <a:rPr dirty="0" err="1"/>
+                        <a:rPr sz="1600" dirty="0" err="1"/>
                         <a:t>涵蓋的</a:t>
                       </a:r>
                       <a:r>
-                        <a:rPr dirty="0"/>
+                        <a:rPr sz="1600" dirty="0"/>
                         <a:t> 6P </a:t>
                       </a:r>
                       <a:r>
-                        <a:rPr dirty="0" err="1"/>
+                        <a:rPr sz="1600" dirty="0" err="1"/>
                         <a:t>要素</a:t>
                       </a:r>
-                      <a:endParaRPr dirty="0"/>
+                      <a:endParaRPr sz="1600" dirty="0"/>
                     </a:p>
                   </a:txBody>
                   <a:tcPr anchor="ctr">
@@ -6052,10 +6066,10 @@
                         </a:defRPr>
                       </a:pPr>
                       <a:r>
-                        <a:rPr dirty="0" err="1"/>
+                        <a:rPr sz="1600" dirty="0" err="1"/>
                         <a:t>底層技術實現與硬指標</a:t>
                       </a:r>
-                      <a:endParaRPr dirty="0"/>
+                      <a:endParaRPr sz="1600" dirty="0"/>
                     </a:p>
                   </a:txBody>
                   <a:tcPr anchor="ctr">
@@ -6077,10 +6091,10 @@
                         </a:defRPr>
                       </a:pPr>
                       <a:r>
-                        <a:rPr dirty="0" err="1"/>
+                        <a:rPr sz="1600" dirty="0" err="1"/>
                         <a:t>解決的產業痛點</a:t>
                       </a:r>
-                      <a:endParaRPr dirty="0"/>
+                      <a:endParaRPr sz="1600" dirty="0"/>
                     </a:p>
                   </a:txBody>
                   <a:tcPr anchor="ctr">
@@ -6109,7 +6123,7 @@
                         </a:defRPr>
                       </a:pPr>
                       <a:r>
-                        <a:rPr dirty="0"/>
+                        <a:rPr sz="1600" dirty="0"/>
                         <a:t>📥 Ingress</a:t>
                       </a:r>
                     </a:p>
@@ -6133,7 +6147,7 @@
                         </a:defRPr>
                       </a:pPr>
                       <a:r>
-                        <a:rPr dirty="0"/>
+                        <a:rPr sz="1400" dirty="0"/>
                         <a:t>1. Safe Ingress</a:t>
                       </a:r>
                     </a:p>
@@ -6146,7 +6160,7 @@
                         </a:defRPr>
                       </a:pPr>
                       <a:r>
-                        <a:rPr dirty="0"/>
+                        <a:rPr sz="1400" dirty="0"/>
                         <a:t>Data Redactor</a:t>
                       </a:r>
                     </a:p>
@@ -6159,15 +6173,15 @@
                         </a:defRPr>
                       </a:pPr>
                       <a:r>
-                        <a:rPr dirty="0"/>
+                        <a:rPr sz="1400" dirty="0"/>
                         <a:t>(</a:t>
                       </a:r>
                       <a:r>
-                        <a:rPr dirty="0" err="1"/>
+                        <a:rPr sz="1400" dirty="0" err="1"/>
                         <a:t>安全特徵最小化遮蔽器</a:t>
                       </a:r>
                       <a:r>
-                        <a:rPr dirty="0"/>
+                        <a:rPr sz="1400" dirty="0"/>
                         <a:t>)</a:t>
                       </a:r>
                     </a:p>
@@ -6191,7 +6205,7 @@
                         </a:defRPr>
                       </a:pPr>
                       <a:r>
-                        <a:rPr dirty="0"/>
+                        <a:rPr sz="1400" dirty="0"/>
                         <a:t>P4. Policy Gate</a:t>
                       </a:r>
                     </a:p>
@@ -6204,15 +6218,15 @@
                         </a:defRPr>
                       </a:pPr>
                       <a:r>
-                        <a:rPr dirty="0"/>
+                        <a:rPr sz="1400" dirty="0"/>
                         <a:t>(</a:t>
                       </a:r>
                       <a:r>
-                        <a:rPr dirty="0" err="1"/>
+                        <a:rPr sz="1400" dirty="0" err="1"/>
                         <a:t>隱私與最小化</a:t>
                       </a:r>
                       <a:r>
-                        <a:rPr dirty="0"/>
+                        <a:rPr sz="1400" dirty="0"/>
                         <a:t>)</a:t>
                       </a:r>
                     </a:p>
@@ -6236,6 +6250,7 @@
                         </a:defRPr>
                       </a:pPr>
                       <a:r>
+                        <a:rPr sz="1400"/>
                         <a:t>• 動態正則/NER 遮蔽引擎</a:t>
                       </a:r>
                     </a:p>
@@ -6248,6 +6263,7 @@
                         </a:defRPr>
                       </a:pPr>
                       <a:r>
+                        <a:rPr sz="1400"/>
                         <a:t>• ZKP-Lite 零知識證明生成器</a:t>
                       </a:r>
                     </a:p>
@@ -6271,6 +6287,7 @@
                         </a:defRPr>
                       </a:pPr>
                       <a:r>
+                        <a:rPr sz="1400"/>
                         <a:t>杜絕機密洩漏：</a:t>
                       </a:r>
                     </a:p>
@@ -6283,6 +6300,7 @@
                         </a:defRPr>
                       </a:pPr>
                       <a:r>
+                        <a:rPr sz="1400"/>
                         <a:t>醫療 18 項 PHI、製造 BOM 成本、工廠良率進不來 Agent 大腦。</a:t>
                       </a:r>
                     </a:p>
@@ -6313,6 +6331,7 @@
                         </a:defRPr>
                       </a:pPr>
                       <a:r>
+                        <a:rPr sz="1600" dirty="0"/>
                         <a:t>📥 Ingress</a:t>
                       </a:r>
                     </a:p>
@@ -6336,7 +6355,7 @@
                         </a:defRPr>
                       </a:pPr>
                       <a:r>
-                        <a:rPr dirty="0"/>
+                        <a:rPr sz="1400" dirty="0"/>
                         <a:t>2. DIT Token</a:t>
                       </a:r>
                     </a:p>
@@ -6349,7 +6368,7 @@
                         </a:defRPr>
                       </a:pPr>
                       <a:r>
-                        <a:rPr dirty="0"/>
+                        <a:rPr sz="1400" dirty="0"/>
                         <a:t>Principal Injector</a:t>
                       </a:r>
                     </a:p>
@@ -6362,15 +6381,15 @@
                         </a:defRPr>
                       </a:pPr>
                       <a:r>
-                        <a:rPr dirty="0"/>
+                        <a:rPr sz="1400" dirty="0"/>
                         <a:t>(</a:t>
                       </a:r>
                       <a:r>
-                        <a:rPr dirty="0" err="1"/>
+                        <a:rPr sz="1400" dirty="0" err="1"/>
                         <a:t>確定性身分憑證注入器</a:t>
                       </a:r>
                       <a:r>
-                        <a:rPr dirty="0"/>
+                        <a:rPr sz="1400" dirty="0"/>
                         <a:t>)</a:t>
                       </a:r>
                     </a:p>
@@ -6394,15 +6413,31 @@
                         </a:defRPr>
                       </a:pPr>
                       <a:r>
-                        <a:rPr dirty="0"/>
-                        <a:t>P1. Principal (</a:t>
+                        <a:rPr sz="1400" dirty="0"/>
+                        <a:t>P1. Principal </a:t>
                       </a:r>
                       <a:r>
-                        <a:rPr dirty="0" err="1"/>
+                        <a:rPr sz="1400" dirty="0">
+                          <a:solidFill>
+                            <a:schemeClr val="bg1"/>
+                          </a:solidFill>
+                        </a:rPr>
+                        <a:t>(</a:t>
+                      </a:r>
+                      <a:r>
+                        <a:rPr sz="1400" dirty="0" err="1">
+                          <a:solidFill>
+                            <a:schemeClr val="bg1"/>
+                          </a:solidFill>
+                        </a:rPr>
                         <a:t>身分綁定</a:t>
                       </a:r>
                       <a:r>
-                        <a:rPr dirty="0"/>
+                        <a:rPr sz="1400" dirty="0">
+                          <a:solidFill>
+                            <a:schemeClr val="bg1"/>
+                          </a:solidFill>
+                        </a:rPr>
                         <a:t>)</a:t>
                       </a:r>
                     </a:p>
@@ -6415,15 +6450,41 @@
                         </a:defRPr>
                       </a:pPr>
                       <a:r>
-                        <a:rPr dirty="0"/>
-                        <a:t>P2. Authorization (</a:t>
+                        <a:rPr sz="1400" dirty="0"/>
+                        <a:t>P2. Authorization </a:t>
+                      </a:r>
+                      <a:endParaRPr lang="en-US" sz="1400" dirty="0"/>
+                    </a:p>
+                    <a:p>
+                      <a:pPr algn="ctr">
+                        <a:defRPr sz="1200">
+                          <a:solidFill>
+                            <a:srgbClr val="FBBF24"/>
+                          </a:solidFill>
+                        </a:defRPr>
+                      </a:pPr>
+                      <a:r>
+                        <a:rPr sz="1400" dirty="0">
+                          <a:solidFill>
+                            <a:schemeClr val="bg1"/>
+                          </a:solidFill>
+                        </a:rPr>
+                        <a:t>(</a:t>
                       </a:r>
                       <a:r>
-                        <a:rPr dirty="0" err="1"/>
+                        <a:rPr sz="1400" dirty="0" err="1">
+                          <a:solidFill>
+                            <a:schemeClr val="bg1"/>
+                          </a:solidFill>
+                        </a:rPr>
                         <a:t>權限授權</a:t>
                       </a:r>
                       <a:r>
-                        <a:rPr dirty="0"/>
+                        <a:rPr sz="1400" dirty="0">
+                          <a:solidFill>
+                            <a:schemeClr val="bg1"/>
+                          </a:solidFill>
+                        </a:rPr>
                         <a:t>)</a:t>
                       </a:r>
                     </a:p>
@@ -6447,14 +6508,14 @@
                         </a:defRPr>
                       </a:pPr>
                       <a:r>
-                        <a:rPr dirty="0"/>
+                        <a:rPr sz="1400" dirty="0"/>
                         <a:t>• Ed25519 </a:t>
                       </a:r>
                       <a:r>
-                        <a:rPr dirty="0" err="1"/>
+                        <a:rPr sz="1400" dirty="0" err="1"/>
                         <a:t>密碼學簽名</a:t>
                       </a:r>
-                      <a:endParaRPr dirty="0"/>
+                      <a:endParaRPr sz="1400" dirty="0"/>
                     </a:p>
                     <a:p>
                       <a:pPr algn="ctr">
@@ -6465,7 +6526,7 @@
                         </a:defRPr>
                       </a:pPr>
                       <a:r>
-                        <a:rPr dirty="0"/>
+                        <a:rPr sz="1400" dirty="0"/>
                         <a:t>• Zero-Heap Capability Bitmaps</a:t>
                       </a:r>
                     </a:p>
@@ -6489,6 +6550,7 @@
                         </a:defRPr>
                       </a:pPr>
                       <a:r>
+                        <a:rPr sz="1400"/>
                         <a:t>杜絕假冒身分：</a:t>
                       </a:r>
                     </a:p>
@@ -6501,6 +6563,7 @@
                         </a:defRPr>
                       </a:pPr>
                       <a:r>
+                        <a:rPr sz="1400"/>
                         <a:t>強綁定法人 vLEI、自然人 MyData 與 1:1:1 移工防偽。</a:t>
                       </a:r>
                     </a:p>
@@ -6531,6 +6594,7 @@
                         </a:defRPr>
                       </a:pPr>
                       <a:r>
+                        <a:rPr sz="1600" dirty="0"/>
                         <a:t>📤 Egress</a:t>
                       </a:r>
                     </a:p>
@@ -6554,6 +6618,7 @@
                         </a:defRPr>
                       </a:pPr>
                       <a:r>
+                        <a:rPr sz="1400"/>
                         <a:t>3. C-ABI In-Band</a:t>
                       </a:r>
                     </a:p>
@@ -6566,6 +6631,7 @@
                         </a:defRPr>
                       </a:pPr>
                       <a:r>
+                        <a:rPr sz="1400"/>
                         <a:t>Policy Gate</a:t>
                       </a:r>
                     </a:p>
@@ -6578,6 +6644,7 @@
                         </a:defRPr>
                       </a:pPr>
                       <a:r>
+                        <a:rPr sz="1400"/>
                         <a:t>(帶內二進位執行期閘門)</a:t>
                       </a:r>
                     </a:p>
@@ -6601,7 +6668,42 @@
                         </a:defRPr>
                       </a:pPr>
                       <a:r>
-                        <a:t>P2. Authorization (範圍比對)</a:t>
+                        <a:rPr sz="1400" dirty="0"/>
+                        <a:t>P2. Authorization </a:t>
+                      </a:r>
+                      <a:endParaRPr lang="en-US" sz="1400" dirty="0"/>
+                    </a:p>
+                    <a:p>
+                      <a:pPr algn="ctr">
+                        <a:defRPr sz="1200">
+                          <a:solidFill>
+                            <a:srgbClr val="FBBF24"/>
+                          </a:solidFill>
+                        </a:defRPr>
+                      </a:pPr>
+                      <a:r>
+                        <a:rPr sz="1400" dirty="0">
+                          <a:solidFill>
+                            <a:schemeClr val="bg1"/>
+                          </a:solidFill>
+                        </a:rPr>
+                        <a:t>(</a:t>
+                      </a:r>
+                      <a:r>
+                        <a:rPr sz="1400" dirty="0" err="1">
+                          <a:solidFill>
+                            <a:schemeClr val="bg1"/>
+                          </a:solidFill>
+                        </a:rPr>
+                        <a:t>範圍比對</a:t>
+                      </a:r>
+                      <a:r>
+                        <a:rPr sz="1400" dirty="0">
+                          <a:solidFill>
+                            <a:schemeClr val="bg1"/>
+                          </a:solidFill>
+                        </a:rPr>
+                        <a:t>)</a:t>
                       </a:r>
                     </a:p>
                     <a:p>
@@ -6613,7 +6715,42 @@
                         </a:defRPr>
                       </a:pPr>
                       <a:r>
-                        <a:t>P3. Tool Bound (工具硬防線)</a:t>
+                        <a:rPr sz="1400" dirty="0"/>
+                        <a:t>P3. Tool Bound </a:t>
+                      </a:r>
+                      <a:endParaRPr lang="en-US" sz="1400" dirty="0"/>
+                    </a:p>
+                    <a:p>
+                      <a:pPr algn="ctr">
+                        <a:defRPr sz="1200">
+                          <a:solidFill>
+                            <a:srgbClr val="FBBF24"/>
+                          </a:solidFill>
+                        </a:defRPr>
+                      </a:pPr>
+                      <a:r>
+                        <a:rPr sz="1400" dirty="0">
+                          <a:solidFill>
+                            <a:schemeClr val="bg1"/>
+                          </a:solidFill>
+                        </a:rPr>
+                        <a:t>(</a:t>
+                      </a:r>
+                      <a:r>
+                        <a:rPr sz="1400" dirty="0" err="1">
+                          <a:solidFill>
+                            <a:schemeClr val="bg1"/>
+                          </a:solidFill>
+                        </a:rPr>
+                        <a:t>工具硬防線</a:t>
+                      </a:r>
+                      <a:r>
+                        <a:rPr sz="1400" dirty="0">
+                          <a:solidFill>
+                            <a:schemeClr val="bg1"/>
+                          </a:solidFill>
+                        </a:rPr>
+                        <a:t>)</a:t>
                       </a:r>
                     </a:p>
                   </a:txBody>
@@ -6636,30 +6773,30 @@
                         </a:defRPr>
                       </a:pPr>
                       <a:r>
-                        <a:rPr dirty="0"/>
+                        <a:rPr sz="1400" dirty="0"/>
                         <a:t>• 26.1 </a:t>
                       </a:r>
                       <a:r>
-                        <a:rPr dirty="0" err="1"/>
+                        <a:rPr sz="1400" dirty="0" err="1"/>
                         <a:t>μs</a:t>
                       </a:r>
                       <a:r>
-                        <a:rPr dirty="0"/>
+                        <a:rPr sz="1400" dirty="0"/>
                         <a:t> </a:t>
                       </a:r>
                       <a:r>
-                        <a:rPr dirty="0" err="1"/>
+                        <a:rPr sz="1400" dirty="0" err="1"/>
                         <a:t>二進位</a:t>
                       </a:r>
                       <a:r>
-                        <a:rPr dirty="0"/>
+                        <a:rPr sz="1400" dirty="0"/>
                         <a:t> C </a:t>
                       </a:r>
                       <a:r>
-                        <a:rPr dirty="0" err="1"/>
+                        <a:rPr sz="1400" dirty="0" err="1"/>
                         <a:t>介面呼叫</a:t>
                       </a:r>
-                      <a:endParaRPr dirty="0"/>
+                      <a:endParaRPr sz="1400" dirty="0"/>
                     </a:p>
                     <a:p>
                       <a:pPr algn="ctr">
@@ -6670,22 +6807,22 @@
                         </a:defRPr>
                       </a:pPr>
                       <a:r>
-                        <a:rPr dirty="0"/>
+                        <a:rPr sz="1400" dirty="0"/>
                         <a:t>• </a:t>
                       </a:r>
                       <a:r>
-                        <a:rPr dirty="0" err="1"/>
+                        <a:rPr sz="1400" dirty="0" err="1"/>
                         <a:t>暫存器級位元比對</a:t>
                       </a:r>
                       <a:r>
-                        <a:rPr dirty="0"/>
+                        <a:rPr sz="1400" dirty="0"/>
                         <a:t> + 403 </a:t>
                       </a:r>
                       <a:r>
-                        <a:rPr dirty="0" err="1"/>
+                        <a:rPr sz="1400" dirty="0" err="1"/>
                         <a:t>熔斷</a:t>
                       </a:r>
-                      <a:endParaRPr dirty="0"/>
+                      <a:endParaRPr sz="1400" dirty="0"/>
                     </a:p>
                   </a:txBody>
                   <a:tcPr anchor="ctr">
@@ -6707,11 +6844,11 @@
                         </a:defRPr>
                       </a:pPr>
                       <a:r>
-                        <a:rPr dirty="0" err="1"/>
+                        <a:rPr sz="1400" dirty="0" err="1"/>
                         <a:t>杜絕越權動作</a:t>
                       </a:r>
                       <a:r>
-                        <a:rPr dirty="0"/>
+                        <a:rPr sz="1400" dirty="0"/>
                         <a:t>：</a:t>
                       </a:r>
                     </a:p>
@@ -6724,23 +6861,23 @@
                         </a:defRPr>
                       </a:pPr>
                       <a:r>
-                        <a:rPr dirty="0"/>
+                        <a:rPr sz="1400" dirty="0"/>
                         <a:t>Agent 被 Prompt Injection </a:t>
                       </a:r>
                       <a:r>
-                        <a:rPr dirty="0" err="1"/>
+                        <a:rPr sz="1400" dirty="0" err="1"/>
                         <a:t>催眠想偷查戶籍</a:t>
                       </a:r>
                       <a:r>
-                        <a:rPr dirty="0"/>
+                        <a:rPr sz="1400" dirty="0"/>
                         <a:t>/</a:t>
                       </a:r>
                       <a:r>
-                        <a:rPr dirty="0" err="1"/>
+                        <a:rPr sz="1400" dirty="0" err="1"/>
                         <a:t>轉帳，在呼叫鏈被物理斷開</a:t>
                       </a:r>
                       <a:r>
-                        <a:rPr dirty="0"/>
+                        <a:rPr sz="1400" dirty="0"/>
                         <a:t>。</a:t>
                       </a:r>
                     </a:p>
@@ -6771,6 +6908,7 @@
                         </a:defRPr>
                       </a:pPr>
                       <a:r>
+                        <a:rPr sz="1600" dirty="0"/>
                         <a:t>📤 Egress</a:t>
                       </a:r>
                     </a:p>
@@ -6794,6 +6932,7 @@
                         </a:defRPr>
                       </a:pPr>
                       <a:r>
+                        <a:rPr sz="1400"/>
                         <a:t>4. Merkle Chain &amp;</a:t>
                       </a:r>
                     </a:p>
@@ -6806,6 +6945,7 @@
                         </a:defRPr>
                       </a:pPr>
                       <a:r>
+                        <a:rPr sz="1400"/>
                         <a:t>RCU Revocation</a:t>
                       </a:r>
                     </a:p>
@@ -6818,6 +6958,7 @@
                         </a:defRPr>
                       </a:pPr>
                       <a:r>
+                        <a:rPr sz="1400"/>
                         <a:t>(密碼學存證與秒級撤銷內核)</a:t>
                       </a:r>
                     </a:p>
@@ -6841,7 +6982,42 @@
                         </a:defRPr>
                       </a:pPr>
                       <a:r>
-                        <a:t>P5. Audit Log (防篡改日誌)</a:t>
+                        <a:rPr sz="1400" dirty="0"/>
+                        <a:t>P5. Audit Log</a:t>
+                      </a:r>
+                      <a:endParaRPr lang="en-US" sz="1400" dirty="0"/>
+                    </a:p>
+                    <a:p>
+                      <a:pPr algn="ctr">
+                        <a:defRPr sz="1200">
+                          <a:solidFill>
+                            <a:srgbClr val="FBBF24"/>
+                          </a:solidFill>
+                        </a:defRPr>
+                      </a:pPr>
+                      <a:r>
+                        <a:rPr sz="1400" dirty="0">
+                          <a:solidFill>
+                            <a:schemeClr val="bg1"/>
+                          </a:solidFill>
+                        </a:rPr>
+                        <a:t> (</a:t>
+                      </a:r>
+                      <a:r>
+                        <a:rPr sz="1400" dirty="0" err="1">
+                          <a:solidFill>
+                            <a:schemeClr val="bg1"/>
+                          </a:solidFill>
+                        </a:rPr>
+                        <a:t>防篡改日誌</a:t>
+                      </a:r>
+                      <a:r>
+                        <a:rPr sz="1400" dirty="0">
+                          <a:solidFill>
+                            <a:schemeClr val="bg1"/>
+                          </a:solidFill>
+                        </a:rPr>
+                        <a:t>)</a:t>
                       </a:r>
                     </a:p>
                     <a:p>
@@ -6853,7 +7029,42 @@
                         </a:defRPr>
                       </a:pPr>
                       <a:r>
-                        <a:t>P6. Revocation (即時動態撤銷)</a:t>
+                        <a:rPr sz="1400" dirty="0"/>
+                        <a:t>P6. Revocation </a:t>
+                      </a:r>
+                      <a:endParaRPr lang="en-US" sz="1400" dirty="0"/>
+                    </a:p>
+                    <a:p>
+                      <a:pPr algn="ctr">
+                        <a:defRPr sz="1200">
+                          <a:solidFill>
+                            <a:srgbClr val="FBBF24"/>
+                          </a:solidFill>
+                        </a:defRPr>
+                      </a:pPr>
+                      <a:r>
+                        <a:rPr sz="1400" dirty="0">
+                          <a:solidFill>
+                            <a:schemeClr val="bg1"/>
+                          </a:solidFill>
+                        </a:rPr>
+                        <a:t>(</a:t>
+                      </a:r>
+                      <a:r>
+                        <a:rPr sz="1400" dirty="0" err="1">
+                          <a:solidFill>
+                            <a:schemeClr val="bg1"/>
+                          </a:solidFill>
+                        </a:rPr>
+                        <a:t>即時動態撤銷</a:t>
+                      </a:r>
+                      <a:r>
+                        <a:rPr sz="1400" dirty="0">
+                          <a:solidFill>
+                            <a:schemeClr val="bg1"/>
+                          </a:solidFill>
+                        </a:rPr>
+                        <a:t>)</a:t>
                       </a:r>
                     </a:p>
                   </a:txBody>
@@ -6876,6 +7087,7 @@
                         </a:defRPr>
                       </a:pPr>
                       <a:r>
+                        <a:rPr sz="1400"/>
                         <a:t>• SHA-256 前後哈希鏈結收據</a:t>
                       </a:r>
                     </a:p>
@@ -6888,6 +7100,7 @@
                         </a:defRPr>
                       </a:pPr>
                       <a:r>
+                        <a:rPr sz="1400"/>
                         <a:t>• O(1) 常數時間 RCU 原子指針</a:t>
                       </a:r>
                     </a:p>
@@ -6911,11 +7124,11 @@
                         </a:defRPr>
                       </a:pPr>
                       <a:r>
-                        <a:rPr dirty="0" err="1"/>
+                        <a:rPr sz="1400" dirty="0" err="1"/>
                         <a:t>杜絕無法問責與偷跑</a:t>
                       </a:r>
                       <a:r>
-                        <a:rPr dirty="0"/>
+                        <a:rPr sz="1400" dirty="0"/>
                         <a:t>：</a:t>
                       </a:r>
                     </a:p>
@@ -6928,19 +7141,19 @@
                         </a:defRPr>
                       </a:pPr>
                       <a:r>
-                        <a:rPr dirty="0" err="1"/>
+                        <a:rPr sz="1400" dirty="0" err="1"/>
                         <a:t>產出具備法庭採信力的</a:t>
                       </a:r>
                       <a:r>
-                        <a:rPr dirty="0"/>
+                        <a:rPr sz="1400" dirty="0"/>
                         <a:t> Cert </a:t>
                       </a:r>
                       <a:r>
-                        <a:rPr dirty="0" err="1"/>
+                        <a:rPr sz="1400" dirty="0" err="1"/>
                         <a:t>收據；管理員一鍵凍結權限秒級生效</a:t>
                       </a:r>
                       <a:r>
-                        <a:rPr dirty="0"/>
+                        <a:rPr sz="1400" dirty="0"/>
                         <a:t>。</a:t>
                       </a:r>
                     </a:p>
@@ -9086,7 +9299,7 @@
         </p:nvSpPr>
         <p:spPr>
           <a:xfrm>
-            <a:off x="731520" y="1280160"/>
+            <a:off x="731520" y="1520296"/>
             <a:ext cx="5212080" cy="1554480"/>
           </a:xfrm>
           <a:prstGeom prst="roundRect">
@@ -9154,11 +9367,25 @@
             </a:r>
             <a:r>
               <a:rPr sz="1400" dirty="0"/>
-              <a:t> </a:t>
+              <a:t> Redact：</a:t>
+            </a:r>
+            <a:endParaRPr lang="en-US" sz="1400" dirty="0"/>
+          </a:p>
+          <a:p>
+            <a:pPr>
+              <a:defRPr sz="1100">
+                <a:solidFill>
+                  <a:srgbClr val="F8FAFC"/>
+                </a:solidFill>
+              </a:defRPr>
+            </a:pPr>
+            <a:r>
+              <a:rPr lang="en-US" sz="1400" dirty="0"/>
+              <a:t>                   </a:t>
             </a:r>
             <a:r>
               <a:rPr sz="1400" dirty="0" err="1"/>
-              <a:t>Redact：隔離</a:t>
+              <a:t>隔離</a:t>
             </a:r>
             <a:r>
               <a:rPr sz="1400" dirty="0"/>
@@ -9195,7 +9422,29 @@
             </a:r>
             <a:r>
               <a:rPr sz="1400" dirty="0" err="1"/>
-              <a:t>門閥：輸出機密瞬間熔斷，僅放行</a:t>
+              <a:t>門閥</a:t>
+            </a:r>
+            <a:r>
+              <a:rPr sz="1400" dirty="0"/>
+              <a:t>：</a:t>
+            </a:r>
+            <a:endParaRPr lang="en-US" sz="1400" dirty="0"/>
+          </a:p>
+          <a:p>
+            <a:pPr>
+              <a:defRPr sz="1100">
+                <a:solidFill>
+                  <a:srgbClr val="CBD5E1"/>
+                </a:solidFill>
+              </a:defRPr>
+            </a:pPr>
+            <a:r>
+              <a:rPr lang="en-US" sz="1400" dirty="0"/>
+              <a:t>                   </a:t>
+            </a:r>
+            <a:r>
+              <a:rPr sz="1400" dirty="0" err="1"/>
+              <a:t>輸出機密瞬間熔斷，僅放行</a:t>
             </a:r>
             <a:r>
               <a:rPr sz="1400" dirty="0"/>
@@ -9220,7 +9469,7 @@
         </p:nvSpPr>
         <p:spPr>
           <a:xfrm>
-            <a:off x="6248095" y="1280160"/>
+            <a:off x="6248095" y="1520296"/>
             <a:ext cx="5212080" cy="1554480"/>
           </a:xfrm>
           <a:prstGeom prst="roundRect">
@@ -9292,7 +9541,29 @@
             </a:r>
             <a:r>
               <a:rPr sz="1400" dirty="0" err="1"/>
-              <a:t>去識別化密態特徵：遮蔽姓名</a:t>
+              <a:t>去識別化密態特徵</a:t>
+            </a:r>
+            <a:r>
+              <a:rPr sz="1400" dirty="0"/>
+              <a:t>：</a:t>
+            </a:r>
+            <a:endParaRPr lang="en-US" sz="1400" dirty="0"/>
+          </a:p>
+          <a:p>
+            <a:pPr>
+              <a:defRPr sz="1100">
+                <a:solidFill>
+                  <a:srgbClr val="F8FAFC"/>
+                </a:solidFill>
+              </a:defRPr>
+            </a:pPr>
+            <a:r>
+              <a:rPr lang="en-US" sz="1400" dirty="0"/>
+              <a:t>                   </a:t>
+            </a:r>
+            <a:r>
+              <a:rPr sz="1400" dirty="0" err="1"/>
+              <a:t>遮蔽姓名</a:t>
             </a:r>
             <a:r>
               <a:rPr sz="1400" dirty="0"/>
@@ -9329,7 +9600,29 @@
             </a:r>
             <a:r>
               <a:rPr sz="1400" dirty="0" err="1"/>
-              <a:t>微秒支付阻斷：洗錢特徵瞬間</a:t>
+              <a:t>微秒支付阻斷</a:t>
+            </a:r>
+            <a:r>
+              <a:rPr sz="1400" dirty="0"/>
+              <a:t>：</a:t>
+            </a:r>
+            <a:endParaRPr lang="en-US" sz="1400" dirty="0"/>
+          </a:p>
+          <a:p>
+            <a:pPr>
+              <a:defRPr sz="1100">
+                <a:solidFill>
+                  <a:srgbClr val="CBD5E1"/>
+                </a:solidFill>
+              </a:defRPr>
+            </a:pPr>
+            <a:r>
+              <a:rPr lang="en-US" sz="1400" dirty="0"/>
+              <a:t>                   </a:t>
+            </a:r>
+            <a:r>
+              <a:rPr sz="1400" dirty="0" err="1"/>
+              <a:t>洗錢特徵瞬間</a:t>
             </a:r>
             <a:r>
               <a:rPr sz="1400" dirty="0"/>
@@ -9354,7 +9647,7 @@
         </p:nvSpPr>
         <p:spPr>
           <a:xfrm>
-            <a:off x="731520" y="2971800"/>
+            <a:off x="731520" y="3211936"/>
             <a:ext cx="5212080" cy="1554480"/>
           </a:xfrm>
           <a:prstGeom prst="roundRect">
@@ -9418,7 +9711,29 @@
             </a:r>
             <a:r>
               <a:rPr sz="1400" dirty="0" err="1"/>
-              <a:t>自動遮蔽：病歷與基因嚴密隔離，輸入診斷碼</a:t>
+              <a:t>自動遮蔽</a:t>
+            </a:r>
+            <a:r>
+              <a:rPr sz="1400" dirty="0"/>
+              <a:t>：</a:t>
+            </a:r>
+            <a:endParaRPr lang="en-US" sz="1400" dirty="0"/>
+          </a:p>
+          <a:p>
+            <a:pPr>
+              <a:defRPr sz="1100">
+                <a:solidFill>
+                  <a:srgbClr val="F8FAFC"/>
+                </a:solidFill>
+              </a:defRPr>
+            </a:pPr>
+            <a:r>
+              <a:rPr lang="en-US" sz="1400" dirty="0"/>
+              <a:t>                   </a:t>
+            </a:r>
+            <a:r>
+              <a:rPr sz="1400" dirty="0" err="1"/>
+              <a:t>病歷與基因嚴密隔離，輸入診斷碼</a:t>
             </a:r>
             <a:r>
               <a:rPr sz="1400" dirty="0"/>
@@ -9447,7 +9762,29 @@
             </a:r>
             <a:r>
               <a:rPr sz="1400" dirty="0" err="1"/>
-              <a:t>保險聯盟鏈對接：越權調閱</a:t>
+              <a:t>保險聯盟鏈對接</a:t>
+            </a:r>
+            <a:r>
+              <a:rPr sz="1400" dirty="0"/>
+              <a:t>：</a:t>
+            </a:r>
+            <a:endParaRPr lang="en-US" sz="1400" dirty="0"/>
+          </a:p>
+          <a:p>
+            <a:pPr>
+              <a:defRPr sz="1100">
+                <a:solidFill>
+                  <a:srgbClr val="CBD5E1"/>
+                </a:solidFill>
+              </a:defRPr>
+            </a:pPr>
+            <a:r>
+              <a:rPr lang="en-US" sz="1400" dirty="0"/>
+              <a:t>                   </a:t>
+            </a:r>
+            <a:r>
+              <a:rPr sz="1400" dirty="0" err="1"/>
+              <a:t>越權調閱</a:t>
             </a:r>
             <a:r>
               <a:rPr sz="1400" dirty="0"/>
@@ -9472,7 +9809,7 @@
         </p:nvSpPr>
         <p:spPr>
           <a:xfrm>
-            <a:off x="6248095" y="2971800"/>
+            <a:off x="6248095" y="3211936"/>
             <a:ext cx="5212080" cy="1554480"/>
           </a:xfrm>
           <a:prstGeom prst="roundRect">
@@ -9536,7 +9873,29 @@
             </a:r>
             <a:r>
               <a:rPr sz="1400" dirty="0" err="1"/>
-              <a:t>三層代理過濾：事務所</a:t>
+              <a:t>三層代理過濾</a:t>
+            </a:r>
+            <a:r>
+              <a:rPr sz="1400" dirty="0"/>
+              <a:t>：</a:t>
+            </a:r>
+            <a:endParaRPr lang="en-US" sz="1400" dirty="0"/>
+          </a:p>
+          <a:p>
+            <a:pPr>
+              <a:defRPr sz="1100">
+                <a:solidFill>
+                  <a:srgbClr val="F8FAFC"/>
+                </a:solidFill>
+              </a:defRPr>
+            </a:pPr>
+            <a:r>
+              <a:rPr lang="en-US" sz="1400" dirty="0"/>
+              <a:t>                    </a:t>
+            </a:r>
+            <a:r>
+              <a:rPr sz="1400" dirty="0" err="1"/>
+              <a:t>事務所</a:t>
             </a:r>
             <a:r>
               <a:rPr sz="1400" dirty="0"/>
@@ -9573,7 +9932,29 @@
             </a:r>
             <a:r>
               <a:rPr sz="1400" dirty="0" err="1"/>
-              <a:t>代送件越權阻斷：越權調閱戶政瞬間攔截，出具</a:t>
+              <a:t>代送件越權阻斷</a:t>
+            </a:r>
+            <a:r>
+              <a:rPr sz="1400" dirty="0"/>
+              <a:t>：</a:t>
+            </a:r>
+            <a:endParaRPr lang="en-US" sz="1400" dirty="0"/>
+          </a:p>
+          <a:p>
+            <a:pPr>
+              <a:defRPr sz="1100">
+                <a:solidFill>
+                  <a:srgbClr val="CBD5E1"/>
+                </a:solidFill>
+              </a:defRPr>
+            </a:pPr>
+            <a:r>
+              <a:rPr lang="en-US" sz="1400" dirty="0"/>
+              <a:t>                    </a:t>
+            </a:r>
+            <a:r>
+              <a:rPr sz="1400" dirty="0" err="1"/>
+              <a:t>越權調閱戶政瞬間攔截，出具</a:t>
             </a:r>
             <a:r>
               <a:rPr sz="1400" dirty="0"/>
@@ -9598,7 +9979,7 @@
         </p:nvSpPr>
         <p:spPr>
           <a:xfrm>
-            <a:off x="731520" y="4663440"/>
+            <a:off x="731520" y="4903576"/>
             <a:ext cx="5212080" cy="1554480"/>
           </a:xfrm>
           <a:prstGeom prst="roundRect">
@@ -9662,7 +10043,29 @@
             </a:r>
             <a:r>
               <a:rPr sz="1400" dirty="0" err="1"/>
-              <a:t>複合身分綁定：護照+居留證+門號為</a:t>
+              <a:t>複合身分綁定</a:t>
+            </a:r>
+            <a:r>
+              <a:rPr sz="1400" dirty="0"/>
+              <a:t>：</a:t>
+            </a:r>
+            <a:endParaRPr lang="en-US" sz="1400" dirty="0"/>
+          </a:p>
+          <a:p>
+            <a:pPr>
+              <a:defRPr sz="1100">
+                <a:solidFill>
+                  <a:srgbClr val="F8FAFC"/>
+                </a:solidFill>
+              </a:defRPr>
+            </a:pPr>
+            <a:r>
+              <a:rPr lang="en-US" sz="1400" dirty="0"/>
+              <a:t>                   </a:t>
+            </a:r>
+            <a:r>
+              <a:rPr sz="1400" dirty="0" err="1"/>
+              <a:t>護照+居留證+門號為</a:t>
             </a:r>
             <a:r>
               <a:rPr sz="1400" dirty="0"/>
@@ -9691,7 +10094,29 @@
             </a:r>
             <a:r>
               <a:rPr sz="1400" dirty="0" err="1"/>
-              <a:t>連鎖凍結：換卡</a:t>
+              <a:t>連鎖凍結</a:t>
+            </a:r>
+            <a:r>
+              <a:rPr sz="1400" dirty="0"/>
+              <a:t>：</a:t>
+            </a:r>
+            <a:endParaRPr lang="en-US" sz="1400" dirty="0"/>
+          </a:p>
+          <a:p>
+            <a:pPr>
+              <a:defRPr sz="1100">
+                <a:solidFill>
+                  <a:srgbClr val="CBD5E1"/>
+                </a:solidFill>
+              </a:defRPr>
+            </a:pPr>
+            <a:r>
+              <a:rPr lang="en-US" sz="1400" dirty="0"/>
+              <a:t>                   </a:t>
+            </a:r>
+            <a:r>
+              <a:rPr sz="1400" dirty="0" err="1"/>
+              <a:t>換卡</a:t>
             </a:r>
             <a:r>
               <a:rPr sz="1400" dirty="0"/>
@@ -9724,7 +10149,7 @@
         </p:nvSpPr>
         <p:spPr>
           <a:xfrm>
-            <a:off x="6248095" y="4663440"/>
+            <a:off x="6248095" y="4903576"/>
             <a:ext cx="5212080" cy="1554480"/>
           </a:xfrm>
           <a:prstGeom prst="roundRect">
@@ -9800,11 +10225,25 @@
             </a:r>
             <a:r>
               <a:rPr sz="1400" dirty="0"/>
-              <a:t> </a:t>
+              <a:t> ZKP-Lite：</a:t>
+            </a:r>
+            <a:endParaRPr lang="en-US" sz="1400" dirty="0"/>
+          </a:p>
+          <a:p>
+            <a:pPr>
+              <a:defRPr sz="1100">
+                <a:solidFill>
+                  <a:srgbClr val="F8FAFC"/>
+                </a:solidFill>
+              </a:defRPr>
+            </a:pPr>
+            <a:r>
+              <a:rPr lang="en-US" sz="1400" dirty="0"/>
+              <a:t>                   </a:t>
             </a:r>
             <a:r>
               <a:rPr sz="1400" dirty="0" err="1"/>
-              <a:t>ZKP-Lite：採購</a:t>
+              <a:t>採購</a:t>
             </a:r>
             <a:r>
               <a:rPr sz="1400" dirty="0"/>
@@ -9841,7 +10280,29 @@
             </a:r>
             <a:r>
               <a:rPr sz="1400" dirty="0" err="1"/>
-              <a:t>雇主付費存證：物理鎖定採購</a:t>
+              <a:t>雇主付費存證</a:t>
+            </a:r>
+            <a:r>
+              <a:rPr sz="1400" dirty="0"/>
+              <a:t>：</a:t>
+            </a:r>
+            <a:endParaRPr lang="en-US" sz="1400" dirty="0"/>
+          </a:p>
+          <a:p>
+            <a:pPr>
+              <a:defRPr sz="1100">
+                <a:solidFill>
+                  <a:srgbClr val="CBD5E1"/>
+                </a:solidFill>
+              </a:defRPr>
+            </a:pPr>
+            <a:r>
+              <a:rPr lang="en-US" sz="1400" dirty="0"/>
+              <a:t>                   </a:t>
+            </a:r>
+            <a:r>
+              <a:rPr sz="1400" dirty="0" err="1"/>
+              <a:t>物理鎖定採購</a:t>
             </a:r>
             <a:r>
               <a:rPr sz="1400" dirty="0"/>
@@ -9855,6 +10316,59 @@
               <a:rPr sz="1400" dirty="0"/>
               <a:t>。</a:t>
             </a:r>
+          </a:p>
+        </p:txBody>
+      </p:sp>
+      <p:sp>
+        <p:nvSpPr>
+          <p:cNvPr id="10" name="文字方塊 9">
+            <a:extLst>
+              <a:ext uri="{FF2B5EF4-FFF2-40B4-BE49-F238E27FC236}">
+                <a16:creationId xmlns:a16="http://schemas.microsoft.com/office/drawing/2014/main" id="{DA92601C-7350-A44F-2337-75E4A67804D1}"/>
+              </a:ext>
+            </a:extLst>
+          </p:cNvPr>
+          <p:cNvSpPr txBox="1"/>
+          <p:nvPr/>
+        </p:nvSpPr>
+        <p:spPr>
+          <a:xfrm>
+            <a:off x="831273" y="1043710"/>
+            <a:ext cx="10400145" cy="369332"/>
+          </a:xfrm>
+          <a:prstGeom prst="rect">
+            <a:avLst/>
+          </a:prstGeom>
+          <a:noFill/>
+        </p:spPr>
+        <p:txBody>
+          <a:bodyPr wrap="square" rtlCol="0">
+            <a:spAutoFit/>
+          </a:bodyPr>
+          <a:lstStyle/>
+          <a:p>
+            <a:r>
+              <a:rPr lang="zh-TW" altLang="en-US" b="1" dirty="0">
+                <a:solidFill>
+                  <a:schemeClr val="bg1"/>
+                </a:solidFill>
+              </a:rPr>
+              <a:t>六大產業題解：</a:t>
+            </a:r>
+            <a:r>
+              <a:rPr lang="en-US" altLang="zh-TW" b="1" dirty="0">
+                <a:solidFill>
+                  <a:schemeClr val="bg1"/>
+                </a:solidFill>
+                <a:hlinkClick r:id="rId2"/>
+              </a:rPr>
+              <a:t>https://github.com/Top-Celestial-Company-Ltd/DROS-Hackathon-Showcase</a:t>
+            </a:r>
+            <a:endParaRPr lang="zh-TW" altLang="en-US" b="1" dirty="0">
+              <a:solidFill>
+                <a:schemeClr val="bg1"/>
+              </a:solidFill>
+            </a:endParaRPr>
           </a:p>
         </p:txBody>
       </p:sp>
@@ -10383,8 +10897,12 @@
               </a:defRPr>
             </a:pPr>
             <a:r>
-              <a:rPr dirty="0"/>
-              <a:t>   github.com/Top-Celestial-Company-Ltd/DROS-Hackathon-Showcase</a:t>
+              <a:rPr lang="en-US" dirty="0"/>
+              <a:t>https://</a:t>
+            </a:r>
+            <a:r>
+              <a:rPr dirty="0"/>
+              <a:t>github.com/Top-Celestial-Company-Ltd/DROS-Hackathon-Showcase</a:t>
             </a:r>
             <a:endParaRPr lang="en-US" dirty="0"/>
           </a:p>
@@ -10425,8 +10943,12 @@
               </a:defRPr>
             </a:pPr>
             <a:r>
-              <a:rPr dirty="0"/>
-              <a:t>   github.com/Top-Celestial-Company-Ltd/DROS-VEP-lite (0.001s PASS)</a:t>
+              <a:rPr lang="en-US" dirty="0"/>
+              <a:t>https://</a:t>
+            </a:r>
+            <a:r>
+              <a:rPr dirty="0"/>
+              <a:t>github.com/Top-Celestial-Company-Ltd/DROS-VEP-lite (0.001s PASS)</a:t>
             </a:r>
             <a:endParaRPr lang="en-US" dirty="0"/>
           </a:p>
@@ -10553,16 +11075,76 @@
               </a:defRPr>
             </a:pPr>
             <a:r>
-              <a:rPr dirty="0"/>
-              <a:t>• 🔒 </a:t>
-            </a:r>
-            <a:r>
-              <a:rPr dirty="0" err="1"/>
-              <a:t>美國臨時專利保護</a:t>
-            </a:r>
-            <a:r>
-              <a:rPr dirty="0"/>
-              <a:t> (Patent Pending)</a:t>
+              <a:rPr dirty="0">
+                <a:solidFill>
+                  <a:srgbClr val="FFC000"/>
+                </a:solidFill>
+              </a:rPr>
+              <a:t>•  </a:t>
+            </a:r>
+            <a:r>
+              <a:rPr lang="en-US" dirty="0">
+                <a:solidFill>
+                  <a:srgbClr val="FFC000"/>
+                </a:solidFill>
+              </a:rPr>
+              <a:t>DROS-</a:t>
+            </a:r>
+            <a:r>
+              <a:rPr lang="en-US" dirty="0" err="1">
+                <a:solidFill>
+                  <a:srgbClr val="FFC000"/>
+                </a:solidFill>
+              </a:rPr>
+              <a:t>VajraClaw</a:t>
+            </a:r>
+            <a:r>
+              <a:rPr lang="en-US" dirty="0">
+                <a:solidFill>
+                  <a:srgbClr val="FFC000"/>
+                </a:solidFill>
+              </a:rPr>
+              <a:t>-Hacker </a:t>
+            </a:r>
+            <a:r>
+              <a:rPr dirty="0">
+                <a:solidFill>
+                  <a:srgbClr val="FFC000"/>
+                </a:solidFill>
+              </a:rPr>
+              <a:t>(</a:t>
+            </a:r>
+            <a:r>
+              <a:rPr lang="zh-TW" altLang="en-US" dirty="0">
+                <a:solidFill>
+                  <a:srgbClr val="FFC000"/>
+                </a:solidFill>
+              </a:rPr>
+              <a:t>微核心</a:t>
+            </a:r>
+            <a:r>
+              <a:rPr lang="en-US" altLang="zh-TW" dirty="0">
+                <a:solidFill>
+                  <a:srgbClr val="FFC000"/>
+                </a:solidFill>
+              </a:rPr>
+              <a:t>Docker</a:t>
+            </a:r>
+            <a:r>
+              <a:rPr lang="zh-TW" altLang="en-US" dirty="0">
+                <a:solidFill>
+                  <a:srgbClr val="FFC000"/>
+                </a:solidFill>
+              </a:rPr>
+              <a:t>版</a:t>
+            </a:r>
+            <a:r>
+              <a:rPr dirty="0">
+                <a:solidFill>
+                  <a:srgbClr val="FFC000"/>
+                </a:solidFill>
+              </a:rPr>
+              <a:t>)</a:t>
             </a:r>
           </a:p>
           <a:p>
@@ -10574,9 +11156,10 @@
               </a:defRPr>
             </a:pPr>
             <a:r>
-              <a:rPr dirty="0"/>
-              <a:t>   U.S. Provisional Patent Application No. 64/111,973</a:t>
-            </a:r>
+              <a:rPr lang="en-US" dirty="0"/>
+              <a:t>https://github.com/Top-Celestial-Company-Ltd/DROS-VajraClaw-Hacker</a:t>
+            </a:r>
+            <a:endParaRPr dirty="0"/>
           </a:p>
         </p:txBody>
       </p:sp>
@@ -10739,6 +11322,7 @@
               </a:defRPr>
             </a:pPr>
             <a:r>
+              <a:rPr dirty="0"/>
               <a:t>● ARCHITECTURE MAP</a:t>
             </a:r>
           </a:p>
@@ -10751,8 +11335,18 @@
               </a:defRPr>
             </a:pPr>
             <a:r>
-              <a:t>OpenShip × Multi-VEP 全景技術架構與現實信任接軌</a:t>
-            </a:r>
+              <a:rPr dirty="0" err="1"/>
+              <a:t>OpenShip</a:t>
+            </a:r>
+            <a:r>
+              <a:rPr dirty="0"/>
+              <a:t> × Multi-VEP </a:t>
+            </a:r>
+            <a:r>
+              <a:rPr dirty="0" err="1"/>
+              <a:t>全景技術架構與現實信任接軌</a:t>
+            </a:r>
+            <a:endParaRPr dirty="0"/>
           </a:p>
         </p:txBody>
       </p:sp>
@@ -10764,8 +11358,8 @@
         </p:nvSpPr>
         <p:spPr>
           <a:xfrm>
-            <a:off x="731520" y="1219195"/>
-            <a:ext cx="10728655" cy="1948873"/>
+            <a:off x="731520" y="1054359"/>
+            <a:ext cx="10728655" cy="2052735"/>
           </a:xfrm>
           <a:prstGeom prst="roundRect">
             <a:avLst/>
@@ -10837,42 +11431,42 @@
               </a:defRPr>
             </a:pPr>
             <a:r>
-              <a:rPr dirty="0"/>
+              <a:rPr sz="1600" dirty="0"/>
               <a:t>• </a:t>
             </a:r>
             <a:r>
-              <a:rPr dirty="0" err="1"/>
+              <a:rPr sz="1600" dirty="0" err="1"/>
               <a:t>法人端：GLEIF</a:t>
             </a:r>
             <a:r>
-              <a:rPr dirty="0"/>
+              <a:rPr sz="1600" dirty="0"/>
               <a:t> </a:t>
             </a:r>
             <a:r>
-              <a:rPr dirty="0" err="1"/>
+              <a:rPr sz="1600" dirty="0" err="1"/>
               <a:t>國際組織</a:t>
             </a:r>
             <a:r>
-              <a:rPr dirty="0"/>
+              <a:rPr sz="1600" dirty="0"/>
               <a:t> </a:t>
             </a:r>
             <a:r>
-              <a:rPr dirty="0" err="1"/>
+              <a:rPr sz="1600" dirty="0" err="1"/>
               <a:t>vLEI</a:t>
             </a:r>
             <a:r>
-              <a:rPr dirty="0"/>
+              <a:rPr sz="1600" dirty="0"/>
               <a:t> </a:t>
             </a:r>
             <a:r>
-              <a:rPr dirty="0" err="1"/>
+              <a:rPr sz="1600" dirty="0" err="1"/>
               <a:t>憑證與法定代理人授權鏈</a:t>
             </a:r>
             <a:r>
-              <a:rPr dirty="0"/>
+              <a:rPr sz="1600" dirty="0"/>
               <a:t> (Mandates)</a:t>
             </a:r>
-            <a:endParaRPr lang="en-US" dirty="0"/>
+            <a:endParaRPr lang="en-US" sz="1600" dirty="0"/>
           </a:p>
           <a:p>
             <a:pPr algn="ctr">
@@ -10883,17 +11477,17 @@
               </a:defRPr>
             </a:pPr>
             <a:br>
-              <a:rPr dirty="0"/>
+              <a:rPr sz="1600" dirty="0"/>
             </a:br>
             <a:r>
-              <a:rPr dirty="0"/>
+              <a:rPr sz="1600" dirty="0"/>
               <a:t>• 個人端：W3C DID / </a:t>
             </a:r>
             <a:r>
-              <a:rPr dirty="0" err="1"/>
+              <a:rPr sz="1600" dirty="0" err="1"/>
               <a:t>數位身分皮夾與使用者自主宣告簽署</a:t>
             </a:r>
-            <a:endParaRPr lang="en-US" dirty="0"/>
+            <a:endParaRPr lang="en-US" sz="1600" dirty="0"/>
           </a:p>
           <a:p>
             <a:pPr algn="ctr">
@@ -10904,33 +11498,33 @@
               </a:defRPr>
             </a:pPr>
             <a:br>
-              <a:rPr dirty="0"/>
+              <a:rPr sz="1600" dirty="0"/>
             </a:br>
             <a:r>
-              <a:rPr dirty="0"/>
+              <a:rPr sz="1600" dirty="0"/>
               <a:t>• </a:t>
             </a:r>
             <a:r>
-              <a:rPr dirty="0" err="1"/>
+              <a:rPr sz="1600" dirty="0" err="1"/>
               <a:t>國家端：數位發展部</a:t>
             </a:r>
             <a:r>
-              <a:rPr dirty="0"/>
+              <a:rPr sz="1600" dirty="0"/>
               <a:t> </a:t>
             </a:r>
             <a:r>
-              <a:rPr dirty="0" err="1"/>
+              <a:rPr sz="1600" dirty="0" err="1"/>
               <a:t>MyData</a:t>
             </a:r>
             <a:r>
-              <a:rPr dirty="0"/>
+              <a:rPr sz="1600" dirty="0"/>
               <a:t> / FIDO </a:t>
             </a:r>
             <a:r>
-              <a:rPr dirty="0" err="1"/>
+              <a:rPr sz="1600" dirty="0" err="1"/>
               <a:t>雙軌整合與法庭可採信證據邊界</a:t>
             </a:r>
-            <a:endParaRPr lang="en-US" dirty="0"/>
+            <a:endParaRPr lang="en-US" sz="1600" dirty="0"/>
           </a:p>
           <a:p>
             <a:pPr algn="ctr">
@@ -10952,8 +11546,8 @@
         </p:nvSpPr>
         <p:spPr>
           <a:xfrm>
-            <a:off x="731520" y="3463632"/>
-            <a:ext cx="5212080" cy="2965796"/>
+            <a:off x="731520" y="3370322"/>
+            <a:ext cx="5212080" cy="2470637"/>
           </a:xfrm>
           <a:prstGeom prst="roundRect">
             <a:avLst/>
@@ -11033,22 +11627,22 @@
               </a:defRPr>
             </a:pPr>
             <a:r>
-              <a:rPr dirty="0"/>
+              <a:rPr sz="1600" dirty="0"/>
               <a:t>• 18項 PHI </a:t>
             </a:r>
             <a:r>
-              <a:rPr dirty="0" err="1"/>
+              <a:rPr sz="1600" dirty="0" err="1"/>
               <a:t>敏感個資動態</a:t>
             </a:r>
             <a:r>
-              <a:rPr dirty="0"/>
+              <a:rPr sz="1600" dirty="0"/>
               <a:t> Redact </a:t>
             </a:r>
             <a:r>
-              <a:rPr dirty="0" err="1"/>
+              <a:rPr sz="1600" dirty="0" err="1"/>
               <a:t>遮蔽</a:t>
             </a:r>
-            <a:endParaRPr lang="en-US" dirty="0"/>
+            <a:endParaRPr lang="en-US" sz="1600" dirty="0"/>
           </a:p>
           <a:p>
             <a:pPr algn="ctr">
@@ -11059,17 +11653,17 @@
               </a:defRPr>
             </a:pPr>
             <a:br>
-              <a:rPr dirty="0"/>
+              <a:rPr sz="1600" dirty="0"/>
             </a:br>
             <a:r>
-              <a:rPr dirty="0"/>
+              <a:rPr sz="1600" dirty="0"/>
               <a:t>• </a:t>
             </a:r>
             <a:r>
-              <a:rPr dirty="0" err="1"/>
+              <a:rPr sz="1600" dirty="0" err="1"/>
               <a:t>精準對接壽險公會理賠聯盟鏈</a:t>
             </a:r>
-            <a:endParaRPr lang="en-US" dirty="0"/>
+            <a:endParaRPr lang="en-US" sz="1600" dirty="0"/>
           </a:p>
           <a:p>
             <a:pPr algn="ctr">
@@ -11080,33 +11674,33 @@
               </a:defRPr>
             </a:pPr>
             <a:br>
-              <a:rPr dirty="0"/>
+              <a:rPr sz="1600" dirty="0"/>
             </a:br>
             <a:r>
-              <a:rPr dirty="0"/>
+              <a:rPr sz="1600" dirty="0"/>
               <a:t>• </a:t>
             </a:r>
             <a:r>
-              <a:rPr dirty="0" err="1"/>
+              <a:rPr sz="1600" dirty="0" err="1"/>
               <a:t>越權調閱病歷</a:t>
             </a:r>
             <a:r>
-              <a:rPr dirty="0"/>
+              <a:rPr sz="1600" dirty="0"/>
               <a:t> ➔ 26.1 </a:t>
             </a:r>
             <a:r>
-              <a:rPr dirty="0" err="1"/>
+              <a:rPr sz="1600" dirty="0" err="1"/>
               <a:t>μs</a:t>
             </a:r>
             <a:r>
-              <a:rPr dirty="0"/>
+              <a:rPr sz="1600" dirty="0"/>
               <a:t> </a:t>
             </a:r>
             <a:r>
-              <a:rPr dirty="0" err="1"/>
+              <a:rPr sz="1600" dirty="0" err="1"/>
               <a:t>帶內硬熔斷</a:t>
             </a:r>
-            <a:endParaRPr lang="en-US" dirty="0"/>
+            <a:endParaRPr lang="en-US" sz="1600" dirty="0"/>
           </a:p>
           <a:p>
             <a:pPr algn="ctr">
@@ -11117,25 +11711,25 @@
               </a:defRPr>
             </a:pPr>
             <a:br>
-              <a:rPr dirty="0"/>
+              <a:rPr sz="1600" dirty="0"/>
             </a:br>
             <a:r>
-              <a:rPr dirty="0"/>
+              <a:rPr sz="1600" dirty="0"/>
               <a:t>• SHA-256 Merkle </a:t>
             </a:r>
             <a:r>
-              <a:rPr dirty="0" err="1"/>
+              <a:rPr sz="1600" dirty="0" err="1"/>
               <a:t>收據</a:t>
             </a:r>
             <a:r>
-              <a:rPr dirty="0"/>
+              <a:rPr sz="1600" dirty="0"/>
               <a:t> + O(1) </a:t>
             </a:r>
             <a:r>
-              <a:rPr dirty="0" err="1"/>
+              <a:rPr sz="1600" dirty="0" err="1"/>
               <a:t>立即撤銷</a:t>
             </a:r>
-            <a:endParaRPr dirty="0"/>
+            <a:endParaRPr sz="1600" dirty="0"/>
           </a:p>
         </p:txBody>
       </p:sp>
@@ -11147,8 +11741,8 @@
         </p:nvSpPr>
         <p:spPr>
           <a:xfrm>
-            <a:off x="6248095" y="3463631"/>
-            <a:ext cx="5212080" cy="2965796"/>
+            <a:off x="6248095" y="3370321"/>
+            <a:ext cx="5212080" cy="2470638"/>
           </a:xfrm>
           <a:prstGeom prst="roundRect">
             <a:avLst/>
@@ -11228,46 +11822,46 @@
               </a:defRPr>
             </a:pPr>
             <a:r>
-              <a:rPr dirty="0"/>
+              <a:rPr sz="1600" dirty="0"/>
               <a:t>• </a:t>
             </a:r>
             <a:r>
-              <a:rPr dirty="0" err="1"/>
+              <a:rPr sz="1600" dirty="0" err="1"/>
               <a:t>自然人</a:t>
             </a:r>
             <a:r>
-              <a:rPr dirty="0"/>
+              <a:rPr sz="1600" dirty="0"/>
               <a:t> </a:t>
             </a:r>
             <a:r>
-              <a:rPr dirty="0" err="1"/>
+              <a:rPr sz="1600" dirty="0" err="1"/>
               <a:t>MyData</a:t>
             </a:r>
             <a:r>
-              <a:rPr dirty="0"/>
+              <a:rPr sz="1600" dirty="0"/>
               <a:t> + </a:t>
             </a:r>
             <a:r>
-              <a:rPr dirty="0" err="1"/>
+              <a:rPr sz="1600" dirty="0" err="1"/>
               <a:t>事務所</a:t>
             </a:r>
             <a:r>
-              <a:rPr dirty="0"/>
+              <a:rPr sz="1600" dirty="0"/>
               <a:t> </a:t>
             </a:r>
             <a:r>
-              <a:rPr dirty="0" err="1"/>
+              <a:rPr sz="1600" dirty="0" err="1"/>
               <a:t>vLEI</a:t>
             </a:r>
             <a:r>
-              <a:rPr dirty="0"/>
+              <a:rPr sz="1600" dirty="0"/>
               <a:t> </a:t>
             </a:r>
             <a:r>
-              <a:rPr dirty="0" err="1"/>
+              <a:rPr sz="1600" dirty="0" err="1"/>
               <a:t>雙軌授權</a:t>
             </a:r>
-            <a:endParaRPr lang="en-US" dirty="0"/>
+            <a:endParaRPr lang="en-US" sz="1600" dirty="0"/>
           </a:p>
           <a:p>
             <a:pPr algn="ctr">
@@ -11278,25 +11872,25 @@
               </a:defRPr>
             </a:pPr>
             <a:br>
-              <a:rPr dirty="0"/>
+              <a:rPr sz="1600" dirty="0"/>
             </a:br>
             <a:r>
-              <a:rPr dirty="0"/>
+              <a:rPr sz="1600" dirty="0"/>
               <a:t>• </a:t>
             </a:r>
             <a:r>
-              <a:rPr dirty="0" err="1"/>
+              <a:rPr sz="1600" dirty="0" err="1"/>
               <a:t>三層邊界：代查所得放行</a:t>
             </a:r>
             <a:r>
-              <a:rPr dirty="0"/>
+              <a:rPr sz="1600" dirty="0"/>
               <a:t> / </a:t>
             </a:r>
             <a:r>
-              <a:rPr dirty="0" err="1"/>
+              <a:rPr sz="1600" dirty="0" err="1"/>
               <a:t>稅籍隔離</a:t>
             </a:r>
-            <a:endParaRPr lang="en-US" dirty="0"/>
+            <a:endParaRPr lang="en-US" sz="1600" dirty="0"/>
           </a:p>
           <a:p>
             <a:pPr algn="ctr">
@@ -11307,29 +11901,29 @@
               </a:defRPr>
             </a:pPr>
             <a:br>
-              <a:rPr dirty="0"/>
+              <a:rPr sz="1600" dirty="0"/>
             </a:br>
             <a:r>
-              <a:rPr dirty="0"/>
+              <a:rPr sz="1600" dirty="0"/>
               <a:t>• </a:t>
             </a:r>
             <a:r>
-              <a:rPr dirty="0" err="1"/>
+              <a:rPr sz="1600" dirty="0" err="1"/>
               <a:t>越權調閱全戶日誌</a:t>
             </a:r>
             <a:r>
-              <a:rPr dirty="0"/>
+              <a:rPr sz="1600" dirty="0"/>
               <a:t> ➔ </a:t>
             </a:r>
             <a:r>
-              <a:rPr dirty="0" err="1"/>
+              <a:rPr sz="1600" dirty="0" err="1"/>
               <a:t>瞬間拋出</a:t>
             </a:r>
             <a:r>
-              <a:rPr dirty="0"/>
+              <a:rPr sz="1600" dirty="0"/>
               <a:t> HTTP 403</a:t>
             </a:r>
-            <a:endParaRPr lang="en-US" dirty="0"/>
+            <a:endParaRPr lang="en-US" sz="1600" dirty="0"/>
           </a:p>
           <a:p>
             <a:pPr algn="ctr">
@@ -11340,25 +11934,80 @@
               </a:defRPr>
             </a:pPr>
             <a:br>
-              <a:rPr dirty="0"/>
+              <a:rPr sz="1600" dirty="0"/>
             </a:br>
             <a:r>
-              <a:rPr dirty="0"/>
+              <a:rPr sz="1600" dirty="0"/>
               <a:t>• W3C </a:t>
             </a:r>
             <a:r>
-              <a:rPr dirty="0" err="1"/>
+              <a:rPr sz="1600" dirty="0" err="1"/>
               <a:t>可驗證憑證</a:t>
             </a:r>
             <a:r>
-              <a:rPr dirty="0"/>
+              <a:rPr sz="1600" dirty="0"/>
               <a:t> (VC) + </a:t>
             </a:r>
             <a:r>
-              <a:rPr dirty="0" err="1"/>
+              <a:rPr sz="1600" dirty="0" err="1"/>
               <a:t>代理一鍵廢止</a:t>
             </a:r>
-            <a:endParaRPr dirty="0"/>
+            <a:endParaRPr sz="1600" dirty="0"/>
+          </a:p>
+        </p:txBody>
+      </p:sp>
+      <p:sp>
+        <p:nvSpPr>
+          <p:cNvPr id="7" name="文字方塊 6"/>
+          <p:cNvSpPr txBox="1"/>
+          <p:nvPr/>
+        </p:nvSpPr>
+        <p:spPr>
+          <a:xfrm>
+            <a:off x="858416" y="6176865"/>
+            <a:ext cx="8621486" cy="369332"/>
+          </a:xfrm>
+          <a:prstGeom prst="rect">
+            <a:avLst/>
+          </a:prstGeom>
+          <a:noFill/>
+        </p:spPr>
+        <p:txBody>
+          <a:bodyPr wrap="square" rtlCol="0">
+            <a:spAutoFit/>
+          </a:bodyPr>
+          <a:lstStyle/>
+          <a:p>
+            <a:r>
+              <a:rPr lang="en-US" altLang="zh-TW" dirty="0">
+                <a:solidFill>
+                  <a:schemeClr val="bg1"/>
+                </a:solidFill>
+              </a:rPr>
+              <a:t>DEMO</a:t>
+            </a:r>
+            <a:r>
+              <a:rPr lang="zh-TW" altLang="en-US" dirty="0">
+                <a:solidFill>
+                  <a:schemeClr val="bg1"/>
+                </a:solidFill>
+              </a:rPr>
+              <a:t>影片  </a:t>
+            </a:r>
+            <a:r>
+              <a:rPr lang="en-US" altLang="zh-TW" dirty="0">
+                <a:solidFill>
+                  <a:schemeClr val="bg1"/>
+                </a:solidFill>
+                <a:hlinkClick r:id="rId2"/>
+              </a:rPr>
+              <a:t>https://youtu.be/zeVWf0EOSw0</a:t>
+            </a:r>
+            <a:endParaRPr lang="zh-TW" altLang="en-US" dirty="0">
+              <a:solidFill>
+                <a:schemeClr val="bg1"/>
+              </a:solidFill>
+            </a:endParaRPr>
           </a:p>
         </p:txBody>
       </p:sp>

</xml_diff>